<commit_message>
Update demo presentation wording
</commit_message>
<xml_diff>
--- a/docs/presentation/LibriSense_Demo.pptx
+++ b/docs/presentation/LibriSense_Demo.pptx
@@ -1679,7 +1679,7 @@
                 <a:ea typeface="Calibri" pitchFamily="34" charset="-122"/>
                 <a:cs typeface="Calibri" pitchFamily="34" charset="-120"/>
               </a:rPr>
-              <a:t>A library that senses, plans and acts</a:t>
+              <a:t>An adaptive smart library</a:t>
             </a:r>
             <a:endParaRPr lang="en-US" sz="1800" dirty="0"/>
           </a:p>
@@ -2023,7 +2023,7 @@
                 <a:ea typeface="Cambria" pitchFamily="34" charset="-122"/>
                 <a:cs typeface="Cambria" pitchFamily="34" charset="-120"/>
               </a:rPr>
-              <a:t>0</a:t>
+              <a:t>24/7</a:t>
             </a:r>
             <a:endParaRPr lang="en-US" sz="5200" dirty="0"/>
           </a:p>
@@ -2062,7 +2062,7 @@
                 <a:ea typeface="Calibri" pitchFamily="34" charset="-122"/>
                 <a:cs typeface="Calibri" pitchFamily="34" charset="-120"/>
               </a:rPr>
-              <a:t>people whose job it is to manage light, air and breaks</a:t>
+              <a:t>lighting and ventilation usually run on fixed schedules, not on demand</a:t>
             </a:r>
             <a:endParaRPr lang="en-US" sz="1450" dirty="0"/>
           </a:p>
@@ -2093,15 +2093,15 @@
               <a:buNone/>
             </a:pPr>
             <a:r>
-              <a:rPr lang="en-US" sz="1700" i="1" dirty="0">
-                <a:solidFill>
-                  <a:srgbClr val="D97706"/>
+              <a:rPr lang="en-US" sz="1700" dirty="0">
+                <a:solidFill>
+                  <a:srgbClr val="6B7280"/>
                 </a:solidFill>
                 <a:latin typeface="Calibri" pitchFamily="34" charset="0"/>
                 <a:ea typeface="Calibri" pitchFamily="34" charset="-122"/>
                 <a:cs typeface="Calibri" pitchFamily="34" charset="-120"/>
               </a:rPr>
-              <a:t>LibriSense: a reading room that optimises focus, comfort and energy on its own and can justify every decision.</a:t>
+              <a:t>Our project: a reading zone that controls light, air quality and break timing automatically, with transparent decisions.</a:t>
             </a:r>
             <a:endParaRPr lang="en-US" sz="1700" dirty="0"/>
           </a:p>
@@ -2211,7 +2211,7 @@
                 <a:ea typeface="Cambria" pitchFamily="34" charset="-122"/>
                 <a:cs typeface="Cambria" pitchFamily="34" charset="-120"/>
               </a:rPr>
-              <a:t>What it senses, what it moves, what it does</a:t>
+              <a:t>Sensors, actuators and functionality</a:t>
             </a:r>
             <a:endParaRPr lang="en-US" sz="3000" dirty="0"/>
           </a:p>
@@ -3625,7 +3625,7 @@
                 <a:ea typeface="Calibri" pitchFamily="34" charset="-122"/>
                 <a:cs typeface="Calibri" pitchFamily="34" charset="-120"/>
               </a:rPr>
-              <a:t>Coach breaks: LED + buzzer after 2 min of focus</a:t>
+              <a:t>Suggest breaks via LED + buzzer after 2 min of focus</a:t>
             </a:r>
             <a:endParaRPr lang="en-US" sz="1250" dirty="0"/>
           </a:p>
@@ -3749,7 +3749,7 @@
                 <a:ea typeface="Calibri" pitchFamily="34" charset="-122"/>
                 <a:cs typeface="Calibri" pitchFamily="34" charset="-120"/>
               </a:rPr>
-              <a:t>Re-plan on every state change; self-heal in &lt; 1 s</a:t>
+              <a:t>Re-plan on every state change; recover in &lt; 1 s</a:t>
             </a:r>
             <a:endParaRPr lang="en-US" sz="1250" dirty="0"/>
           </a:p>
@@ -3898,7 +3898,7 @@
                 <a:ea typeface="Cambria" pitchFamily="34" charset="-122"/>
                 <a:cs typeface="Cambria" pitchFamily="34" charset="-120"/>
               </a:rPr>
-              <a:t>Eight modules, one rule: talk only via MQTT</a:t>
+              <a:t>Eight modules, communicating only via MQTT</a:t>
             </a:r>
             <a:endParaRPr lang="en-US" sz="3000" dirty="0"/>
           </a:p>
@@ -5512,7 +5512,7 @@
                 <a:ea typeface="Cambria" pitchFamily="34" charset="-122"/>
                 <a:cs typeface="Cambria" pitchFamily="34" charset="-120"/>
               </a:rPr>
-              <a:t>Discretisation bridges the analog world</a:t>
+              <a:t>Discretisation thresholds</a:t>
             </a:r>
             <a:endParaRPr lang="en-US" sz="1450" dirty="0"/>
           </a:p>
@@ -5660,15 +5660,15 @@
               <a:buNone/>
             </a:pPr>
             <a:r>
-              <a:rPr lang="en-US" sz="1200" i="1" dirty="0">
-                <a:solidFill>
-                  <a:srgbClr val="D97706"/>
+              <a:rPr lang="en-US" sz="1200" dirty="0">
+                <a:solidFill>
+                  <a:srgbClr val="6B7280"/>
                 </a:solidFill>
                 <a:latin typeface="Calibri" pitchFamily="34" charset="0"/>
                 <a:ea typeface="Calibri" pitchFamily="34" charset="-122"/>
                 <a:cs typeface="Calibri" pitchFamily="34" charset="-120"/>
               </a:rPr>
-              <a:t>Continuous quantities stay out of the planner by design: cleanly classical, hence provably optimal plans.</a:t>
+              <a:t>Continuous values are discretised before planning, so the domain stays classical and plans remain provably optimal.</a:t>
             </a:r>
             <a:endParaRPr lang="en-US" sz="1200" dirty="0"/>
           </a:p>
@@ -6708,15 +6708,15 @@
               <a:buNone/>
             </a:pPr>
             <a:r>
-              <a:rPr lang="en-US" sz="1350" i="1" dirty="0">
-                <a:solidFill>
-                  <a:srgbClr val="D97706"/>
+              <a:rPr lang="en-US" sz="1350" dirty="0">
+                <a:solidFill>
+                  <a:srgbClr val="6B7280"/>
                 </a:solidFill>
                 <a:latin typeface="Calibri" pitchFamily="34" charset="0"/>
                 <a:ea typeface="Calibri" pitchFamily="34" charset="-122"/>
                 <a:cs typeface="Calibri" pitchFamily="34" charset="-120"/>
               </a:rPr>
-              <a:t>LM-Cut is admissible, so A* returns provably minimal-cost plans. Nobody programmed the winter rule; it falls out of the cost model.</a:t>
+              <a:t>LM-Cut is admissible, so A* returns minimal-cost plans. The winter strategy is not hard-coded; it results from the weather-dependent action costs.</a:t>
             </a:r>
             <a:endParaRPr lang="en-US" sz="1350" dirty="0"/>
           </a:p>
@@ -6826,7 +6826,7 @@
                 <a:ea typeface="Cambria" pitchFamily="34" charset="-122"/>
                 <a:cs typeface="Cambria" pitchFamily="34" charset="-120"/>
               </a:rPr>
-              <a:t>The demo: six moments</a:t>
+              <a:t>Live demo procedure</a:t>
             </a:r>
             <a:endParaRPr lang="en-US" sz="3000" dirty="0"/>
           </a:p>
@@ -7184,7 +7184,7 @@
                 <a:ea typeface="Cambria" pitchFamily="34" charset="-122"/>
                 <a:cs typeface="Cambria" pitchFamily="34" charset="-120"/>
               </a:rPr>
-              <a:t>Sabotage the lamp</a:t>
+              <a:t>Switch the lamp off manually</a:t>
             </a:r>
             <a:endParaRPr lang="en-US" sz="1600" dirty="0"/>
           </a:p>
@@ -7223,7 +7223,7 @@
                 <a:ea typeface="Calibri" pitchFamily="34" charset="-122"/>
                 <a:cs typeface="Calibri" pitchFamily="34" charset="-120"/>
               </a:rPr>
-              <a:t>switched off by hand: re-planned and re-lit in under 1 s</a:t>
+              <a:t>the disturbance is detected and corrected in under 1 s</a:t>
             </a:r>
             <a:endParaRPr lang="en-US" sz="1250" dirty="0"/>
           </a:p>
@@ -7464,7 +7464,7 @@
                 <a:ea typeface="Cambria" pitchFamily="34" charset="-122"/>
                 <a:cs typeface="Cambria" pitchFamily="34" charset="-120"/>
               </a:rPr>
-              <a:t>Air gets stale</a:t>
+              <a:t>CO₂ rises</a:t>
             </a:r>
             <a:endParaRPr lang="en-US" sz="1600" dirty="0"/>
           </a:p>
@@ -7503,7 +7503,7 @@
                 <a:ea typeface="Calibri" pitchFamily="34" charset="-122"/>
                 <a:cs typeface="Calibri" pitchFamily="34" charset="-120"/>
               </a:rPr>
-              <a:t>CO₂ climbs, windows open on the floor plan, CO₂ falls</a:t>
+              <a:t>the planner opens the windows on the floor plan, CO₂ falls again</a:t>
             </a:r>
             <a:endParaRPr lang="en-US" sz="1250" dirty="0"/>
           </a:p>
@@ -7815,7 +7815,7 @@
                 <a:ea typeface="Cambria" pitchFamily="34" charset="-122"/>
                 <a:cs typeface="Cambria" pitchFamily="34" charset="-120"/>
               </a:rPr>
-              <a:t>All six, measured on the real system</a:t>
+              <a:t>All six requirements are met</a:t>
             </a:r>
             <a:endParaRPr lang="en-US" sz="3000" dirty="0"/>
           </a:p>
@@ -8765,7 +8765,7 @@
                 <a:ea typeface="Calibri" pitchFamily="34" charset="-122"/>
                 <a:cs typeface="Calibri" pitchFamily="34" charset="-120"/>
               </a:rPr>
-              <a:t>WHAT WE LEARNED</a:t>
+              <a:t>LESSONS LEARNED</a:t>
             </a:r>
             <a:endParaRPr lang="en-US" sz="1100" dirty="0"/>
           </a:p>
@@ -8804,7 +8804,7 @@
                 <a:ea typeface="Cambria" pitchFamily="34" charset="-122"/>
                 <a:cs typeface="Cambria" pitchFamily="34" charset="-120"/>
               </a:rPr>
-              <a:t>Honesty beats fake data</a:t>
+              <a:t>Sound sensor removed</a:t>
             </a:r>
             <a:endParaRPr lang="en-US" sz="1700" dirty="0"/>
           </a:p>
@@ -8843,7 +8843,7 @@
                 <a:ea typeface="Calibri" pitchFamily="34" charset="-122"/>
                 <a:cs typeface="Calibri" pitchFamily="34" charset="-120"/>
               </a:rPr>
-              <a:t>the sound sensor could not measure loudness over the slow GrovePi bus, so we removed it instead of showing noise.</a:t>
+              <a:t>it could not measure loudness over the slow GrovePi bus, so we removed it instead of publishing noise as data.</a:t>
             </a:r>
             <a:endParaRPr lang="en-US" sz="1250" dirty="0"/>
           </a:p>
@@ -8882,7 +8882,7 @@
                 <a:ea typeface="Cambria" pitchFamily="34" charset="-122"/>
                 <a:cs typeface="Cambria" pitchFamily="34" charset="-120"/>
               </a:rPr>
-              <a:t>Guard the planner</a:t>
+              <a:t>Unsolvable goals prevented</a:t>
             </a:r>
             <a:endParaRPr lang="en-US" sz="1700" dirty="0"/>
           </a:p>
@@ -8921,7 +8921,7 @@
                 <a:ea typeface="Calibri" pitchFamily="34" charset="-122"/>
                 <a:cs typeface="Calibri" pitchFamily="34" charset="-120"/>
               </a:rPr>
-              <a:t>an early bug asked it to brighten a zone whose lamp was already on. The generator now emits only achievable goals.</a:t>
+              <a:t>an early bug asked the planner to brighten a zone whose lamp was already on. The generator now emits only achievable goals.</a:t>
             </a:r>
             <a:endParaRPr lang="en-US" sz="1250" dirty="0"/>
           </a:p>
@@ -8960,7 +8960,7 @@
                 <a:ea typeface="Cambria" pitchFamily="34" charset="-122"/>
                 <a:cs typeface="Cambria" pitchFamily="34" charset="-120"/>
               </a:rPr>
-              <a:t>Simulate transparently</a:t>
+              <a:t>CO₂ and windows are simulated</a:t>
             </a:r>
             <a:endParaRPr lang="en-US" sz="1700" dirty="0"/>
           </a:p>
@@ -8999,7 +8999,7 @@
                 <a:ea typeface="Calibri" pitchFamily="34" charset="-122"/>
                 <a:cs typeface="Calibri" pitchFamily="34" charset="-120"/>
               </a:rPr>
-              <a:t>CO₂ and windows are modelled, clearly labelled, and react realistically to planner actions.</a:t>
+              <a:t>both are modelled, clearly labelled, and react realistically to planner actions.</a:t>
             </a:r>
             <a:endParaRPr lang="en-US" sz="1250" dirty="0"/>
           </a:p>
@@ -9038,7 +9038,7 @@
                 <a:ea typeface="Cambria" pitchFamily="34" charset="-122"/>
                 <a:cs typeface="Cambria" pitchFamily="34" charset="-120"/>
               </a:rPr>
-              <a:t>WiFi is the real enemy</a:t>
+              <a:t>WiFi reliability</a:t>
             </a:r>
             <a:endParaRPr lang="en-US" sz="1700" dirty="0"/>
           </a:p>
@@ -9077,7 +9077,7 @@
                 <a:ea typeface="Calibri" pitchFamily="34" charset="-122"/>
                 <a:cs typeface="Calibri" pitchFamily="34" charset="-120"/>
               </a:rPr>
-              <a:t>client isolation, band steering, power-save. Demo mode now spans its own access point.</a:t>
+              <a:t>client isolation, band steering and power-save caused repeated dropouts, so the demo runs on its own access point.</a:t>
             </a:r>
             <a:endParaRPr lang="en-US" sz="1250" dirty="0"/>
           </a:p>

</xml_diff>

<commit_message>
Add logo and narrative problem slide
</commit_message>
<xml_diff>
--- a/docs/presentation/LibriSense_Demo.pptx
+++ b/docs/presentation/LibriSense_Demo.pptx
@@ -687,7 +687,7 @@
           <a:p>
             <a:r>
               <a:rPr lang="en-US" dirty="0"/>
-              <a:t>The one explaining slide: on the desk sit two Raspberry Pis. The edge Pi senses and acts, the core Pi thinks: every sensor reading flows over MQTT into the context, becomes a PDDL problem with weather-based costs, Fast Downward returns the cost-optimal plan, the executor sends the actions back to the edge. The laptop is only a window into the system; in the demo it joins the WiFi that the core Pi itself provides.</a:t>
+              <a:t>Narrative opener (idea by Niclas). Tell it slowly, first person. The card numbers are an illustrative scenario; the Harvard COGfx study (2015) documented cognitive decline above roughly 1,000 ppm CO2. Close with the question, then answer it on the next slide: this is exactly what LibriSense does.</a:t>
             </a:r>
             <a:endParaRPr lang="en-US" dirty="0"/>
           </a:p>
@@ -775,7 +775,7 @@
           <a:p>
             <a:r>
               <a:rPr lang="en-US" dirty="0"/>
-              <a:t>Opening story: this summer is brutal, libraries are packed. Light, air and breaks are constant trade-offs that nobody actively manages. That is a planning problem, so we gave the room a planner.</a:t>
+              <a:t>The one explaining slide: on the desk sit two Raspberry Pis. The edge Pi senses and acts, the core Pi thinks: every sensor reading flows over MQTT into the context, becomes a PDDL problem with weather-based costs, Fast Downward returns the cost-optimal plan, the executor sends the actions back to the edge. The laptop is only a window into the system; in the demo it joins the WiFi that the core Pi itself provides.</a:t>
             </a:r>
             <a:endParaRPr lang="en-US" dirty="0"/>
           </a:p>
@@ -1676,35 +1676,39 @@
           <a:chExt cx="0" cy="0"/>
         </a:xfrm>
       </p:grpSpPr>
-      <p:sp>
-        <p:nvSpPr>
-          <p:cNvPr id="2" name="Shape 0"/>
-          <p:cNvSpPr/>
-          <p:nvPr/>
-        </p:nvSpPr>
-        <p:spPr>
-          <a:xfrm>
-            <a:off x="5870448" y="1847088"/>
-            <a:ext cx="457200" cy="457200"/>
-          </a:xfrm>
-          <a:prstGeom prst="ellipse">
-            <a:avLst/>
-          </a:prstGeom>
-          <a:solidFill>
-            <a:srgbClr val="D97706"/>
-          </a:solidFill>
-          <a:ln/>
-        </p:spPr>
-      </p:sp>
-      <p:sp>
-        <p:nvSpPr>
-          <p:cNvPr id="3" name="Text 1"/>
-          <p:cNvSpPr/>
-          <p:nvPr/>
-        </p:nvSpPr>
-        <p:spPr>
-          <a:xfrm>
-            <a:off x="0" y="2377440"/>
+      <p:pic>
+        <p:nvPicPr>
+          <p:cNvPr id="2" name="Image 0" descr="/Users/dennisgunt/Library/CloudStorage/OneDrive-Persönlich/Master_Studium/03_Semester/SmartCities/librisense/docs/logo/librisense_logo_dark.png">    </p:cNvPr>
+          <p:cNvPicPr>
+            <a:picLocks noChangeAspect="1"/>
+          </p:cNvPicPr>
+          <p:nvPr/>
+        </p:nvPicPr>
+        <p:blipFill>
+          <a:blip r:embed="rId1"/>
+          <a:stretch>
+            <a:fillRect/>
+          </a:stretch>
+        </p:blipFill>
+        <p:spPr>
+          <a:xfrm>
+            <a:off x="5294376" y="868680"/>
+            <a:ext cx="1600200" cy="1600200"/>
+          </a:xfrm>
+          <a:prstGeom prst="rect">
+            <a:avLst/>
+          </a:prstGeom>
+        </p:spPr>
+      </p:pic>
+      <p:sp>
+        <p:nvSpPr>
+          <p:cNvPr id="3" name="Text 0"/>
+          <p:cNvSpPr/>
+          <p:nvPr/>
+        </p:nvSpPr>
+        <p:spPr>
+          <a:xfrm>
+            <a:off x="0" y="2560320"/>
             <a:ext cx="12188952" cy="1005840"/>
           </a:xfrm>
           <a:prstGeom prst="rect">
@@ -1737,13 +1741,13 @@
       </p:sp>
       <p:sp>
         <p:nvSpPr>
-          <p:cNvPr id="4" name="Text 2"/>
-          <p:cNvSpPr/>
-          <p:nvPr/>
-        </p:nvSpPr>
-        <p:spPr>
-          <a:xfrm>
-            <a:off x="0" y="3429000"/>
+          <p:cNvPr id="4" name="Text 1"/>
+          <p:cNvSpPr/>
+          <p:nvPr/>
+        </p:nvSpPr>
+        <p:spPr>
+          <a:xfrm>
+            <a:off x="0" y="3584448"/>
             <a:ext cx="12188952" cy="457200"/>
           </a:xfrm>
           <a:prstGeom prst="rect">
@@ -1776,7 +1780,7 @@
       </p:sp>
       <p:sp>
         <p:nvSpPr>
-          <p:cNvPr id="5" name="Text 3"/>
+          <p:cNvPr id="5" name="Text 2"/>
           <p:cNvSpPr/>
           <p:nvPr/>
         </p:nvSpPr>
@@ -2311,7 +2315,7 @@
     <p:bg>
       <p:bgPr>
         <a:solidFill>
-          <a:srgbClr val="FFFFFF"/>
+          <a:srgbClr val="0F1B2D"/>
         </a:solidFill>
       </p:bgPr>
     </p:bg>
@@ -2337,8 +2341,8 @@
         </p:nvSpPr>
         <p:spPr>
           <a:xfrm>
-            <a:off x="658368" y="219456"/>
-            <a:ext cx="10881360" cy="274320"/>
+            <a:off x="822960" y="502920"/>
+            <a:ext cx="5486400" cy="274320"/>
           </a:xfrm>
           <a:prstGeom prst="rect">
             <a:avLst/>
@@ -2362,7 +2366,7 @@
                 <a:ea typeface="Calibri" pitchFamily="34" charset="-122"/>
                 <a:cs typeface="Calibri" pitchFamily="34" charset="-120"/>
               </a:rPr>
-              <a:t>HOW IT WORKS</a:t>
+              <a:t>THE PROBLEM</a:t>
             </a:r>
             <a:endParaRPr lang="en-US" sz="1100" dirty="0"/>
           </a:p>
@@ -2376,34 +2380,77 @@
         </p:nvSpPr>
         <p:spPr>
           <a:xfrm>
-            <a:off x="640080" y="457200"/>
-            <a:ext cx="10881360" cy="640080"/>
-          </a:xfrm>
-          <a:prstGeom prst="rect">
-            <a:avLst/>
-          </a:prstGeom>
-          <a:noFill/>
-          <a:ln/>
-        </p:spPr>
-        <p:txBody>
-          <a:bodyPr wrap="square" lIns="0" tIns="0" rIns="0" bIns="0" rtlCol="0" anchor="ctr"/>
-          <a:lstStyle/>
-          <a:p>
-            <a:pPr indent="0" marL="0">
-              <a:buNone/>
-            </a:pPr>
-            <a:r>
-              <a:rPr lang="en-US" sz="3000" b="1" dirty="0">
-                <a:solidFill>
-                  <a:srgbClr val="111827"/>
+            <a:off x="822960" y="1097280"/>
+            <a:ext cx="5852160" cy="1600200"/>
+          </a:xfrm>
+          <a:prstGeom prst="rect">
+            <a:avLst/>
+          </a:prstGeom>
+          <a:noFill/>
+          <a:ln/>
+        </p:spPr>
+        <p:txBody>
+          <a:bodyPr wrap="square" lIns="0" tIns="0" rIns="0" bIns="0" rtlCol="0" anchor="ctr"/>
+          <a:lstStyle/>
+          <a:p>
+            <a:pPr indent="0" marL="0">
+              <a:lnSpc>
+                <a:spcPct val="115000"/>
+              </a:lnSpc>
+              <a:buNone/>
+            </a:pPr>
+            <a:r>
+              <a:rPr lang="en-US" sz="2500" b="1" dirty="0">
+                <a:solidFill>
+                  <a:srgbClr val="FFFFFF"/>
                 </a:solidFill>
                 <a:latin typeface="Cambria" pitchFamily="34" charset="0"/>
                 <a:ea typeface="Cambria" pitchFamily="34" charset="-122"/>
                 <a:cs typeface="Cambria" pitchFamily="34" charset="-120"/>
               </a:rPr>
-              <a:t>Setup: two Raspberry Pis and a browser dashboard</a:t>
-            </a:r>
-            <a:endParaRPr lang="en-US" sz="3000" dirty="0"/>
+              <a:t>It's a hot Monday morning.</a:t>
+            </a:r>
+            <a:endParaRPr lang="en-US" sz="2500" dirty="0"/>
+          </a:p>
+          <a:p>
+            <a:pPr indent="0" marL="0">
+              <a:lnSpc>
+                <a:spcPct val="115000"/>
+              </a:lnSpc>
+              <a:buNone/>
+            </a:pPr>
+            <a:r>
+              <a:rPr lang="en-US" sz="2500" b="1" dirty="0">
+                <a:solidFill>
+                  <a:srgbClr val="FFFFFF"/>
+                </a:solidFill>
+                <a:latin typeface="Cambria" pitchFamily="34" charset="0"/>
+                <a:ea typeface="Cambria" pitchFamily="34" charset="-122"/>
+                <a:cs typeface="Cambria" pitchFamily="34" charset="-120"/>
+              </a:rPr>
+              <a:t>You find a seat in the library,</a:t>
+            </a:r>
+            <a:endParaRPr lang="en-US" sz="2500" dirty="0"/>
+          </a:p>
+          <a:p>
+            <a:pPr indent="0" marL="0">
+              <a:lnSpc>
+                <a:spcPct val="115000"/>
+              </a:lnSpc>
+              <a:buNone/>
+            </a:pPr>
+            <a:r>
+              <a:rPr lang="en-US" sz="2500" b="1" dirty="0">
+                <a:solidFill>
+                  <a:srgbClr val="FFFFFF"/>
+                </a:solidFill>
+                <a:latin typeface="Cambria" pitchFamily="34" charset="0"/>
+                <a:ea typeface="Cambria" pitchFamily="34" charset="-122"/>
+                <a:cs typeface="Cambria" pitchFamily="34" charset="-120"/>
+              </a:rPr>
+              <a:t>close the door.</a:t>
+            </a:r>
+            <a:endParaRPr lang="en-US" sz="2500" dirty="0"/>
           </a:p>
         </p:txBody>
       </p:sp>
@@ -2415,20 +2462,16 @@
         </p:nvSpPr>
         <p:spPr>
           <a:xfrm>
-            <a:off x="640080" y="1325880"/>
-            <a:ext cx="3383280" cy="4343400"/>
-          </a:xfrm>
-          <a:prstGeom prst="roundRect">
-            <a:avLst>
-              <a:gd name="adj" fmla="val 2703"/>
-            </a:avLst>
-          </a:prstGeom>
-          <a:solidFill>
-            <a:srgbClr val="FFFFFF"/>
-          </a:solidFill>
-          <a:ln w="15875">
+            <a:off x="822960" y="2926080"/>
+            <a:ext cx="2377440" cy="0"/>
+          </a:xfrm>
+          <a:prstGeom prst="line">
+            <a:avLst/>
+          </a:prstGeom>
+          <a:noFill/>
+          <a:ln w="12700">
             <a:solidFill>
-              <a:srgbClr val="E5E7EB"/>
+              <a:srgbClr val="3A4A63"/>
             </a:solidFill>
             <a:prstDash val="solid"/>
           </a:ln>
@@ -2442,278 +2485,262 @@
         </p:nvSpPr>
         <p:spPr>
           <a:xfrm>
-            <a:off x="868680" y="1481328"/>
-            <a:ext cx="2926080" cy="320040"/>
-          </a:xfrm>
-          <a:prstGeom prst="rect">
-            <a:avLst/>
-          </a:prstGeom>
-          <a:noFill/>
-          <a:ln/>
-        </p:spPr>
-        <p:txBody>
-          <a:bodyPr wrap="square" lIns="0" tIns="0" rIns="0" bIns="0" rtlCol="0" anchor="ctr"/>
-          <a:lstStyle/>
-          <a:p>
-            <a:pPr indent="0" marL="0">
-              <a:buNone/>
-            </a:pPr>
-            <a:r>
-              <a:rPr lang="en-US" sz="1500" b="1" dirty="0">
-                <a:solidFill>
-                  <a:srgbClr val="111827"/>
+            <a:off x="822960" y="3154680"/>
+            <a:ext cx="5852160" cy="1234440"/>
+          </a:xfrm>
+          <a:prstGeom prst="rect">
+            <a:avLst/>
+          </a:prstGeom>
+          <a:noFill/>
+          <a:ln/>
+        </p:spPr>
+        <p:txBody>
+          <a:bodyPr wrap="square" lIns="0" tIns="0" rIns="0" bIns="0" rtlCol="0" anchor="ctr"/>
+          <a:lstStyle/>
+          <a:p>
+            <a:pPr indent="0" marL="0">
+              <a:lnSpc>
+                <a:spcPct val="130000"/>
+              </a:lnSpc>
+              <a:buNone/>
+            </a:pPr>
+            <a:r>
+              <a:rPr lang="en-US" sz="1550" dirty="0">
+                <a:solidFill>
+                  <a:srgbClr val="9DB2C7"/>
+                </a:solidFill>
+                <a:latin typeface="Calibri" pitchFamily="34" charset="0"/>
+                <a:ea typeface="Calibri" pitchFamily="34" charset="-122"/>
+                <a:cs typeface="Calibri" pitchFamily="34" charset="-120"/>
+              </a:rPr>
+              <a:t>Two hours in, the air is heavy.</a:t>
+            </a:r>
+            <a:endParaRPr lang="en-US" sz="1550" dirty="0"/>
+          </a:p>
+          <a:p>
+            <a:pPr indent="0" marL="0">
+              <a:lnSpc>
+                <a:spcPct val="130000"/>
+              </a:lnSpc>
+              <a:buNone/>
+            </a:pPr>
+            <a:r>
+              <a:rPr lang="en-US" sz="1550" dirty="0">
+                <a:solidFill>
+                  <a:srgbClr val="9DB2C7"/>
+                </a:solidFill>
+                <a:latin typeface="Calibri" pitchFamily="34" charset="0"/>
+                <a:ea typeface="Calibri" pitchFamily="34" charset="-122"/>
+                <a:cs typeface="Calibri" pitchFamily="34" charset="-120"/>
+              </a:rPr>
+              <a:t>You can't open the window.</a:t>
+            </a:r>
+            <a:endParaRPr lang="en-US" sz="1550" dirty="0"/>
+          </a:p>
+          <a:p>
+            <a:pPr indent="0" marL="0">
+              <a:lnSpc>
+                <a:spcPct val="130000"/>
+              </a:lnSpc>
+              <a:buNone/>
+            </a:pPr>
+            <a:r>
+              <a:rPr lang="en-US" sz="1550" dirty="0">
+                <a:solidFill>
+                  <a:srgbClr val="9DB2C7"/>
+                </a:solidFill>
+                <a:latin typeface="Calibri" pitchFamily="34" charset="0"/>
+                <a:ea typeface="Calibri" pitchFamily="34" charset="-122"/>
+                <a:cs typeface="Calibri" pitchFamily="34" charset="-120"/>
+              </a:rPr>
+              <a:t>It's hotter outside than in.</a:t>
+            </a:r>
+            <a:endParaRPr lang="en-US" sz="1550" dirty="0"/>
+          </a:p>
+        </p:txBody>
+      </p:sp>
+      <p:sp>
+        <p:nvSpPr>
+          <p:cNvPr id="6" name="Text 4"/>
+          <p:cNvSpPr/>
+          <p:nvPr/>
+        </p:nvSpPr>
+        <p:spPr>
+          <a:xfrm>
+            <a:off x="822960" y="4526280"/>
+            <a:ext cx="5852160" cy="457200"/>
+          </a:xfrm>
+          <a:prstGeom prst="rect">
+            <a:avLst/>
+          </a:prstGeom>
+          <a:noFill/>
+          <a:ln/>
+        </p:spPr>
+        <p:txBody>
+          <a:bodyPr wrap="square" lIns="0" tIns="0" rIns="0" bIns="0" rtlCol="0" anchor="ctr"/>
+          <a:lstStyle/>
+          <a:p>
+            <a:pPr indent="0" marL="0">
+              <a:buNone/>
+            </a:pPr>
+            <a:r>
+              <a:rPr lang="en-US" sz="1550" dirty="0">
+                <a:solidFill>
+                  <a:srgbClr val="9DB2C7"/>
+                </a:solidFill>
+                <a:latin typeface="Calibri" pitchFamily="34" charset="0"/>
+                <a:ea typeface="Calibri" pitchFamily="34" charset="-122"/>
+                <a:cs typeface="Calibri" pitchFamily="34" charset="-120"/>
+              </a:rPr>
+              <a:t>By hour three, you're rereading the same paragraph.</a:t>
+            </a:r>
+            <a:endParaRPr lang="en-US" sz="1550" dirty="0"/>
+          </a:p>
+        </p:txBody>
+      </p:sp>
+      <p:sp>
+        <p:nvSpPr>
+          <p:cNvPr id="7" name="Text 5"/>
+          <p:cNvSpPr/>
+          <p:nvPr/>
+        </p:nvSpPr>
+        <p:spPr>
+          <a:xfrm>
+            <a:off x="822960" y="5120640"/>
+            <a:ext cx="5852160" cy="457200"/>
+          </a:xfrm>
+          <a:prstGeom prst="rect">
+            <a:avLst/>
+          </a:prstGeom>
+          <a:noFill/>
+          <a:ln/>
+        </p:spPr>
+        <p:txBody>
+          <a:bodyPr wrap="square" lIns="0" tIns="0" rIns="0" bIns="0" rtlCol="0" anchor="ctr"/>
+          <a:lstStyle/>
+          <a:p>
+            <a:pPr indent="0" marL="0">
+              <a:buNone/>
+            </a:pPr>
+            <a:r>
+              <a:rPr lang="en-US" sz="1650" b="1" dirty="0">
+                <a:solidFill>
+                  <a:srgbClr val="FFFFFF"/>
+                </a:solidFill>
+                <a:latin typeface="Calibri" pitchFamily="34" charset="0"/>
+                <a:ea typeface="Calibri" pitchFamily="34" charset="-122"/>
+                <a:cs typeface="Calibri" pitchFamily="34" charset="-120"/>
+              </a:rPr>
+              <a:t>Nobody noticed. Nobody acted.</a:t>
+            </a:r>
+            <a:endParaRPr lang="en-US" sz="1650" dirty="0"/>
+          </a:p>
+        </p:txBody>
+      </p:sp>
+      <p:sp>
+        <p:nvSpPr>
+          <p:cNvPr id="8" name="Shape 6"/>
+          <p:cNvSpPr/>
+          <p:nvPr/>
+        </p:nvSpPr>
+        <p:spPr>
+          <a:xfrm>
+            <a:off x="7223760" y="960120"/>
+            <a:ext cx="4297680" cy="1874520"/>
+          </a:xfrm>
+          <a:prstGeom prst="roundRect">
+            <a:avLst>
+              <a:gd name="adj" fmla="val 4878"/>
+            </a:avLst>
+          </a:prstGeom>
+          <a:solidFill>
+            <a:srgbClr val="2A2113"/>
+          </a:solidFill>
+          <a:ln w="12700">
+            <a:solidFill>
+              <a:srgbClr val="6B5426"/>
+            </a:solidFill>
+            <a:prstDash val="solid"/>
+          </a:ln>
+        </p:spPr>
+      </p:sp>
+      <p:sp>
+        <p:nvSpPr>
+          <p:cNvPr id="9" name="Text 7"/>
+          <p:cNvSpPr/>
+          <p:nvPr/>
+        </p:nvSpPr>
+        <p:spPr>
+          <a:xfrm>
+            <a:off x="7452360" y="1143000"/>
+            <a:ext cx="3840480" cy="256032"/>
+          </a:xfrm>
+          <a:prstGeom prst="rect">
+            <a:avLst/>
+          </a:prstGeom>
+          <a:noFill/>
+          <a:ln/>
+        </p:spPr>
+        <p:txBody>
+          <a:bodyPr wrap="square" lIns="0" tIns="0" rIns="0" bIns="0" rtlCol="0" anchor="ctr"/>
+          <a:lstStyle/>
+          <a:p>
+            <a:pPr indent="0" marL="0">
+              <a:buNone/>
+            </a:pPr>
+            <a:r>
+              <a:rPr lang="en-US" sz="1050" b="1" spc="200" kern="0" dirty="0">
+                <a:solidFill>
+                  <a:srgbClr val="E8B45A"/>
+                </a:solidFill>
+                <a:latin typeface="Calibri" pitchFamily="34" charset="0"/>
+                <a:ea typeface="Calibri" pitchFamily="34" charset="-122"/>
+                <a:cs typeface="Calibri" pitchFamily="34" charset="-120"/>
+              </a:rPr>
+              <a:t>OUTDOOR TEMPERATURE</a:t>
+            </a:r>
+            <a:endParaRPr lang="en-US" sz="1050" dirty="0"/>
+          </a:p>
+        </p:txBody>
+      </p:sp>
+      <p:sp>
+        <p:nvSpPr>
+          <p:cNvPr id="10" name="Text 8"/>
+          <p:cNvSpPr/>
+          <p:nvPr/>
+        </p:nvSpPr>
+        <p:spPr>
+          <a:xfrm>
+            <a:off x="7452360" y="1463040"/>
+            <a:ext cx="3840480" cy="777240"/>
+          </a:xfrm>
+          <a:prstGeom prst="rect">
+            <a:avLst/>
+          </a:prstGeom>
+          <a:noFill/>
+          <a:ln/>
+        </p:spPr>
+        <p:txBody>
+          <a:bodyPr wrap="square" lIns="0" tIns="0" rIns="0" bIns="0" rtlCol="0" anchor="ctr"/>
+          <a:lstStyle/>
+          <a:p>
+            <a:pPr indent="0" marL="0">
+              <a:buNone/>
+            </a:pPr>
+            <a:r>
+              <a:rPr lang="en-US" sz="4400" b="1" dirty="0">
+                <a:solidFill>
+                  <a:srgbClr val="D97706"/>
                 </a:solidFill>
                 <a:latin typeface="Cambria" pitchFamily="34" charset="0"/>
                 <a:ea typeface="Cambria" pitchFamily="34" charset="-122"/>
                 <a:cs typeface="Cambria" pitchFamily="34" charset="-120"/>
               </a:rPr>
-              <a:t>Raspberry Pi 3 B+  ·  edge</a:t>
-            </a:r>
-            <a:endParaRPr lang="en-US" sz="1500" dirty="0"/>
-          </a:p>
-        </p:txBody>
-      </p:sp>
-      <p:sp>
-        <p:nvSpPr>
-          <p:cNvPr id="6" name="Text 4"/>
-          <p:cNvSpPr/>
-          <p:nvPr/>
-        </p:nvSpPr>
-        <p:spPr>
-          <a:xfrm>
-            <a:off x="868680" y="1938528"/>
-            <a:ext cx="2926080" cy="228600"/>
-          </a:xfrm>
-          <a:prstGeom prst="rect">
-            <a:avLst/>
-          </a:prstGeom>
-          <a:noFill/>
-          <a:ln/>
-        </p:spPr>
-        <p:txBody>
-          <a:bodyPr wrap="square" lIns="0" tIns="0" rIns="0" bIns="0" rtlCol="0" anchor="ctr"/>
-          <a:lstStyle/>
-          <a:p>
-            <a:pPr indent="0" marL="0">
-              <a:buNone/>
-            </a:pPr>
-            <a:r>
-              <a:rPr lang="en-US" sz="950" b="1" spc="200" kern="0" dirty="0">
-                <a:solidFill>
-                  <a:srgbClr val="15803D"/>
-                </a:solidFill>
-                <a:latin typeface="Calibri" pitchFamily="34" charset="0"/>
-                <a:ea typeface="Calibri" pitchFamily="34" charset="-122"/>
-                <a:cs typeface="Calibri" pitchFamily="34" charset="-120"/>
-              </a:rPr>
-              <a:t>SENSES</a:t>
-            </a:r>
-            <a:endParaRPr lang="en-US" sz="950" dirty="0"/>
-          </a:p>
-        </p:txBody>
-      </p:sp>
-      <p:sp>
-        <p:nvSpPr>
-          <p:cNvPr id="7" name="Text 5"/>
-          <p:cNvSpPr/>
-          <p:nvPr/>
-        </p:nvSpPr>
-        <p:spPr>
-          <a:xfrm>
-            <a:off x="868680" y="2194560"/>
-            <a:ext cx="2926080" cy="594360"/>
-          </a:xfrm>
-          <a:prstGeom prst="rect">
-            <a:avLst/>
-          </a:prstGeom>
-          <a:noFill/>
-          <a:ln/>
-        </p:spPr>
-        <p:txBody>
-          <a:bodyPr wrap="square" lIns="0" tIns="0" rIns="0" bIns="0" rtlCol="0" anchor="ctr"/>
-          <a:lstStyle/>
-          <a:p>
-            <a:pPr indent="0" marL="0">
-              <a:lnSpc>
-                <a:spcPct val="125000"/>
-              </a:lnSpc>
-              <a:buNone/>
-            </a:pPr>
-            <a:r>
-              <a:rPr lang="en-US" sz="1250" dirty="0">
-                <a:solidFill>
-                  <a:srgbClr val="111827"/>
-                </a:solidFill>
-                <a:latin typeface="Calibri" pitchFamily="34" charset="0"/>
-                <a:ea typeface="Calibri" pitchFamily="34" charset="-122"/>
-                <a:cs typeface="Calibri" pitchFamily="34" charset="-120"/>
-              </a:rPr>
-              <a:t>motion sensor · 2 Hz</a:t>
-            </a:r>
-            <a:endParaRPr lang="en-US" sz="1250" dirty="0"/>
-          </a:p>
-          <a:p>
-            <a:pPr indent="0" marL="0">
-              <a:lnSpc>
-                <a:spcPct val="125000"/>
-              </a:lnSpc>
-              <a:buNone/>
-            </a:pPr>
-            <a:r>
-              <a:rPr lang="en-US" sz="1250" dirty="0">
-                <a:solidFill>
-                  <a:srgbClr val="111827"/>
-                </a:solidFill>
-                <a:latin typeface="Calibri" pitchFamily="34" charset="0"/>
-                <a:ea typeface="Calibri" pitchFamily="34" charset="-122"/>
-                <a:cs typeface="Calibri" pitchFamily="34" charset="-120"/>
-              </a:rPr>
-              <a:t>light sensor · 2 Hz</a:t>
-            </a:r>
-            <a:endParaRPr lang="en-US" sz="1250" dirty="0"/>
-          </a:p>
-        </p:txBody>
-      </p:sp>
-      <p:sp>
-        <p:nvSpPr>
-          <p:cNvPr id="8" name="Text 6"/>
-          <p:cNvSpPr/>
-          <p:nvPr/>
-        </p:nvSpPr>
-        <p:spPr>
-          <a:xfrm>
-            <a:off x="868680" y="2971800"/>
-            <a:ext cx="2926080" cy="228600"/>
-          </a:xfrm>
-          <a:prstGeom prst="rect">
-            <a:avLst/>
-          </a:prstGeom>
-          <a:noFill/>
-          <a:ln/>
-        </p:spPr>
-        <p:txBody>
-          <a:bodyPr wrap="square" lIns="0" tIns="0" rIns="0" bIns="0" rtlCol="0" anchor="ctr"/>
-          <a:lstStyle/>
-          <a:p>
-            <a:pPr indent="0" marL="0">
-              <a:buNone/>
-            </a:pPr>
-            <a:r>
-              <a:rPr lang="en-US" sz="950" b="1" spc="200" kern="0" dirty="0">
-                <a:solidFill>
-                  <a:srgbClr val="D97706"/>
-                </a:solidFill>
-                <a:latin typeface="Calibri" pitchFamily="34" charset="0"/>
-                <a:ea typeface="Calibri" pitchFamily="34" charset="-122"/>
-                <a:cs typeface="Calibri" pitchFamily="34" charset="-120"/>
-              </a:rPr>
-              <a:t>ACTS</a:t>
-            </a:r>
-            <a:endParaRPr lang="en-US" sz="950" dirty="0"/>
-          </a:p>
-        </p:txBody>
-      </p:sp>
-      <p:sp>
-        <p:nvSpPr>
-          <p:cNvPr id="9" name="Text 7"/>
-          <p:cNvSpPr/>
-          <p:nvPr/>
-        </p:nvSpPr>
-        <p:spPr>
-          <a:xfrm>
-            <a:off x="868680" y="3227832"/>
-            <a:ext cx="2926080" cy="914400"/>
-          </a:xfrm>
-          <a:prstGeom prst="rect">
-            <a:avLst/>
-          </a:prstGeom>
-          <a:noFill/>
-          <a:ln/>
-        </p:spPr>
-        <p:txBody>
-          <a:bodyPr wrap="square" lIns="0" tIns="0" rIns="0" bIns="0" rtlCol="0" anchor="ctr"/>
-          <a:lstStyle/>
-          <a:p>
-            <a:pPr indent="0" marL="0">
-              <a:lnSpc>
-                <a:spcPct val="125000"/>
-              </a:lnSpc>
-              <a:buNone/>
-            </a:pPr>
-            <a:r>
-              <a:rPr lang="en-US" sz="1250" dirty="0">
-                <a:solidFill>
-                  <a:srgbClr val="111827"/>
-                </a:solidFill>
-                <a:latin typeface="Calibri" pitchFamily="34" charset="0"/>
-                <a:ea typeface="Calibri" pitchFamily="34" charset="-122"/>
-                <a:cs typeface="Calibri" pitchFamily="34" charset="-120"/>
-              </a:rPr>
-              <a:t>reading lamp · ZigBee relay</a:t>
-            </a:r>
-            <a:endParaRPr lang="en-US" sz="1250" dirty="0"/>
-          </a:p>
-          <a:p>
-            <a:pPr indent="0" marL="0">
-              <a:lnSpc>
-                <a:spcPct val="125000"/>
-              </a:lnSpc>
-              <a:buNone/>
-            </a:pPr>
-            <a:r>
-              <a:rPr lang="en-US" sz="1250" dirty="0">
-                <a:solidFill>
-                  <a:srgbClr val="111827"/>
-                </a:solidFill>
-                <a:latin typeface="Calibri" pitchFamily="34" charset="0"/>
-                <a:ea typeface="Calibri" pitchFamily="34" charset="-122"/>
-                <a:cs typeface="Calibri" pitchFamily="34" charset="-120"/>
-              </a:rPr>
-              <a:t>break LED + quiet buzzer</a:t>
-            </a:r>
-            <a:endParaRPr lang="en-US" sz="1250" dirty="0"/>
-          </a:p>
-          <a:p>
-            <a:pPr indent="0" marL="0">
-              <a:lnSpc>
-                <a:spcPct val="125000"/>
-              </a:lnSpc>
-              <a:buNone/>
-            </a:pPr>
-            <a:r>
-              <a:rPr lang="en-US" sz="1250" dirty="0">
-                <a:solidFill>
-                  <a:srgbClr val="111827"/>
-                </a:solidFill>
-                <a:latin typeface="Calibri" pitchFamily="34" charset="0"/>
-                <a:ea typeface="Calibri" pitchFamily="34" charset="-122"/>
-                <a:cs typeface="Calibri" pitchFamily="34" charset="-120"/>
-              </a:rPr>
-              <a:t>status LCD · CO₂ light</a:t>
-            </a:r>
-            <a:endParaRPr lang="en-US" sz="1250" dirty="0"/>
-          </a:p>
-        </p:txBody>
-      </p:sp>
-      <p:sp>
-        <p:nvSpPr>
-          <p:cNvPr id="10" name="Shape 8"/>
-          <p:cNvSpPr/>
-          <p:nvPr/>
-        </p:nvSpPr>
-        <p:spPr>
-          <a:xfrm>
-            <a:off x="868680" y="4434840"/>
-            <a:ext cx="201168" cy="201168"/>
-          </a:xfrm>
-          <a:prstGeom prst="ellipse">
-            <a:avLst/>
-          </a:prstGeom>
-          <a:solidFill>
-            <a:srgbClr val="D97706"/>
-          </a:solidFill>
-          <a:ln/>
-        </p:spPr>
+              <a:t>33 °C</a:t>
+            </a:r>
+            <a:endParaRPr lang="en-US" sz="4400" dirty="0"/>
+          </a:p>
+        </p:txBody>
       </p:sp>
       <p:sp>
         <p:nvSpPr>
@@ -2723,34 +2750,34 @@
         </p:nvSpPr>
         <p:spPr>
           <a:xfrm>
-            <a:off x="1170432" y="4416552"/>
-            <a:ext cx="2743200" cy="457200"/>
-          </a:xfrm>
-          <a:prstGeom prst="rect">
-            <a:avLst/>
-          </a:prstGeom>
-          <a:noFill/>
-          <a:ln/>
-        </p:spPr>
-        <p:txBody>
-          <a:bodyPr wrap="square" lIns="0" tIns="0" rIns="0" bIns="0" rtlCol="0" anchor="ctr"/>
-          <a:lstStyle/>
-          <a:p>
-            <a:pPr indent="0" marL="0">
-              <a:buNone/>
-            </a:pPr>
-            <a:r>
-              <a:rPr lang="en-US" sz="1100" dirty="0">
-                <a:solidFill>
-                  <a:srgbClr val="6B7280"/>
-                </a:solidFill>
-                <a:latin typeface="Calibri" pitchFamily="34" charset="0"/>
-                <a:ea typeface="Calibri" pitchFamily="34" charset="-122"/>
-                <a:cs typeface="Calibri" pitchFamily="34" charset="-120"/>
-              </a:rPr>
-              <a:t>the relay switches a real desk lamp</a:t>
-            </a:r>
-            <a:endParaRPr lang="en-US" sz="1100" dirty="0"/>
+            <a:off x="7452360" y="2331720"/>
+            <a:ext cx="3840480" cy="365760"/>
+          </a:xfrm>
+          <a:prstGeom prst="rect">
+            <a:avLst/>
+          </a:prstGeom>
+          <a:noFill/>
+          <a:ln/>
+        </p:spPr>
+        <p:txBody>
+          <a:bodyPr wrap="square" lIns="0" tIns="0" rIns="0" bIns="0" rtlCol="0" anchor="ctr"/>
+          <a:lstStyle/>
+          <a:p>
+            <a:pPr indent="0" marL="0">
+              <a:buNone/>
+            </a:pPr>
+            <a:r>
+              <a:rPr lang="en-US" sz="1150" dirty="0">
+                <a:solidFill>
+                  <a:srgbClr val="B08D4F"/>
+                </a:solidFill>
+                <a:latin typeface="Calibri" pitchFamily="34" charset="0"/>
+                <a:ea typeface="Calibri" pitchFamily="34" charset="-122"/>
+                <a:cs typeface="Calibri" pitchFamily="34" charset="-120"/>
+              </a:rPr>
+              <a:t>windows stay closed, hotter outside than in</a:t>
+            </a:r>
+            <a:endParaRPr lang="en-US" sz="1150" dirty="0"/>
           </a:p>
         </p:txBody>
       </p:sp>
@@ -2762,20 +2789,20 @@
         </p:nvSpPr>
         <p:spPr>
           <a:xfrm>
-            <a:off x="4709160" y="1325880"/>
-            <a:ext cx="3566160" cy="4343400"/>
+            <a:off x="7223760" y="3063240"/>
+            <a:ext cx="4297680" cy="2331720"/>
           </a:xfrm>
           <a:prstGeom prst="roundRect">
             <a:avLst>
-              <a:gd name="adj" fmla="val 2564"/>
+              <a:gd name="adj" fmla="val 3922"/>
             </a:avLst>
           </a:prstGeom>
           <a:solidFill>
-            <a:srgbClr val="FFFFFF"/>
+            <a:srgbClr val="2A1214"/>
           </a:solidFill>
-          <a:ln w="15875">
+          <a:ln w="12700">
             <a:solidFill>
-              <a:srgbClr val="E5E7EB"/>
+              <a:srgbClr val="7A2E2E"/>
             </a:solidFill>
             <a:prstDash val="solid"/>
           </a:ln>
@@ -2789,69 +2816,249 @@
         </p:nvSpPr>
         <p:spPr>
           <a:xfrm>
-            <a:off x="4937760" y="1481328"/>
-            <a:ext cx="3108960" cy="320040"/>
-          </a:xfrm>
-          <a:prstGeom prst="rect">
-            <a:avLst/>
-          </a:prstGeom>
-          <a:noFill/>
-          <a:ln/>
-        </p:spPr>
-        <p:txBody>
-          <a:bodyPr wrap="square" lIns="0" tIns="0" rIns="0" bIns="0" rtlCol="0" anchor="ctr"/>
-          <a:lstStyle/>
-          <a:p>
-            <a:pPr indent="0" marL="0">
-              <a:buNone/>
-            </a:pPr>
-            <a:r>
-              <a:rPr lang="en-US" sz="1500" b="1" dirty="0">
-                <a:solidFill>
-                  <a:srgbClr val="111827"/>
+            <a:off x="7452360" y="3246120"/>
+            <a:ext cx="3840480" cy="256032"/>
+          </a:xfrm>
+          <a:prstGeom prst="rect">
+            <a:avLst/>
+          </a:prstGeom>
+          <a:noFill/>
+          <a:ln/>
+        </p:spPr>
+        <p:txBody>
+          <a:bodyPr wrap="square" lIns="0" tIns="0" rIns="0" bIns="0" rtlCol="0" anchor="ctr"/>
+          <a:lstStyle/>
+          <a:p>
+            <a:pPr indent="0" marL="0">
+              <a:buNone/>
+            </a:pPr>
+            <a:r>
+              <a:rPr lang="en-US" sz="1050" b="1" spc="200" kern="0" dirty="0">
+                <a:solidFill>
+                  <a:srgbClr val="F0655A"/>
+                </a:solidFill>
+                <a:latin typeface="Calibri" pitchFamily="34" charset="0"/>
+                <a:ea typeface="Calibri" pitchFamily="34" charset="-122"/>
+                <a:cs typeface="Calibri" pitchFamily="34" charset="-120"/>
+              </a:rPr>
+              <a:t>CO₂ CONCENTRATION</a:t>
+            </a:r>
+            <a:endParaRPr lang="en-US" sz="1050" dirty="0"/>
+          </a:p>
+        </p:txBody>
+      </p:sp>
+      <p:sp>
+        <p:nvSpPr>
+          <p:cNvPr id="14" name="Shape 12"/>
+          <p:cNvSpPr/>
+          <p:nvPr/>
+        </p:nvSpPr>
+        <p:spPr>
+          <a:xfrm>
+            <a:off x="7452360" y="3675888"/>
+            <a:ext cx="3840480" cy="0"/>
+          </a:xfrm>
+          <a:prstGeom prst="line">
+            <a:avLst/>
+          </a:prstGeom>
+          <a:noFill/>
+          <a:ln w="25400">
+            <a:solidFill>
+              <a:srgbClr val="F0655A"/>
+            </a:solidFill>
+            <a:prstDash val="solid"/>
+          </a:ln>
+        </p:spPr>
+      </p:sp>
+      <p:sp>
+        <p:nvSpPr>
+          <p:cNvPr id="15" name="Shape 13"/>
+          <p:cNvSpPr/>
+          <p:nvPr/>
+        </p:nvSpPr>
+        <p:spPr>
+          <a:xfrm>
+            <a:off x="9966960" y="3584448"/>
+            <a:ext cx="0" cy="182880"/>
+          </a:xfrm>
+          <a:prstGeom prst="line">
+            <a:avLst/>
+          </a:prstGeom>
+          <a:noFill/>
+          <a:ln w="25400">
+            <a:solidFill>
+              <a:srgbClr val="F0655A"/>
+            </a:solidFill>
+            <a:prstDash val="solid"/>
+          </a:ln>
+        </p:spPr>
+      </p:sp>
+      <p:sp>
+        <p:nvSpPr>
+          <p:cNvPr id="16" name="Text 14"/>
+          <p:cNvSpPr/>
+          <p:nvPr/>
+        </p:nvSpPr>
+        <p:spPr>
+          <a:xfrm>
+            <a:off x="9052560" y="3767328"/>
+            <a:ext cx="2240280" cy="228600"/>
+          </a:xfrm>
+          <a:prstGeom prst="rect">
+            <a:avLst/>
+          </a:prstGeom>
+          <a:noFill/>
+          <a:ln/>
+        </p:spPr>
+        <p:txBody>
+          <a:bodyPr wrap="square" lIns="0" tIns="0" rIns="0" bIns="0" rtlCol="0" anchor="ctr"/>
+          <a:lstStyle/>
+          <a:p>
+            <a:pPr indent="0" marL="0">
+              <a:buNone/>
+            </a:pPr>
+            <a:r>
+              <a:rPr lang="en-US" sz="950" dirty="0">
+                <a:solidFill>
+                  <a:srgbClr val="B76A6A"/>
+                </a:solidFill>
+                <a:latin typeface="Calibri" pitchFamily="34" charset="0"/>
+                <a:ea typeface="Calibri" pitchFamily="34" charset="-122"/>
+                <a:cs typeface="Calibri" pitchFamily="34" charset="-120"/>
+              </a:rPr>
+              <a:t>1,000 ppm threshold</a:t>
+            </a:r>
+            <a:endParaRPr lang="en-US" sz="950" dirty="0"/>
+          </a:p>
+        </p:txBody>
+      </p:sp>
+      <p:sp>
+        <p:nvSpPr>
+          <p:cNvPr id="17" name="Text 15"/>
+          <p:cNvSpPr/>
+          <p:nvPr/>
+        </p:nvSpPr>
+        <p:spPr>
+          <a:xfrm>
+            <a:off x="7452360" y="4023360"/>
+            <a:ext cx="3840480" cy="777240"/>
+          </a:xfrm>
+          <a:prstGeom prst="rect">
+            <a:avLst/>
+          </a:prstGeom>
+          <a:noFill/>
+          <a:ln/>
+        </p:spPr>
+        <p:txBody>
+          <a:bodyPr wrap="square" lIns="0" tIns="0" rIns="0" bIns="0" rtlCol="0" anchor="ctr"/>
+          <a:lstStyle/>
+          <a:p>
+            <a:pPr indent="0" marL="0">
+              <a:buNone/>
+            </a:pPr>
+            <a:r>
+              <a:rPr lang="en-US" sz="4600" b="1" dirty="0">
+                <a:solidFill>
+                  <a:srgbClr val="F0655A"/>
                 </a:solidFill>
                 <a:latin typeface="Cambria" pitchFamily="34" charset="0"/>
                 <a:ea typeface="Cambria" pitchFamily="34" charset="-122"/>
                 <a:cs typeface="Cambria" pitchFamily="34" charset="-120"/>
               </a:rPr>
-              <a:t>Raspberry Pi 5  ·  core</a:t>
-            </a:r>
-            <a:endParaRPr lang="en-US" sz="1500" dirty="0"/>
-          </a:p>
-        </p:txBody>
-      </p:sp>
-      <p:sp>
-        <p:nvSpPr>
-          <p:cNvPr id="14" name="Shape 12"/>
-          <p:cNvSpPr/>
-          <p:nvPr/>
-        </p:nvSpPr>
-        <p:spPr>
-          <a:xfrm>
-            <a:off x="4937760" y="1874520"/>
-            <a:ext cx="3108960" cy="384048"/>
-          </a:xfrm>
-          <a:prstGeom prst="roundRect">
-            <a:avLst>
-              <a:gd name="adj" fmla="val 14286"/>
-            </a:avLst>
-          </a:prstGeom>
-          <a:solidFill>
-            <a:srgbClr val="FBEFD9"/>
-          </a:solidFill>
-          <a:ln/>
-        </p:spPr>
-      </p:sp>
-      <p:sp>
-        <p:nvSpPr>
-          <p:cNvPr id="15" name="Text 13"/>
-          <p:cNvSpPr/>
-          <p:nvPr/>
-        </p:nvSpPr>
-        <p:spPr>
-          <a:xfrm>
-            <a:off x="4937760" y="1911096"/>
-            <a:ext cx="3108960" cy="320040"/>
+              <a:t>1,547</a:t>
+            </a:r>
+            <a:endParaRPr lang="en-US" sz="4600" dirty="0"/>
+          </a:p>
+        </p:txBody>
+      </p:sp>
+      <p:sp>
+        <p:nvSpPr>
+          <p:cNvPr id="18" name="Text 16"/>
+          <p:cNvSpPr/>
+          <p:nvPr/>
+        </p:nvSpPr>
+        <p:spPr>
+          <a:xfrm>
+            <a:off x="7452360" y="4892040"/>
+            <a:ext cx="3840480" cy="457200"/>
+          </a:xfrm>
+          <a:prstGeom prst="rect">
+            <a:avLst/>
+          </a:prstGeom>
+          <a:noFill/>
+          <a:ln/>
+        </p:spPr>
+        <p:txBody>
+          <a:bodyPr wrap="square" lIns="0" tIns="0" rIns="0" bIns="0" rtlCol="0" anchor="ctr"/>
+          <a:lstStyle/>
+          <a:p>
+            <a:pPr indent="0" marL="0">
+              <a:buNone/>
+            </a:pPr>
+            <a:r>
+              <a:rPr lang="en-US" sz="1100" dirty="0">
+                <a:solidFill>
+                  <a:srgbClr val="B76A6A"/>
+                </a:solidFill>
+                <a:latin typeface="Calibri" pitchFamily="34" charset="0"/>
+                <a:ea typeface="Calibri" pitchFamily="34" charset="-122"/>
+                <a:cs typeface="Calibri" pitchFamily="34" charset="-120"/>
+              </a:rPr>
+              <a:t>ppm · cognitive performance declines above 1,000 ppm (Harvard study, 2015)</a:t>
+            </a:r>
+            <a:endParaRPr lang="en-US" sz="1100" dirty="0"/>
+          </a:p>
+        </p:txBody>
+      </p:sp>
+      <p:sp>
+        <p:nvSpPr>
+          <p:cNvPr id="19" name="Text 17"/>
+          <p:cNvSpPr/>
+          <p:nvPr/>
+        </p:nvSpPr>
+        <p:spPr>
+          <a:xfrm>
+            <a:off x="7223760" y="5532120"/>
+            <a:ext cx="4297680" cy="228600"/>
+          </a:xfrm>
+          <a:prstGeom prst="rect">
+            <a:avLst/>
+          </a:prstGeom>
+          <a:noFill/>
+          <a:ln/>
+        </p:spPr>
+        <p:txBody>
+          <a:bodyPr wrap="square" lIns="0" tIns="0" rIns="0" bIns="0" rtlCol="0" anchor="ctr"/>
+          <a:lstStyle/>
+          <a:p>
+            <a:pPr algn="r" indent="0" marL="0">
+              <a:buNone/>
+            </a:pPr>
+            <a:r>
+              <a:rPr lang="en-US" sz="900" spc="200" kern="0" dirty="0">
+                <a:solidFill>
+                  <a:srgbClr val="3A4A63"/>
+                </a:solidFill>
+                <a:latin typeface="Calibri" pitchFamily="34" charset="0"/>
+                <a:ea typeface="Calibri" pitchFamily="34" charset="-122"/>
+                <a:cs typeface="Calibri" pitchFamily="34" charset="-120"/>
+              </a:rPr>
+              <a:t>UNIVERSITÄTSBIBLIOTHEK STUTTGART</a:t>
+            </a:r>
+            <a:endParaRPr lang="en-US" sz="900" dirty="0"/>
+          </a:p>
+        </p:txBody>
+      </p:sp>
+      <p:sp>
+        <p:nvSpPr>
+          <p:cNvPr id="20" name="Text 18"/>
+          <p:cNvSpPr/>
+          <p:nvPr/>
+        </p:nvSpPr>
+        <p:spPr>
+          <a:xfrm>
+            <a:off x="0" y="6035040"/>
+            <a:ext cx="12188952" cy="548640"/>
           </a:xfrm>
           <a:prstGeom prst="rect">
             <a:avLst/>
@@ -2867,1024 +3074,17 @@
               <a:buNone/>
             </a:pPr>
             <a:r>
-              <a:rPr lang="en-US" sz="1150" b="1" dirty="0">
-                <a:solidFill>
-                  <a:srgbClr val="D97706"/>
-                </a:solidFill>
-                <a:latin typeface="Calibri" pitchFamily="34" charset="0"/>
-                <a:ea typeface="Calibri" pitchFamily="34" charset="-122"/>
-                <a:cs typeface="Calibri" pitchFamily="34" charset="-120"/>
-              </a:rPr>
-              <a:t>MQTT broker · Mosquitto</a:t>
-            </a:r>
-            <a:endParaRPr lang="en-US" sz="1150" dirty="0"/>
-          </a:p>
-        </p:txBody>
-      </p:sp>
-      <p:sp>
-        <p:nvSpPr>
-          <p:cNvPr id="16" name="Shape 14"/>
-          <p:cNvSpPr/>
-          <p:nvPr/>
-        </p:nvSpPr>
-        <p:spPr>
-          <a:xfrm>
-            <a:off x="4937760" y="2450592"/>
-            <a:ext cx="3108960" cy="548640"/>
-          </a:xfrm>
-          <a:prstGeom prst="roundRect">
-            <a:avLst>
-              <a:gd name="adj" fmla="val 10000"/>
-            </a:avLst>
-          </a:prstGeom>
-          <a:solidFill>
-            <a:srgbClr val="F3F4F6"/>
-          </a:solidFill>
-          <a:ln/>
-        </p:spPr>
-      </p:sp>
-      <p:sp>
-        <p:nvSpPr>
-          <p:cNvPr id="17" name="Text 15"/>
-          <p:cNvSpPr/>
-          <p:nvPr/>
-        </p:nvSpPr>
-        <p:spPr>
-          <a:xfrm>
-            <a:off x="5047488" y="2496312"/>
-            <a:ext cx="2889504" cy="237744"/>
-          </a:xfrm>
-          <a:prstGeom prst="rect">
-            <a:avLst/>
-          </a:prstGeom>
-          <a:noFill/>
-          <a:ln/>
-        </p:spPr>
-        <p:txBody>
-          <a:bodyPr wrap="square" lIns="0" tIns="0" rIns="0" bIns="0" rtlCol="0" anchor="ctr"/>
-          <a:lstStyle/>
-          <a:p>
-            <a:pPr indent="0" marL="0">
-              <a:buNone/>
-            </a:pPr>
-            <a:r>
-              <a:rPr lang="en-US" sz="1150" b="1" dirty="0">
-                <a:solidFill>
-                  <a:srgbClr val="111827"/>
-                </a:solidFill>
-                <a:latin typeface="Calibri" pitchFamily="34" charset="0"/>
-                <a:ea typeface="Calibri" pitchFamily="34" charset="-122"/>
-                <a:cs typeface="Calibri" pitchFamily="34" charset="-120"/>
-              </a:rPr>
-              <a:t>context</a:t>
-            </a:r>
-            <a:endParaRPr lang="en-US" sz="1150" dirty="0"/>
-          </a:p>
-        </p:txBody>
-      </p:sp>
-      <p:sp>
-        <p:nvSpPr>
-          <p:cNvPr id="18" name="Text 16"/>
-          <p:cNvSpPr/>
-          <p:nvPr/>
-        </p:nvSpPr>
-        <p:spPr>
-          <a:xfrm>
-            <a:off x="5047488" y="2734056"/>
-            <a:ext cx="2889504" cy="228600"/>
-          </a:xfrm>
-          <a:prstGeom prst="rect">
-            <a:avLst/>
-          </a:prstGeom>
-          <a:noFill/>
-          <a:ln/>
-        </p:spPr>
-        <p:txBody>
-          <a:bodyPr wrap="square" lIns="0" tIns="0" rIns="0" bIns="0" rtlCol="0" anchor="ctr"/>
-          <a:lstStyle/>
-          <a:p>
-            <a:pPr indent="0" marL="0">
-              <a:buNone/>
-            </a:pPr>
-            <a:r>
-              <a:rPr lang="en-US" sz="950" dirty="0">
-                <a:solidFill>
-                  <a:srgbClr val="6B7280"/>
-                </a:solidFill>
-                <a:latin typeface="Calibri" pitchFamily="34" charset="0"/>
-                <a:ea typeface="Calibri" pitchFamily="34" charset="-122"/>
-                <a:cs typeface="Calibri" pitchFamily="34" charset="-120"/>
-              </a:rPr>
-              <a:t>world state · CO₂ · session FSM</a:t>
-            </a:r>
-            <a:endParaRPr lang="en-US" sz="950" dirty="0"/>
-          </a:p>
-        </p:txBody>
-      </p:sp>
-      <p:sp>
-        <p:nvSpPr>
-          <p:cNvPr id="19" name="Text 17"/>
-          <p:cNvSpPr/>
-          <p:nvPr/>
-        </p:nvSpPr>
-        <p:spPr>
-          <a:xfrm>
-            <a:off x="6400800" y="2962656"/>
-            <a:ext cx="274320" cy="274320"/>
-          </a:xfrm>
-          <a:prstGeom prst="rect">
-            <a:avLst/>
-          </a:prstGeom>
-          <a:noFill/>
-          <a:ln/>
-        </p:spPr>
-        <p:txBody>
-          <a:bodyPr wrap="square" lIns="0" tIns="0" rIns="0" bIns="0" rtlCol="0" anchor="ctr"/>
-          <a:lstStyle/>
-          <a:p>
-            <a:pPr algn="ctr" indent="0" marL="0">
-              <a:buNone/>
-            </a:pPr>
-            <a:r>
-              <a:rPr lang="en-US" sz="1100" dirty="0">
-                <a:solidFill>
-                  <a:srgbClr val="6B7280"/>
-                </a:solidFill>
-                <a:latin typeface="Calibri" pitchFamily="34" charset="0"/>
-                <a:ea typeface="Calibri" pitchFamily="34" charset="-122"/>
-                <a:cs typeface="Calibri" pitchFamily="34" charset="-120"/>
-              </a:rPr>
-              <a:t>↓</a:t>
-            </a:r>
-            <a:endParaRPr lang="en-US" sz="1100" dirty="0"/>
-          </a:p>
-        </p:txBody>
-      </p:sp>
-      <p:sp>
-        <p:nvSpPr>
-          <p:cNvPr id="20" name="Shape 18"/>
-          <p:cNvSpPr/>
-          <p:nvPr/>
-        </p:nvSpPr>
-        <p:spPr>
-          <a:xfrm>
-            <a:off x="4937760" y="3209544"/>
-            <a:ext cx="3108960" cy="548640"/>
-          </a:xfrm>
-          <a:prstGeom prst="roundRect">
-            <a:avLst>
-              <a:gd name="adj" fmla="val 10000"/>
-            </a:avLst>
-          </a:prstGeom>
-          <a:solidFill>
-            <a:srgbClr val="F3F4F6"/>
-          </a:solidFill>
-          <a:ln/>
-        </p:spPr>
-      </p:sp>
-      <p:sp>
-        <p:nvSpPr>
-          <p:cNvPr id="21" name="Text 19"/>
-          <p:cNvSpPr/>
-          <p:nvPr/>
-        </p:nvSpPr>
-        <p:spPr>
-          <a:xfrm>
-            <a:off x="5047488" y="3255264"/>
-            <a:ext cx="2889504" cy="237744"/>
-          </a:xfrm>
-          <a:prstGeom prst="rect">
-            <a:avLst/>
-          </a:prstGeom>
-          <a:noFill/>
-          <a:ln/>
-        </p:spPr>
-        <p:txBody>
-          <a:bodyPr wrap="square" lIns="0" tIns="0" rIns="0" bIns="0" rtlCol="0" anchor="ctr"/>
-          <a:lstStyle/>
-          <a:p>
-            <a:pPr indent="0" marL="0">
-              <a:buNone/>
-            </a:pPr>
-            <a:r>
-              <a:rPr lang="en-US" sz="1150" b="1" dirty="0">
-                <a:solidFill>
-                  <a:srgbClr val="111827"/>
-                </a:solidFill>
-                <a:latin typeface="Calibri" pitchFamily="34" charset="0"/>
-                <a:ea typeface="Calibri" pitchFamily="34" charset="-122"/>
-                <a:cs typeface="Calibri" pitchFamily="34" charset="-120"/>
-              </a:rPr>
-              <a:t>problem generator</a:t>
-            </a:r>
-            <a:endParaRPr lang="en-US" sz="1150" dirty="0"/>
-          </a:p>
-        </p:txBody>
-      </p:sp>
-      <p:sp>
-        <p:nvSpPr>
-          <p:cNvPr id="22" name="Text 20"/>
-          <p:cNvSpPr/>
-          <p:nvPr/>
-        </p:nvSpPr>
-        <p:spPr>
-          <a:xfrm>
-            <a:off x="5047488" y="3493008"/>
-            <a:ext cx="2889504" cy="228600"/>
-          </a:xfrm>
-          <a:prstGeom prst="rect">
-            <a:avLst/>
-          </a:prstGeom>
-          <a:noFill/>
-          <a:ln/>
-        </p:spPr>
-        <p:txBody>
-          <a:bodyPr wrap="square" lIns="0" tIns="0" rIns="0" bIns="0" rtlCol="0" anchor="ctr"/>
-          <a:lstStyle/>
-          <a:p>
-            <a:pPr indent="0" marL="0">
-              <a:buNone/>
-            </a:pPr>
-            <a:r>
-              <a:rPr lang="en-US" sz="950" dirty="0">
-                <a:solidFill>
-                  <a:srgbClr val="6B7280"/>
-                </a:solidFill>
-                <a:latin typeface="Calibri" pitchFamily="34" charset="0"/>
-                <a:ea typeface="Calibri" pitchFamily="34" charset="-122"/>
-                <a:cs typeface="Calibri" pitchFamily="34" charset="-120"/>
-              </a:rPr>
-              <a:t>state → PDDL goals + weather costs</a:t>
-            </a:r>
-            <a:endParaRPr lang="en-US" sz="950" dirty="0"/>
-          </a:p>
-        </p:txBody>
-      </p:sp>
-      <p:sp>
-        <p:nvSpPr>
-          <p:cNvPr id="23" name="Text 21"/>
-          <p:cNvSpPr/>
-          <p:nvPr/>
-        </p:nvSpPr>
-        <p:spPr>
-          <a:xfrm>
-            <a:off x="6400800" y="3721608"/>
-            <a:ext cx="274320" cy="274320"/>
-          </a:xfrm>
-          <a:prstGeom prst="rect">
-            <a:avLst/>
-          </a:prstGeom>
-          <a:noFill/>
-          <a:ln/>
-        </p:spPr>
-        <p:txBody>
-          <a:bodyPr wrap="square" lIns="0" tIns="0" rIns="0" bIns="0" rtlCol="0" anchor="ctr"/>
-          <a:lstStyle/>
-          <a:p>
-            <a:pPr algn="ctr" indent="0" marL="0">
-              <a:buNone/>
-            </a:pPr>
-            <a:r>
-              <a:rPr lang="en-US" sz="1100" dirty="0">
-                <a:solidFill>
-                  <a:srgbClr val="6B7280"/>
-                </a:solidFill>
-                <a:latin typeface="Calibri" pitchFamily="34" charset="0"/>
-                <a:ea typeface="Calibri" pitchFamily="34" charset="-122"/>
-                <a:cs typeface="Calibri" pitchFamily="34" charset="-120"/>
-              </a:rPr>
-              <a:t>↓</a:t>
-            </a:r>
-            <a:endParaRPr lang="en-US" sz="1100" dirty="0"/>
-          </a:p>
-        </p:txBody>
-      </p:sp>
-      <p:sp>
-        <p:nvSpPr>
-          <p:cNvPr id="24" name="Shape 22"/>
-          <p:cNvSpPr/>
-          <p:nvPr/>
-        </p:nvSpPr>
-        <p:spPr>
-          <a:xfrm>
-            <a:off x="4937760" y="3968496"/>
-            <a:ext cx="3108960" cy="548640"/>
-          </a:xfrm>
-          <a:prstGeom prst="roundRect">
-            <a:avLst>
-              <a:gd name="adj" fmla="val 10000"/>
-            </a:avLst>
-          </a:prstGeom>
-          <a:solidFill>
-            <a:srgbClr val="FBEFD9"/>
-          </a:solidFill>
-          <a:ln w="12700">
-            <a:solidFill>
-              <a:srgbClr val="D97706"/>
-            </a:solidFill>
-            <a:prstDash val="solid"/>
-          </a:ln>
-        </p:spPr>
-      </p:sp>
-      <p:sp>
-        <p:nvSpPr>
-          <p:cNvPr id="25" name="Text 23"/>
-          <p:cNvSpPr/>
-          <p:nvPr/>
-        </p:nvSpPr>
-        <p:spPr>
-          <a:xfrm>
-            <a:off x="5047488" y="4014216"/>
-            <a:ext cx="2889504" cy="237744"/>
-          </a:xfrm>
-          <a:prstGeom prst="rect">
-            <a:avLst/>
-          </a:prstGeom>
-          <a:noFill/>
-          <a:ln/>
-        </p:spPr>
-        <p:txBody>
-          <a:bodyPr wrap="square" lIns="0" tIns="0" rIns="0" bIns="0" rtlCol="0" anchor="ctr"/>
-          <a:lstStyle/>
-          <a:p>
-            <a:pPr indent="0" marL="0">
-              <a:buNone/>
-            </a:pPr>
-            <a:r>
-              <a:rPr lang="en-US" sz="1150" b="1" dirty="0">
-                <a:solidFill>
-                  <a:srgbClr val="D97706"/>
-                </a:solidFill>
-                <a:latin typeface="Calibri" pitchFamily="34" charset="0"/>
-                <a:ea typeface="Calibri" pitchFamily="34" charset="-122"/>
-                <a:cs typeface="Calibri" pitchFamily="34" charset="-120"/>
-              </a:rPr>
-              <a:t>planner · Fast Downward</a:t>
-            </a:r>
-            <a:endParaRPr lang="en-US" sz="1150" dirty="0"/>
-          </a:p>
-        </p:txBody>
-      </p:sp>
-      <p:sp>
-        <p:nvSpPr>
-          <p:cNvPr id="26" name="Text 24"/>
-          <p:cNvSpPr/>
-          <p:nvPr/>
-        </p:nvSpPr>
-        <p:spPr>
-          <a:xfrm>
-            <a:off x="5047488" y="4251960"/>
-            <a:ext cx="2889504" cy="228600"/>
-          </a:xfrm>
-          <a:prstGeom prst="rect">
-            <a:avLst/>
-          </a:prstGeom>
-          <a:noFill/>
-          <a:ln/>
-        </p:spPr>
-        <p:txBody>
-          <a:bodyPr wrap="square" lIns="0" tIns="0" rIns="0" bIns="0" rtlCol="0" anchor="ctr"/>
-          <a:lstStyle/>
-          <a:p>
-            <a:pPr indent="0" marL="0">
-              <a:buNone/>
-            </a:pPr>
-            <a:r>
-              <a:rPr lang="en-US" sz="950" dirty="0">
-                <a:solidFill>
-                  <a:srgbClr val="6B7280"/>
-                </a:solidFill>
-                <a:latin typeface="Calibri" pitchFamily="34" charset="0"/>
-                <a:ea typeface="Calibri" pitchFamily="34" charset="-122"/>
-                <a:cs typeface="Calibri" pitchFamily="34" charset="-120"/>
-              </a:rPr>
-              <a:t>cost-optimal plan, ~130 ms</a:t>
-            </a:r>
-            <a:endParaRPr lang="en-US" sz="950" dirty="0"/>
-          </a:p>
-        </p:txBody>
-      </p:sp>
-      <p:sp>
-        <p:nvSpPr>
-          <p:cNvPr id="27" name="Text 25"/>
-          <p:cNvSpPr/>
-          <p:nvPr/>
-        </p:nvSpPr>
-        <p:spPr>
-          <a:xfrm>
-            <a:off x="6400800" y="4480560"/>
-            <a:ext cx="274320" cy="274320"/>
-          </a:xfrm>
-          <a:prstGeom prst="rect">
-            <a:avLst/>
-          </a:prstGeom>
-          <a:noFill/>
-          <a:ln/>
-        </p:spPr>
-        <p:txBody>
-          <a:bodyPr wrap="square" lIns="0" tIns="0" rIns="0" bIns="0" rtlCol="0" anchor="ctr"/>
-          <a:lstStyle/>
-          <a:p>
-            <a:pPr algn="ctr" indent="0" marL="0">
-              <a:buNone/>
-            </a:pPr>
-            <a:r>
-              <a:rPr lang="en-US" sz="1100" dirty="0">
-                <a:solidFill>
-                  <a:srgbClr val="6B7280"/>
-                </a:solidFill>
-                <a:latin typeface="Calibri" pitchFamily="34" charset="0"/>
-                <a:ea typeface="Calibri" pitchFamily="34" charset="-122"/>
-                <a:cs typeface="Calibri" pitchFamily="34" charset="-120"/>
-              </a:rPr>
-              <a:t>↓</a:t>
-            </a:r>
-            <a:endParaRPr lang="en-US" sz="1100" dirty="0"/>
-          </a:p>
-        </p:txBody>
-      </p:sp>
-      <p:sp>
-        <p:nvSpPr>
-          <p:cNvPr id="28" name="Shape 26"/>
-          <p:cNvSpPr/>
-          <p:nvPr/>
-        </p:nvSpPr>
-        <p:spPr>
-          <a:xfrm>
-            <a:off x="4937760" y="4727448"/>
-            <a:ext cx="3108960" cy="548640"/>
-          </a:xfrm>
-          <a:prstGeom prst="roundRect">
-            <a:avLst>
-              <a:gd name="adj" fmla="val 10000"/>
-            </a:avLst>
-          </a:prstGeom>
-          <a:solidFill>
-            <a:srgbClr val="F3F4F6"/>
-          </a:solidFill>
-          <a:ln/>
-        </p:spPr>
-      </p:sp>
-      <p:sp>
-        <p:nvSpPr>
-          <p:cNvPr id="29" name="Text 27"/>
-          <p:cNvSpPr/>
-          <p:nvPr/>
-        </p:nvSpPr>
-        <p:spPr>
-          <a:xfrm>
-            <a:off x="5047488" y="4773168"/>
-            <a:ext cx="2889504" cy="237744"/>
-          </a:xfrm>
-          <a:prstGeom prst="rect">
-            <a:avLst/>
-          </a:prstGeom>
-          <a:noFill/>
-          <a:ln/>
-        </p:spPr>
-        <p:txBody>
-          <a:bodyPr wrap="square" lIns="0" tIns="0" rIns="0" bIns="0" rtlCol="0" anchor="ctr"/>
-          <a:lstStyle/>
-          <a:p>
-            <a:pPr indent="0" marL="0">
-              <a:buNone/>
-            </a:pPr>
-            <a:r>
-              <a:rPr lang="en-US" sz="1150" b="1" dirty="0">
-                <a:solidFill>
-                  <a:srgbClr val="111827"/>
-                </a:solidFill>
-                <a:latin typeface="Calibri" pitchFamily="34" charset="0"/>
-                <a:ea typeface="Calibri" pitchFamily="34" charset="-122"/>
-                <a:cs typeface="Calibri" pitchFamily="34" charset="-120"/>
-              </a:rPr>
-              <a:t>executor</a:t>
-            </a:r>
-            <a:endParaRPr lang="en-US" sz="1150" dirty="0"/>
-          </a:p>
-        </p:txBody>
-      </p:sp>
-      <p:sp>
-        <p:nvSpPr>
-          <p:cNvPr id="30" name="Text 28"/>
-          <p:cNvSpPr/>
-          <p:nvPr/>
-        </p:nvSpPr>
-        <p:spPr>
-          <a:xfrm>
-            <a:off x="5047488" y="5010912"/>
-            <a:ext cx="2889504" cy="228600"/>
-          </a:xfrm>
-          <a:prstGeom prst="rect">
-            <a:avLst/>
-          </a:prstGeom>
-          <a:noFill/>
-          <a:ln/>
-        </p:spPr>
-        <p:txBody>
-          <a:bodyPr wrap="square" lIns="0" tIns="0" rIns="0" bIns="0" rtlCol="0" anchor="ctr"/>
-          <a:lstStyle/>
-          <a:p>
-            <a:pPr indent="0" marL="0">
-              <a:buNone/>
-            </a:pPr>
-            <a:r>
-              <a:rPr lang="en-US" sz="950" dirty="0">
-                <a:solidFill>
-                  <a:srgbClr val="6B7280"/>
-                </a:solidFill>
-                <a:latin typeface="Calibri" pitchFamily="34" charset="0"/>
-                <a:ea typeface="Calibri" pitchFamily="34" charset="-122"/>
-                <a:cs typeface="Calibri" pitchFamily="34" charset="-120"/>
-              </a:rPr>
-              <a:t>dispatches planned actions</a:t>
-            </a:r>
-            <a:endParaRPr lang="en-US" sz="950" dirty="0"/>
-          </a:p>
-        </p:txBody>
-      </p:sp>
-      <p:sp>
-        <p:nvSpPr>
-          <p:cNvPr id="31" name="Shape 29"/>
-          <p:cNvSpPr/>
-          <p:nvPr/>
-        </p:nvSpPr>
-        <p:spPr>
-          <a:xfrm>
-            <a:off x="9006840" y="1325880"/>
-            <a:ext cx="2560320" cy="4343400"/>
-          </a:xfrm>
-          <a:prstGeom prst="roundRect">
-            <a:avLst>
-              <a:gd name="adj" fmla="val 3571"/>
-            </a:avLst>
-          </a:prstGeom>
-          <a:solidFill>
-            <a:srgbClr val="FFFFFF"/>
-          </a:solidFill>
-          <a:ln w="15875">
-            <a:solidFill>
-              <a:srgbClr val="E5E7EB"/>
-            </a:solidFill>
-            <a:prstDash val="solid"/>
-          </a:ln>
-        </p:spPr>
-      </p:sp>
-      <p:sp>
-        <p:nvSpPr>
-          <p:cNvPr id="32" name="Text 30"/>
-          <p:cNvSpPr/>
-          <p:nvPr/>
-        </p:nvSpPr>
-        <p:spPr>
-          <a:xfrm>
-            <a:off x="9189720" y="1481328"/>
-            <a:ext cx="2194560" cy="320040"/>
-          </a:xfrm>
-          <a:prstGeom prst="rect">
-            <a:avLst/>
-          </a:prstGeom>
-          <a:noFill/>
-          <a:ln/>
-        </p:spPr>
-        <p:txBody>
-          <a:bodyPr wrap="square" lIns="0" tIns="0" rIns="0" bIns="0" rtlCol="0" anchor="ctr"/>
-          <a:lstStyle/>
-          <a:p>
-            <a:pPr indent="0" marL="0">
-              <a:buNone/>
-            </a:pPr>
-            <a:r>
-              <a:rPr lang="en-US" sz="1500" b="1" dirty="0">
-                <a:solidFill>
-                  <a:srgbClr val="111827"/>
+              <a:rPr lang="en-US" sz="2600" b="1" dirty="0">
+                <a:solidFill>
+                  <a:srgbClr val="FFFFFF"/>
                 </a:solidFill>
                 <a:latin typeface="Cambria" pitchFamily="34" charset="0"/>
                 <a:ea typeface="Cambria" pitchFamily="34" charset="-122"/>
                 <a:cs typeface="Cambria" pitchFamily="34" charset="-120"/>
               </a:rPr>
-              <a:t>Laptop · browser</a:t>
-            </a:r>
-            <a:endParaRPr lang="en-US" sz="1500" dirty="0"/>
-          </a:p>
-        </p:txBody>
-      </p:sp>
-      <p:sp>
-        <p:nvSpPr>
-          <p:cNvPr id="33" name="Text 31"/>
-          <p:cNvSpPr/>
-          <p:nvPr/>
-        </p:nvSpPr>
-        <p:spPr>
-          <a:xfrm>
-            <a:off x="9189720" y="1938528"/>
-            <a:ext cx="2194560" cy="228600"/>
-          </a:xfrm>
-          <a:prstGeom prst="rect">
-            <a:avLst/>
-          </a:prstGeom>
-          <a:noFill/>
-          <a:ln/>
-        </p:spPr>
-        <p:txBody>
-          <a:bodyPr wrap="square" lIns="0" tIns="0" rIns="0" bIns="0" rtlCol="0" anchor="ctr"/>
-          <a:lstStyle/>
-          <a:p>
-            <a:pPr indent="0" marL="0">
-              <a:buNone/>
-            </a:pPr>
-            <a:r>
-              <a:rPr lang="en-US" sz="950" b="1" spc="200" kern="0" dirty="0">
-                <a:solidFill>
-                  <a:srgbClr val="1D4ED8"/>
-                </a:solidFill>
-                <a:latin typeface="Calibri" pitchFamily="34" charset="0"/>
-                <a:ea typeface="Calibri" pitchFamily="34" charset="-122"/>
-                <a:cs typeface="Calibri" pitchFamily="34" charset="-120"/>
-              </a:rPr>
-              <a:t>LIVE DASHBOARD</a:t>
-            </a:r>
-            <a:endParaRPr lang="en-US" sz="950" dirty="0"/>
-          </a:p>
-        </p:txBody>
-      </p:sp>
-      <p:sp>
-        <p:nvSpPr>
-          <p:cNvPr id="34" name="Text 32"/>
-          <p:cNvSpPr/>
-          <p:nvPr/>
-        </p:nvSpPr>
-        <p:spPr>
-          <a:xfrm>
-            <a:off x="9189720" y="2194560"/>
-            <a:ext cx="2240280" cy="1371600"/>
-          </a:xfrm>
-          <a:prstGeom prst="rect">
-            <a:avLst/>
-          </a:prstGeom>
-          <a:noFill/>
-          <a:ln/>
-        </p:spPr>
-        <p:txBody>
-          <a:bodyPr wrap="square" lIns="0" tIns="0" rIns="0" bIns="0" rtlCol="0" anchor="ctr"/>
-          <a:lstStyle/>
-          <a:p>
-            <a:pPr indent="0" marL="0">
-              <a:lnSpc>
-                <a:spcPct val="130000"/>
-              </a:lnSpc>
-              <a:buNone/>
-            </a:pPr>
-            <a:r>
-              <a:rPr lang="en-US" sz="1200" dirty="0">
-                <a:solidFill>
-                  <a:srgbClr val="111827"/>
-                </a:solidFill>
-                <a:latin typeface="Calibri" pitchFamily="34" charset="0"/>
-                <a:ea typeface="Calibri" pitchFamily="34" charset="-122"/>
-                <a:cs typeface="Calibri" pitchFamily="34" charset="-120"/>
-              </a:rPr>
-              <a:t>seat floor plan + windows</a:t>
-            </a:r>
-            <a:endParaRPr lang="en-US" sz="1200" dirty="0"/>
-          </a:p>
-          <a:p>
-            <a:pPr indent="0" marL="0">
-              <a:lnSpc>
-                <a:spcPct val="130000"/>
-              </a:lnSpc>
-              <a:buNone/>
-            </a:pPr>
-            <a:r>
-              <a:rPr lang="en-US" sz="1200" dirty="0">
-                <a:solidFill>
-                  <a:srgbClr val="111827"/>
-                </a:solidFill>
-                <a:latin typeface="Calibri" pitchFamily="34" charset="0"/>
-                <a:ea typeface="Calibri" pitchFamily="34" charset="-122"/>
-                <a:cs typeface="Calibri" pitchFamily="34" charset="-120"/>
-              </a:rPr>
-              <a:t>current plan with cost</a:t>
-            </a:r>
-            <a:endParaRPr lang="en-US" sz="1200" dirty="0"/>
-          </a:p>
-          <a:p>
-            <a:pPr indent="0" marL="0">
-              <a:lnSpc>
-                <a:spcPct val="130000"/>
-              </a:lnSpc>
-              <a:buNone/>
-            </a:pPr>
-            <a:r>
-              <a:rPr lang="en-US" sz="1200" dirty="0">
-                <a:solidFill>
-                  <a:srgbClr val="111827"/>
-                </a:solidFill>
-                <a:latin typeface="Calibri" pitchFamily="34" charset="0"/>
-                <a:ea typeface="Calibri" pitchFamily="34" charset="-122"/>
-                <a:cs typeface="Calibri" pitchFamily="34" charset="-120"/>
-              </a:rPr>
-              <a:t>trend charts</a:t>
-            </a:r>
-            <a:endParaRPr lang="en-US" sz="1200" dirty="0"/>
-          </a:p>
-          <a:p>
-            <a:pPr indent="0" marL="0">
-              <a:lnSpc>
-                <a:spcPct val="130000"/>
-              </a:lnSpc>
-              <a:buNone/>
-            </a:pPr>
-            <a:r>
-              <a:rPr lang="en-US" sz="1200" dirty="0">
-                <a:solidFill>
-                  <a:srgbClr val="111827"/>
-                </a:solidFill>
-                <a:latin typeface="Calibri" pitchFamily="34" charset="0"/>
-                <a:ea typeface="Calibri" pitchFamily="34" charset="-122"/>
-                <a:cs typeface="Calibri" pitchFamily="34" charset="-120"/>
-              </a:rPr>
-              <a:t>Pomodoro session rings</a:t>
-            </a:r>
-            <a:endParaRPr lang="en-US" sz="1200" dirty="0"/>
-          </a:p>
-        </p:txBody>
-      </p:sp>
-      <p:sp>
-        <p:nvSpPr>
-          <p:cNvPr id="35" name="Text 33"/>
-          <p:cNvSpPr/>
-          <p:nvPr/>
-        </p:nvSpPr>
-        <p:spPr>
-          <a:xfrm>
-            <a:off x="9189720" y="4160520"/>
-            <a:ext cx="2240280" cy="914400"/>
-          </a:xfrm>
-          <a:prstGeom prst="rect">
-            <a:avLst/>
-          </a:prstGeom>
-          <a:noFill/>
-          <a:ln/>
-        </p:spPr>
-        <p:txBody>
-          <a:bodyPr wrap="square" lIns="0" tIns="0" rIns="0" bIns="0" rtlCol="0" anchor="ctr"/>
-          <a:lstStyle/>
-          <a:p>
-            <a:pPr indent="0" marL="0">
-              <a:buNone/>
-            </a:pPr>
-            <a:r>
-              <a:rPr lang="en-US" sz="1050" dirty="0">
-                <a:solidFill>
-                  <a:srgbClr val="6B7280"/>
-                </a:solidFill>
-                <a:latin typeface="Calibri" pitchFamily="34" charset="0"/>
-                <a:ea typeface="Calibri" pitchFamily="34" charset="-122"/>
-                <a:cs typeface="Calibri" pitchFamily="34" charset="-120"/>
-              </a:rPr>
-              <a:t>in demo mode the laptop joins the WiFi access point spanned by the Pi 5</a:t>
-            </a:r>
-            <a:endParaRPr lang="en-US" sz="1050" dirty="0"/>
-          </a:p>
-        </p:txBody>
-      </p:sp>
-      <p:sp>
-        <p:nvSpPr>
-          <p:cNvPr id="36" name="Shape 34"/>
-          <p:cNvSpPr/>
-          <p:nvPr/>
-        </p:nvSpPr>
-        <p:spPr>
-          <a:xfrm>
-            <a:off x="4059936" y="2148840"/>
-            <a:ext cx="621792" cy="292608"/>
-          </a:xfrm>
-          <a:prstGeom prst="rightArrow">
-            <a:avLst/>
-          </a:prstGeom>
-          <a:solidFill>
-            <a:srgbClr val="15803D"/>
-          </a:solidFill>
-          <a:ln/>
-        </p:spPr>
-      </p:sp>
-      <p:sp>
-        <p:nvSpPr>
-          <p:cNvPr id="37" name="Text 35"/>
-          <p:cNvSpPr/>
-          <p:nvPr/>
-        </p:nvSpPr>
-        <p:spPr>
-          <a:xfrm>
-            <a:off x="3913632" y="1847088"/>
-            <a:ext cx="914400" cy="256032"/>
-          </a:xfrm>
-          <a:prstGeom prst="rect">
-            <a:avLst/>
-          </a:prstGeom>
-          <a:noFill/>
-          <a:ln/>
-        </p:spPr>
-        <p:txBody>
-          <a:bodyPr wrap="square" lIns="0" tIns="0" rIns="0" bIns="0" rtlCol="0" anchor="ctr"/>
-          <a:lstStyle/>
-          <a:p>
-            <a:pPr algn="ctr" indent="0" marL="0">
-              <a:buNone/>
-            </a:pPr>
-            <a:r>
-              <a:rPr lang="en-US" sz="950" dirty="0">
-                <a:solidFill>
-                  <a:srgbClr val="6B7280"/>
-                </a:solidFill>
-                <a:latin typeface="Calibri" pitchFamily="34" charset="0"/>
-                <a:ea typeface="Calibri" pitchFamily="34" charset="-122"/>
-                <a:cs typeface="Calibri" pitchFamily="34" charset="-120"/>
-              </a:rPr>
-              <a:t>sensor data</a:t>
-            </a:r>
-            <a:endParaRPr lang="en-US" sz="950" dirty="0"/>
-          </a:p>
-        </p:txBody>
-      </p:sp>
-      <p:sp>
-        <p:nvSpPr>
-          <p:cNvPr id="38" name="Shape 36"/>
-          <p:cNvSpPr/>
-          <p:nvPr/>
-        </p:nvSpPr>
-        <p:spPr>
-          <a:xfrm>
-            <a:off x="4059936" y="4297680"/>
-            <a:ext cx="621792" cy="292608"/>
-          </a:xfrm>
-          <a:prstGeom prst="leftArrow">
-            <a:avLst/>
-          </a:prstGeom>
-          <a:solidFill>
-            <a:srgbClr val="D97706"/>
-          </a:solidFill>
-          <a:ln/>
-        </p:spPr>
-      </p:sp>
-      <p:sp>
-        <p:nvSpPr>
-          <p:cNvPr id="39" name="Text 37"/>
-          <p:cNvSpPr/>
-          <p:nvPr/>
-        </p:nvSpPr>
-        <p:spPr>
-          <a:xfrm>
-            <a:off x="3913632" y="4626864"/>
-            <a:ext cx="914400" cy="256032"/>
-          </a:xfrm>
-          <a:prstGeom prst="rect">
-            <a:avLst/>
-          </a:prstGeom>
-          <a:noFill/>
-          <a:ln/>
-        </p:spPr>
-        <p:txBody>
-          <a:bodyPr wrap="square" lIns="0" tIns="0" rIns="0" bIns="0" rtlCol="0" anchor="ctr"/>
-          <a:lstStyle/>
-          <a:p>
-            <a:pPr algn="ctr" indent="0" marL="0">
-              <a:buNone/>
-            </a:pPr>
-            <a:r>
-              <a:rPr lang="en-US" sz="950" dirty="0">
-                <a:solidFill>
-                  <a:srgbClr val="6B7280"/>
-                </a:solidFill>
-                <a:latin typeface="Calibri" pitchFamily="34" charset="0"/>
-                <a:ea typeface="Calibri" pitchFamily="34" charset="-122"/>
-                <a:cs typeface="Calibri" pitchFamily="34" charset="-120"/>
-              </a:rPr>
-              <a:t>actions</a:t>
-            </a:r>
-            <a:endParaRPr lang="en-US" sz="950" dirty="0"/>
-          </a:p>
-        </p:txBody>
-      </p:sp>
-      <p:sp>
-        <p:nvSpPr>
-          <p:cNvPr id="40" name="Shape 38"/>
-          <p:cNvSpPr/>
-          <p:nvPr/>
-        </p:nvSpPr>
-        <p:spPr>
-          <a:xfrm>
-            <a:off x="8311896" y="2148840"/>
-            <a:ext cx="621792" cy="292608"/>
-          </a:xfrm>
-          <a:prstGeom prst="rightArrow">
-            <a:avLst/>
-          </a:prstGeom>
-          <a:solidFill>
-            <a:srgbClr val="1D4ED8"/>
-          </a:solidFill>
-          <a:ln/>
-        </p:spPr>
-      </p:sp>
-      <p:sp>
-        <p:nvSpPr>
-          <p:cNvPr id="41" name="Text 39"/>
-          <p:cNvSpPr/>
-          <p:nvPr/>
-        </p:nvSpPr>
-        <p:spPr>
-          <a:xfrm>
-            <a:off x="8156448" y="1847088"/>
-            <a:ext cx="960120" cy="256032"/>
-          </a:xfrm>
-          <a:prstGeom prst="rect">
-            <a:avLst/>
-          </a:prstGeom>
-          <a:noFill/>
-          <a:ln/>
-        </p:spPr>
-        <p:txBody>
-          <a:bodyPr wrap="square" lIns="0" tIns="0" rIns="0" bIns="0" rtlCol="0" anchor="ctr"/>
-          <a:lstStyle/>
-          <a:p>
-            <a:pPr algn="ctr" indent="0" marL="0">
-              <a:buNone/>
-            </a:pPr>
-            <a:r>
-              <a:rPr lang="en-US" sz="950" dirty="0">
-                <a:solidFill>
-                  <a:srgbClr val="6B7280"/>
-                </a:solidFill>
-                <a:latin typeface="Calibri" pitchFamily="34" charset="0"/>
-                <a:ea typeface="Calibri" pitchFamily="34" charset="-122"/>
-                <a:cs typeface="Calibri" pitchFamily="34" charset="-120"/>
-              </a:rPr>
-              <a:t>state + plan</a:t>
-            </a:r>
-            <a:endParaRPr lang="en-US" sz="950" dirty="0"/>
-          </a:p>
-        </p:txBody>
-      </p:sp>
-      <p:sp>
-        <p:nvSpPr>
-          <p:cNvPr id="42" name="Shape 40"/>
-          <p:cNvSpPr/>
-          <p:nvPr/>
-        </p:nvSpPr>
-        <p:spPr>
-          <a:xfrm>
-            <a:off x="640080" y="5989320"/>
-            <a:ext cx="10927080" cy="0"/>
-          </a:xfrm>
-          <a:prstGeom prst="line">
-            <a:avLst/>
-          </a:prstGeom>
-          <a:noFill/>
-          <a:ln w="9525">
-            <a:solidFill>
-              <a:srgbClr val="E5E7EB"/>
-            </a:solidFill>
-            <a:prstDash val="solid"/>
-          </a:ln>
-        </p:spPr>
-      </p:sp>
-      <p:sp>
-        <p:nvSpPr>
-          <p:cNvPr id="43" name="Text 41"/>
-          <p:cNvSpPr/>
-          <p:nvPr/>
-        </p:nvSpPr>
-        <p:spPr>
-          <a:xfrm>
-            <a:off x="640080" y="6126480"/>
-            <a:ext cx="10927080" cy="457200"/>
-          </a:xfrm>
-          <a:prstGeom prst="rect">
-            <a:avLst/>
-          </a:prstGeom>
-          <a:noFill/>
-          <a:ln/>
-        </p:spPr>
-        <p:txBody>
-          <a:bodyPr wrap="square" lIns="0" tIns="0" rIns="0" bIns="0" rtlCol="0" anchor="ctr"/>
-          <a:lstStyle/>
-          <a:p>
-            <a:pPr algn="ctr" indent="0" marL="0">
-              <a:buNone/>
-            </a:pPr>
-            <a:r>
-              <a:rPr lang="en-US" sz="1250" dirty="0">
-                <a:solidFill>
-                  <a:srgbClr val="6B7280"/>
-                </a:solidFill>
-                <a:latin typeface="Calibri" pitchFamily="34" charset="0"/>
-                <a:ea typeface="Calibri" pitchFamily="34" charset="-122"/>
-                <a:cs typeface="Calibri" pitchFamily="34" charset="-120"/>
-              </a:rPr>
-              <a:t>In effect: the lamp follows occupancy and darkness · the airing strategy follows weather costs · breaks are nudged after 2 min · disturbances are corrected in under 1 s</a:t>
-            </a:r>
-            <a:endParaRPr lang="en-US" sz="1250" dirty="0"/>
+              <a:t>What if the room could?</a:t>
+            </a:r>
+            <a:endParaRPr lang="en-US" sz="2600" dirty="0"/>
           </a:p>
         </p:txBody>
       </p:sp>
@@ -3953,7 +3153,7 @@
                 <a:ea typeface="Calibri" pitchFamily="34" charset="-122"/>
                 <a:cs typeface="Calibri" pitchFamily="34" charset="-120"/>
               </a:rPr>
-              <a:t>WHY</a:t>
+              <a:t>HOW IT WORKS</a:t>
             </a:r>
             <a:endParaRPr lang="en-US" sz="1100" dirty="0"/>
           </a:p>
@@ -3992,7 +3192,7 @@
                 <a:ea typeface="Cambria" pitchFamily="34" charset="-122"/>
                 <a:cs typeface="Cambria" pitchFamily="34" charset="-120"/>
               </a:rPr>
-              <a:t>A hot summer, a full library</a:t>
+              <a:t>Setup: two Raspberry Pis and a browser dashboard</a:t>
             </a:r>
             <a:endParaRPr lang="en-US" sz="3000" dirty="0"/>
           </a:p>
@@ -4000,30 +3200,57 @@
       </p:sp>
       <p:sp>
         <p:nvSpPr>
-          <p:cNvPr id="4" name="Text 2"/>
-          <p:cNvSpPr/>
-          <p:nvPr/>
-        </p:nvSpPr>
-        <p:spPr>
-          <a:xfrm>
-            <a:off x="640080" y="2011680"/>
-            <a:ext cx="3474720" cy="1005840"/>
-          </a:xfrm>
-          <a:prstGeom prst="rect">
-            <a:avLst/>
-          </a:prstGeom>
-          <a:noFill/>
-          <a:ln/>
-        </p:spPr>
-        <p:txBody>
-          <a:bodyPr wrap="square" lIns="0" tIns="0" rIns="0" bIns="0" rtlCol="0" anchor="ctr"/>
-          <a:lstStyle/>
-          <a:p>
-            <a:pPr indent="0" marL="0">
-              <a:buNone/>
-            </a:pPr>
-            <a:r>
-              <a:rPr lang="en-US" sz="5200" b="1" dirty="0">
+          <p:cNvPr id="4" name="Shape 2"/>
+          <p:cNvSpPr/>
+          <p:nvPr/>
+        </p:nvSpPr>
+        <p:spPr>
+          <a:xfrm>
+            <a:off x="640080" y="1325880"/>
+            <a:ext cx="3383280" cy="4343400"/>
+          </a:xfrm>
+          <a:prstGeom prst="roundRect">
+            <a:avLst>
+              <a:gd name="adj" fmla="val 2703"/>
+            </a:avLst>
+          </a:prstGeom>
+          <a:solidFill>
+            <a:srgbClr val="FFFFFF"/>
+          </a:solidFill>
+          <a:ln w="15875">
+            <a:solidFill>
+              <a:srgbClr val="E5E7EB"/>
+            </a:solidFill>
+            <a:prstDash val="solid"/>
+          </a:ln>
+        </p:spPr>
+      </p:sp>
+      <p:sp>
+        <p:nvSpPr>
+          <p:cNvPr id="5" name="Text 3"/>
+          <p:cNvSpPr/>
+          <p:nvPr/>
+        </p:nvSpPr>
+        <p:spPr>
+          <a:xfrm>
+            <a:off x="868680" y="1481328"/>
+            <a:ext cx="2926080" cy="320040"/>
+          </a:xfrm>
+          <a:prstGeom prst="rect">
+            <a:avLst/>
+          </a:prstGeom>
+          <a:noFill/>
+          <a:ln/>
+        </p:spPr>
+        <p:txBody>
+          <a:bodyPr wrap="square" lIns="0" tIns="0" rIns="0" bIns="0" rtlCol="0" anchor="ctr"/>
+          <a:lstStyle/>
+          <a:p>
+            <a:pPr indent="0" marL="0">
+              <a:buNone/>
+            </a:pPr>
+            <a:r>
+              <a:rPr lang="en-US" sz="1500" b="1" dirty="0">
                 <a:solidFill>
                   <a:srgbClr val="111827"/>
                 </a:solidFill>
@@ -4031,38 +3258,280 @@
                 <a:ea typeface="Cambria" pitchFamily="34" charset="-122"/>
                 <a:cs typeface="Cambria" pitchFamily="34" charset="-120"/>
               </a:rPr>
-              <a:t>35 °C+</a:t>
-            </a:r>
-            <a:endParaRPr lang="en-US" sz="5200" dirty="0"/>
-          </a:p>
-        </p:txBody>
-      </p:sp>
-      <p:sp>
-        <p:nvSpPr>
-          <p:cNvPr id="5" name="Text 3"/>
-          <p:cNvSpPr/>
-          <p:nvPr/>
-        </p:nvSpPr>
-        <p:spPr>
-          <a:xfrm>
-            <a:off x="640080" y="3154680"/>
-            <a:ext cx="3246120" cy="1005840"/>
-          </a:xfrm>
-          <a:prstGeom prst="rect">
-            <a:avLst/>
-          </a:prstGeom>
-          <a:noFill/>
-          <a:ln/>
-        </p:spPr>
-        <p:txBody>
-          <a:bodyPr wrap="square" lIns="0" tIns="0" rIns="0" bIns="0" rtlCol="0" anchor="ctr"/>
-          <a:lstStyle/>
-          <a:p>
-            <a:pPr indent="0" marL="0">
-              <a:buNone/>
-            </a:pPr>
-            <a:r>
-              <a:rPr lang="en-US" sz="1450" dirty="0">
+              <a:t>Raspberry Pi 3 B+  ·  edge</a:t>
+            </a:r>
+            <a:endParaRPr lang="en-US" sz="1500" dirty="0"/>
+          </a:p>
+        </p:txBody>
+      </p:sp>
+      <p:sp>
+        <p:nvSpPr>
+          <p:cNvPr id="6" name="Text 4"/>
+          <p:cNvSpPr/>
+          <p:nvPr/>
+        </p:nvSpPr>
+        <p:spPr>
+          <a:xfrm>
+            <a:off x="868680" y="1938528"/>
+            <a:ext cx="2926080" cy="228600"/>
+          </a:xfrm>
+          <a:prstGeom prst="rect">
+            <a:avLst/>
+          </a:prstGeom>
+          <a:noFill/>
+          <a:ln/>
+        </p:spPr>
+        <p:txBody>
+          <a:bodyPr wrap="square" lIns="0" tIns="0" rIns="0" bIns="0" rtlCol="0" anchor="ctr"/>
+          <a:lstStyle/>
+          <a:p>
+            <a:pPr indent="0" marL="0">
+              <a:buNone/>
+            </a:pPr>
+            <a:r>
+              <a:rPr lang="en-US" sz="950" b="1" spc="200" kern="0" dirty="0">
+                <a:solidFill>
+                  <a:srgbClr val="15803D"/>
+                </a:solidFill>
+                <a:latin typeface="Calibri" pitchFamily="34" charset="0"/>
+                <a:ea typeface="Calibri" pitchFamily="34" charset="-122"/>
+                <a:cs typeface="Calibri" pitchFamily="34" charset="-120"/>
+              </a:rPr>
+              <a:t>SENSES</a:t>
+            </a:r>
+            <a:endParaRPr lang="en-US" sz="950" dirty="0"/>
+          </a:p>
+        </p:txBody>
+      </p:sp>
+      <p:sp>
+        <p:nvSpPr>
+          <p:cNvPr id="7" name="Text 5"/>
+          <p:cNvSpPr/>
+          <p:nvPr/>
+        </p:nvSpPr>
+        <p:spPr>
+          <a:xfrm>
+            <a:off x="868680" y="2194560"/>
+            <a:ext cx="2926080" cy="594360"/>
+          </a:xfrm>
+          <a:prstGeom prst="rect">
+            <a:avLst/>
+          </a:prstGeom>
+          <a:noFill/>
+          <a:ln/>
+        </p:spPr>
+        <p:txBody>
+          <a:bodyPr wrap="square" lIns="0" tIns="0" rIns="0" bIns="0" rtlCol="0" anchor="ctr"/>
+          <a:lstStyle/>
+          <a:p>
+            <a:pPr indent="0" marL="0">
+              <a:lnSpc>
+                <a:spcPct val="125000"/>
+              </a:lnSpc>
+              <a:buNone/>
+            </a:pPr>
+            <a:r>
+              <a:rPr lang="en-US" sz="1250" dirty="0">
+                <a:solidFill>
+                  <a:srgbClr val="111827"/>
+                </a:solidFill>
+                <a:latin typeface="Calibri" pitchFamily="34" charset="0"/>
+                <a:ea typeface="Calibri" pitchFamily="34" charset="-122"/>
+                <a:cs typeface="Calibri" pitchFamily="34" charset="-120"/>
+              </a:rPr>
+              <a:t>motion sensor · 2 Hz</a:t>
+            </a:r>
+            <a:endParaRPr lang="en-US" sz="1250" dirty="0"/>
+          </a:p>
+          <a:p>
+            <a:pPr indent="0" marL="0">
+              <a:lnSpc>
+                <a:spcPct val="125000"/>
+              </a:lnSpc>
+              <a:buNone/>
+            </a:pPr>
+            <a:r>
+              <a:rPr lang="en-US" sz="1250" dirty="0">
+                <a:solidFill>
+                  <a:srgbClr val="111827"/>
+                </a:solidFill>
+                <a:latin typeface="Calibri" pitchFamily="34" charset="0"/>
+                <a:ea typeface="Calibri" pitchFamily="34" charset="-122"/>
+                <a:cs typeface="Calibri" pitchFamily="34" charset="-120"/>
+              </a:rPr>
+              <a:t>light sensor · 2 Hz</a:t>
+            </a:r>
+            <a:endParaRPr lang="en-US" sz="1250" dirty="0"/>
+          </a:p>
+        </p:txBody>
+      </p:sp>
+      <p:sp>
+        <p:nvSpPr>
+          <p:cNvPr id="8" name="Text 6"/>
+          <p:cNvSpPr/>
+          <p:nvPr/>
+        </p:nvSpPr>
+        <p:spPr>
+          <a:xfrm>
+            <a:off x="868680" y="2971800"/>
+            <a:ext cx="2926080" cy="228600"/>
+          </a:xfrm>
+          <a:prstGeom prst="rect">
+            <a:avLst/>
+          </a:prstGeom>
+          <a:noFill/>
+          <a:ln/>
+        </p:spPr>
+        <p:txBody>
+          <a:bodyPr wrap="square" lIns="0" tIns="0" rIns="0" bIns="0" rtlCol="0" anchor="ctr"/>
+          <a:lstStyle/>
+          <a:p>
+            <a:pPr indent="0" marL="0">
+              <a:buNone/>
+            </a:pPr>
+            <a:r>
+              <a:rPr lang="en-US" sz="950" b="1" spc="200" kern="0" dirty="0">
+                <a:solidFill>
+                  <a:srgbClr val="D97706"/>
+                </a:solidFill>
+                <a:latin typeface="Calibri" pitchFamily="34" charset="0"/>
+                <a:ea typeface="Calibri" pitchFamily="34" charset="-122"/>
+                <a:cs typeface="Calibri" pitchFamily="34" charset="-120"/>
+              </a:rPr>
+              <a:t>ACTS</a:t>
+            </a:r>
+            <a:endParaRPr lang="en-US" sz="950" dirty="0"/>
+          </a:p>
+        </p:txBody>
+      </p:sp>
+      <p:sp>
+        <p:nvSpPr>
+          <p:cNvPr id="9" name="Text 7"/>
+          <p:cNvSpPr/>
+          <p:nvPr/>
+        </p:nvSpPr>
+        <p:spPr>
+          <a:xfrm>
+            <a:off x="868680" y="3227832"/>
+            <a:ext cx="2926080" cy="914400"/>
+          </a:xfrm>
+          <a:prstGeom prst="rect">
+            <a:avLst/>
+          </a:prstGeom>
+          <a:noFill/>
+          <a:ln/>
+        </p:spPr>
+        <p:txBody>
+          <a:bodyPr wrap="square" lIns="0" tIns="0" rIns="0" bIns="0" rtlCol="0" anchor="ctr"/>
+          <a:lstStyle/>
+          <a:p>
+            <a:pPr indent="0" marL="0">
+              <a:lnSpc>
+                <a:spcPct val="125000"/>
+              </a:lnSpc>
+              <a:buNone/>
+            </a:pPr>
+            <a:r>
+              <a:rPr lang="en-US" sz="1250" dirty="0">
+                <a:solidFill>
+                  <a:srgbClr val="111827"/>
+                </a:solidFill>
+                <a:latin typeface="Calibri" pitchFamily="34" charset="0"/>
+                <a:ea typeface="Calibri" pitchFamily="34" charset="-122"/>
+                <a:cs typeface="Calibri" pitchFamily="34" charset="-120"/>
+              </a:rPr>
+              <a:t>reading lamp · ZigBee relay</a:t>
+            </a:r>
+            <a:endParaRPr lang="en-US" sz="1250" dirty="0"/>
+          </a:p>
+          <a:p>
+            <a:pPr indent="0" marL="0">
+              <a:lnSpc>
+                <a:spcPct val="125000"/>
+              </a:lnSpc>
+              <a:buNone/>
+            </a:pPr>
+            <a:r>
+              <a:rPr lang="en-US" sz="1250" dirty="0">
+                <a:solidFill>
+                  <a:srgbClr val="111827"/>
+                </a:solidFill>
+                <a:latin typeface="Calibri" pitchFamily="34" charset="0"/>
+                <a:ea typeface="Calibri" pitchFamily="34" charset="-122"/>
+                <a:cs typeface="Calibri" pitchFamily="34" charset="-120"/>
+              </a:rPr>
+              <a:t>break LED + quiet buzzer</a:t>
+            </a:r>
+            <a:endParaRPr lang="en-US" sz="1250" dirty="0"/>
+          </a:p>
+          <a:p>
+            <a:pPr indent="0" marL="0">
+              <a:lnSpc>
+                <a:spcPct val="125000"/>
+              </a:lnSpc>
+              <a:buNone/>
+            </a:pPr>
+            <a:r>
+              <a:rPr lang="en-US" sz="1250" dirty="0">
+                <a:solidFill>
+                  <a:srgbClr val="111827"/>
+                </a:solidFill>
+                <a:latin typeface="Calibri" pitchFamily="34" charset="0"/>
+                <a:ea typeface="Calibri" pitchFamily="34" charset="-122"/>
+                <a:cs typeface="Calibri" pitchFamily="34" charset="-120"/>
+              </a:rPr>
+              <a:t>status LCD · CO₂ light</a:t>
+            </a:r>
+            <a:endParaRPr lang="en-US" sz="1250" dirty="0"/>
+          </a:p>
+        </p:txBody>
+      </p:sp>
+      <p:sp>
+        <p:nvSpPr>
+          <p:cNvPr id="10" name="Shape 8"/>
+          <p:cNvSpPr/>
+          <p:nvPr/>
+        </p:nvSpPr>
+        <p:spPr>
+          <a:xfrm>
+            <a:off x="868680" y="4434840"/>
+            <a:ext cx="201168" cy="201168"/>
+          </a:xfrm>
+          <a:prstGeom prst="ellipse">
+            <a:avLst/>
+          </a:prstGeom>
+          <a:solidFill>
+            <a:srgbClr val="D97706"/>
+          </a:solidFill>
+          <a:ln/>
+        </p:spPr>
+      </p:sp>
+      <p:sp>
+        <p:nvSpPr>
+          <p:cNvPr id="11" name="Text 9"/>
+          <p:cNvSpPr/>
+          <p:nvPr/>
+        </p:nvSpPr>
+        <p:spPr>
+          <a:xfrm>
+            <a:off x="1170432" y="4416552"/>
+            <a:ext cx="2743200" cy="457200"/>
+          </a:xfrm>
+          <a:prstGeom prst="rect">
+            <a:avLst/>
+          </a:prstGeom>
+          <a:noFill/>
+          <a:ln/>
+        </p:spPr>
+        <p:txBody>
+          <a:bodyPr wrap="square" lIns="0" tIns="0" rIns="0" bIns="0" rtlCol="0" anchor="ctr"/>
+          <a:lstStyle/>
+          <a:p>
+            <a:pPr indent="0" marL="0">
+              <a:buNone/>
+            </a:pPr>
+            <a:r>
+              <a:rPr lang="en-US" sz="1100" dirty="0">
                 <a:solidFill>
                   <a:srgbClr val="6B7280"/>
                 </a:solidFill>
@@ -4070,38 +3539,65 @@
                 <a:ea typeface="Calibri" pitchFamily="34" charset="-122"/>
                 <a:cs typeface="Calibri" pitchFamily="34" charset="-120"/>
               </a:rPr>
-              <a:t>record heat sends students into the cool, quiet library</a:t>
-            </a:r>
-            <a:endParaRPr lang="en-US" sz="1450" dirty="0"/>
-          </a:p>
-        </p:txBody>
-      </p:sp>
-      <p:sp>
-        <p:nvSpPr>
-          <p:cNvPr id="6" name="Text 4"/>
-          <p:cNvSpPr/>
-          <p:nvPr/>
-        </p:nvSpPr>
-        <p:spPr>
-          <a:xfrm>
-            <a:off x="4480560" y="2011680"/>
-            <a:ext cx="3474720" cy="1005840"/>
-          </a:xfrm>
-          <a:prstGeom prst="rect">
-            <a:avLst/>
-          </a:prstGeom>
-          <a:noFill/>
-          <a:ln/>
-        </p:spPr>
-        <p:txBody>
-          <a:bodyPr wrap="square" lIns="0" tIns="0" rIns="0" bIns="0" rtlCol="0" anchor="ctr"/>
-          <a:lstStyle/>
-          <a:p>
-            <a:pPr indent="0" marL="0">
-              <a:buNone/>
-            </a:pPr>
-            <a:r>
-              <a:rPr lang="en-US" sz="5200" b="1" dirty="0">
+              <a:t>the relay switches a real desk lamp</a:t>
+            </a:r>
+            <a:endParaRPr lang="en-US" sz="1100" dirty="0"/>
+          </a:p>
+        </p:txBody>
+      </p:sp>
+      <p:sp>
+        <p:nvSpPr>
+          <p:cNvPr id="12" name="Shape 10"/>
+          <p:cNvSpPr/>
+          <p:nvPr/>
+        </p:nvSpPr>
+        <p:spPr>
+          <a:xfrm>
+            <a:off x="4709160" y="1325880"/>
+            <a:ext cx="3566160" cy="4343400"/>
+          </a:xfrm>
+          <a:prstGeom prst="roundRect">
+            <a:avLst>
+              <a:gd name="adj" fmla="val 2564"/>
+            </a:avLst>
+          </a:prstGeom>
+          <a:solidFill>
+            <a:srgbClr val="FFFFFF"/>
+          </a:solidFill>
+          <a:ln w="15875">
+            <a:solidFill>
+              <a:srgbClr val="E5E7EB"/>
+            </a:solidFill>
+            <a:prstDash val="solid"/>
+          </a:ln>
+        </p:spPr>
+      </p:sp>
+      <p:sp>
+        <p:nvSpPr>
+          <p:cNvPr id="13" name="Text 11"/>
+          <p:cNvSpPr/>
+          <p:nvPr/>
+        </p:nvSpPr>
+        <p:spPr>
+          <a:xfrm>
+            <a:off x="4937760" y="1481328"/>
+            <a:ext cx="3108960" cy="320040"/>
+          </a:xfrm>
+          <a:prstGeom prst="rect">
+            <a:avLst/>
+          </a:prstGeom>
+          <a:noFill/>
+          <a:ln/>
+        </p:spPr>
+        <p:txBody>
+          <a:bodyPr wrap="square" lIns="0" tIns="0" rIns="0" bIns="0" rtlCol="0" anchor="ctr"/>
+          <a:lstStyle/>
+          <a:p>
+            <a:pPr indent="0" marL="0">
+              <a:buNone/>
+            </a:pPr>
+            <a:r>
+              <a:rPr lang="en-US" sz="1500" b="1" dirty="0">
                 <a:solidFill>
                   <a:srgbClr val="111827"/>
                 </a:solidFill>
@@ -4109,38 +3605,160 @@
                 <a:ea typeface="Cambria" pitchFamily="34" charset="-122"/>
                 <a:cs typeface="Cambria" pitchFamily="34" charset="-120"/>
               </a:rPr>
-              <a:t>~40 %</a:t>
-            </a:r>
-            <a:endParaRPr lang="en-US" sz="5200" dirty="0"/>
-          </a:p>
-        </p:txBody>
-      </p:sp>
-      <p:sp>
-        <p:nvSpPr>
-          <p:cNvPr id="7" name="Text 5"/>
-          <p:cNvSpPr/>
-          <p:nvPr/>
-        </p:nvSpPr>
-        <p:spPr>
-          <a:xfrm>
-            <a:off x="4480560" y="3154680"/>
-            <a:ext cx="3246120" cy="1005840"/>
-          </a:xfrm>
-          <a:prstGeom prst="rect">
-            <a:avLst/>
-          </a:prstGeom>
-          <a:noFill/>
-          <a:ln/>
-        </p:spPr>
-        <p:txBody>
-          <a:bodyPr wrap="square" lIns="0" tIns="0" rIns="0" bIns="0" rtlCol="0" anchor="ctr"/>
-          <a:lstStyle/>
-          <a:p>
-            <a:pPr indent="0" marL="0">
-              <a:buNone/>
-            </a:pPr>
-            <a:r>
-              <a:rPr lang="en-US" sz="1450" dirty="0">
+              <a:t>Raspberry Pi 5  ·  core</a:t>
+            </a:r>
+            <a:endParaRPr lang="en-US" sz="1500" dirty="0"/>
+          </a:p>
+        </p:txBody>
+      </p:sp>
+      <p:sp>
+        <p:nvSpPr>
+          <p:cNvPr id="14" name="Shape 12"/>
+          <p:cNvSpPr/>
+          <p:nvPr/>
+        </p:nvSpPr>
+        <p:spPr>
+          <a:xfrm>
+            <a:off x="4937760" y="1874520"/>
+            <a:ext cx="3108960" cy="384048"/>
+          </a:xfrm>
+          <a:prstGeom prst="roundRect">
+            <a:avLst>
+              <a:gd name="adj" fmla="val 14286"/>
+            </a:avLst>
+          </a:prstGeom>
+          <a:solidFill>
+            <a:srgbClr val="FBEFD9"/>
+          </a:solidFill>
+          <a:ln/>
+        </p:spPr>
+      </p:sp>
+      <p:sp>
+        <p:nvSpPr>
+          <p:cNvPr id="15" name="Text 13"/>
+          <p:cNvSpPr/>
+          <p:nvPr/>
+        </p:nvSpPr>
+        <p:spPr>
+          <a:xfrm>
+            <a:off x="4937760" y="1911096"/>
+            <a:ext cx="3108960" cy="320040"/>
+          </a:xfrm>
+          <a:prstGeom prst="rect">
+            <a:avLst/>
+          </a:prstGeom>
+          <a:noFill/>
+          <a:ln/>
+        </p:spPr>
+        <p:txBody>
+          <a:bodyPr wrap="square" lIns="0" tIns="0" rIns="0" bIns="0" rtlCol="0" anchor="ctr"/>
+          <a:lstStyle/>
+          <a:p>
+            <a:pPr algn="ctr" indent="0" marL="0">
+              <a:buNone/>
+            </a:pPr>
+            <a:r>
+              <a:rPr lang="en-US" sz="1150" b="1" dirty="0">
+                <a:solidFill>
+                  <a:srgbClr val="D97706"/>
+                </a:solidFill>
+                <a:latin typeface="Calibri" pitchFamily="34" charset="0"/>
+                <a:ea typeface="Calibri" pitchFamily="34" charset="-122"/>
+                <a:cs typeface="Calibri" pitchFamily="34" charset="-120"/>
+              </a:rPr>
+              <a:t>MQTT broker · Mosquitto</a:t>
+            </a:r>
+            <a:endParaRPr lang="en-US" sz="1150" dirty="0"/>
+          </a:p>
+        </p:txBody>
+      </p:sp>
+      <p:sp>
+        <p:nvSpPr>
+          <p:cNvPr id="16" name="Shape 14"/>
+          <p:cNvSpPr/>
+          <p:nvPr/>
+        </p:nvSpPr>
+        <p:spPr>
+          <a:xfrm>
+            <a:off x="4937760" y="2450592"/>
+            <a:ext cx="3108960" cy="548640"/>
+          </a:xfrm>
+          <a:prstGeom prst="roundRect">
+            <a:avLst>
+              <a:gd name="adj" fmla="val 10000"/>
+            </a:avLst>
+          </a:prstGeom>
+          <a:solidFill>
+            <a:srgbClr val="F3F4F6"/>
+          </a:solidFill>
+          <a:ln/>
+        </p:spPr>
+      </p:sp>
+      <p:sp>
+        <p:nvSpPr>
+          <p:cNvPr id="17" name="Text 15"/>
+          <p:cNvSpPr/>
+          <p:nvPr/>
+        </p:nvSpPr>
+        <p:spPr>
+          <a:xfrm>
+            <a:off x="5047488" y="2496312"/>
+            <a:ext cx="2889504" cy="237744"/>
+          </a:xfrm>
+          <a:prstGeom prst="rect">
+            <a:avLst/>
+          </a:prstGeom>
+          <a:noFill/>
+          <a:ln/>
+        </p:spPr>
+        <p:txBody>
+          <a:bodyPr wrap="square" lIns="0" tIns="0" rIns="0" bIns="0" rtlCol="0" anchor="ctr"/>
+          <a:lstStyle/>
+          <a:p>
+            <a:pPr indent="0" marL="0">
+              <a:buNone/>
+            </a:pPr>
+            <a:r>
+              <a:rPr lang="en-US" sz="1150" b="1" dirty="0">
+                <a:solidFill>
+                  <a:srgbClr val="111827"/>
+                </a:solidFill>
+                <a:latin typeface="Calibri" pitchFamily="34" charset="0"/>
+                <a:ea typeface="Calibri" pitchFamily="34" charset="-122"/>
+                <a:cs typeface="Calibri" pitchFamily="34" charset="-120"/>
+              </a:rPr>
+              <a:t>context</a:t>
+            </a:r>
+            <a:endParaRPr lang="en-US" sz="1150" dirty="0"/>
+          </a:p>
+        </p:txBody>
+      </p:sp>
+      <p:sp>
+        <p:nvSpPr>
+          <p:cNvPr id="18" name="Text 16"/>
+          <p:cNvSpPr/>
+          <p:nvPr/>
+        </p:nvSpPr>
+        <p:spPr>
+          <a:xfrm>
+            <a:off x="5047488" y="2734056"/>
+            <a:ext cx="2889504" cy="228600"/>
+          </a:xfrm>
+          <a:prstGeom prst="rect">
+            <a:avLst/>
+          </a:prstGeom>
+          <a:noFill/>
+          <a:ln/>
+        </p:spPr>
+        <p:txBody>
+          <a:bodyPr wrap="square" lIns="0" tIns="0" rIns="0" bIns="0" rtlCol="0" anchor="ctr"/>
+          <a:lstStyle/>
+          <a:p>
+            <a:pPr indent="0" marL="0">
+              <a:buNone/>
+            </a:pPr>
+            <a:r>
+              <a:rPr lang="en-US" sz="950" dirty="0">
                 <a:solidFill>
                   <a:srgbClr val="6B7280"/>
                 </a:solidFill>
@@ -4148,38 +3766,487 @@
                 <a:ea typeface="Calibri" pitchFamily="34" charset="-122"/>
                 <a:cs typeface="Calibri" pitchFamily="34" charset="-120"/>
               </a:rPr>
-              <a:t>of EU energy consumption happens in buildings</a:t>
-            </a:r>
-            <a:endParaRPr lang="en-US" sz="1450" dirty="0"/>
-          </a:p>
-        </p:txBody>
-      </p:sp>
-      <p:sp>
-        <p:nvSpPr>
-          <p:cNvPr id="8" name="Text 6"/>
-          <p:cNvSpPr/>
-          <p:nvPr/>
-        </p:nvSpPr>
-        <p:spPr>
-          <a:xfrm>
-            <a:off x="8321040" y="2011680"/>
-            <a:ext cx="3474720" cy="1005840"/>
-          </a:xfrm>
-          <a:prstGeom prst="rect">
-            <a:avLst/>
-          </a:prstGeom>
-          <a:noFill/>
-          <a:ln/>
-        </p:spPr>
-        <p:txBody>
-          <a:bodyPr wrap="square" lIns="0" tIns="0" rIns="0" bIns="0" rtlCol="0" anchor="ctr"/>
-          <a:lstStyle/>
-          <a:p>
-            <a:pPr indent="0" marL="0">
-              <a:buNone/>
-            </a:pPr>
-            <a:r>
-              <a:rPr lang="en-US" sz="5200" b="1" dirty="0">
+              <a:t>world state · CO₂ · session FSM</a:t>
+            </a:r>
+            <a:endParaRPr lang="en-US" sz="950" dirty="0"/>
+          </a:p>
+        </p:txBody>
+      </p:sp>
+      <p:sp>
+        <p:nvSpPr>
+          <p:cNvPr id="19" name="Text 17"/>
+          <p:cNvSpPr/>
+          <p:nvPr/>
+        </p:nvSpPr>
+        <p:spPr>
+          <a:xfrm>
+            <a:off x="6400800" y="2962656"/>
+            <a:ext cx="274320" cy="274320"/>
+          </a:xfrm>
+          <a:prstGeom prst="rect">
+            <a:avLst/>
+          </a:prstGeom>
+          <a:noFill/>
+          <a:ln/>
+        </p:spPr>
+        <p:txBody>
+          <a:bodyPr wrap="square" lIns="0" tIns="0" rIns="0" bIns="0" rtlCol="0" anchor="ctr"/>
+          <a:lstStyle/>
+          <a:p>
+            <a:pPr algn="ctr" indent="0" marL="0">
+              <a:buNone/>
+            </a:pPr>
+            <a:r>
+              <a:rPr lang="en-US" sz="1100" dirty="0">
+                <a:solidFill>
+                  <a:srgbClr val="6B7280"/>
+                </a:solidFill>
+                <a:latin typeface="Calibri" pitchFamily="34" charset="0"/>
+                <a:ea typeface="Calibri" pitchFamily="34" charset="-122"/>
+                <a:cs typeface="Calibri" pitchFamily="34" charset="-120"/>
+              </a:rPr>
+              <a:t>↓</a:t>
+            </a:r>
+            <a:endParaRPr lang="en-US" sz="1100" dirty="0"/>
+          </a:p>
+        </p:txBody>
+      </p:sp>
+      <p:sp>
+        <p:nvSpPr>
+          <p:cNvPr id="20" name="Shape 18"/>
+          <p:cNvSpPr/>
+          <p:nvPr/>
+        </p:nvSpPr>
+        <p:spPr>
+          <a:xfrm>
+            <a:off x="4937760" y="3209544"/>
+            <a:ext cx="3108960" cy="548640"/>
+          </a:xfrm>
+          <a:prstGeom prst="roundRect">
+            <a:avLst>
+              <a:gd name="adj" fmla="val 10000"/>
+            </a:avLst>
+          </a:prstGeom>
+          <a:solidFill>
+            <a:srgbClr val="F3F4F6"/>
+          </a:solidFill>
+          <a:ln/>
+        </p:spPr>
+      </p:sp>
+      <p:sp>
+        <p:nvSpPr>
+          <p:cNvPr id="21" name="Text 19"/>
+          <p:cNvSpPr/>
+          <p:nvPr/>
+        </p:nvSpPr>
+        <p:spPr>
+          <a:xfrm>
+            <a:off x="5047488" y="3255264"/>
+            <a:ext cx="2889504" cy="237744"/>
+          </a:xfrm>
+          <a:prstGeom prst="rect">
+            <a:avLst/>
+          </a:prstGeom>
+          <a:noFill/>
+          <a:ln/>
+        </p:spPr>
+        <p:txBody>
+          <a:bodyPr wrap="square" lIns="0" tIns="0" rIns="0" bIns="0" rtlCol="0" anchor="ctr"/>
+          <a:lstStyle/>
+          <a:p>
+            <a:pPr indent="0" marL="0">
+              <a:buNone/>
+            </a:pPr>
+            <a:r>
+              <a:rPr lang="en-US" sz="1150" b="1" dirty="0">
+                <a:solidFill>
+                  <a:srgbClr val="111827"/>
+                </a:solidFill>
+                <a:latin typeface="Calibri" pitchFamily="34" charset="0"/>
+                <a:ea typeface="Calibri" pitchFamily="34" charset="-122"/>
+                <a:cs typeface="Calibri" pitchFamily="34" charset="-120"/>
+              </a:rPr>
+              <a:t>problem generator</a:t>
+            </a:r>
+            <a:endParaRPr lang="en-US" sz="1150" dirty="0"/>
+          </a:p>
+        </p:txBody>
+      </p:sp>
+      <p:sp>
+        <p:nvSpPr>
+          <p:cNvPr id="22" name="Text 20"/>
+          <p:cNvSpPr/>
+          <p:nvPr/>
+        </p:nvSpPr>
+        <p:spPr>
+          <a:xfrm>
+            <a:off x="5047488" y="3493008"/>
+            <a:ext cx="2889504" cy="228600"/>
+          </a:xfrm>
+          <a:prstGeom prst="rect">
+            <a:avLst/>
+          </a:prstGeom>
+          <a:noFill/>
+          <a:ln/>
+        </p:spPr>
+        <p:txBody>
+          <a:bodyPr wrap="square" lIns="0" tIns="0" rIns="0" bIns="0" rtlCol="0" anchor="ctr"/>
+          <a:lstStyle/>
+          <a:p>
+            <a:pPr indent="0" marL="0">
+              <a:buNone/>
+            </a:pPr>
+            <a:r>
+              <a:rPr lang="en-US" sz="950" dirty="0">
+                <a:solidFill>
+                  <a:srgbClr val="6B7280"/>
+                </a:solidFill>
+                <a:latin typeface="Calibri" pitchFamily="34" charset="0"/>
+                <a:ea typeface="Calibri" pitchFamily="34" charset="-122"/>
+                <a:cs typeface="Calibri" pitchFamily="34" charset="-120"/>
+              </a:rPr>
+              <a:t>state → PDDL goals + weather costs</a:t>
+            </a:r>
+            <a:endParaRPr lang="en-US" sz="950" dirty="0"/>
+          </a:p>
+        </p:txBody>
+      </p:sp>
+      <p:sp>
+        <p:nvSpPr>
+          <p:cNvPr id="23" name="Text 21"/>
+          <p:cNvSpPr/>
+          <p:nvPr/>
+        </p:nvSpPr>
+        <p:spPr>
+          <a:xfrm>
+            <a:off x="6400800" y="3721608"/>
+            <a:ext cx="274320" cy="274320"/>
+          </a:xfrm>
+          <a:prstGeom prst="rect">
+            <a:avLst/>
+          </a:prstGeom>
+          <a:noFill/>
+          <a:ln/>
+        </p:spPr>
+        <p:txBody>
+          <a:bodyPr wrap="square" lIns="0" tIns="0" rIns="0" bIns="0" rtlCol="0" anchor="ctr"/>
+          <a:lstStyle/>
+          <a:p>
+            <a:pPr algn="ctr" indent="0" marL="0">
+              <a:buNone/>
+            </a:pPr>
+            <a:r>
+              <a:rPr lang="en-US" sz="1100" dirty="0">
+                <a:solidFill>
+                  <a:srgbClr val="6B7280"/>
+                </a:solidFill>
+                <a:latin typeface="Calibri" pitchFamily="34" charset="0"/>
+                <a:ea typeface="Calibri" pitchFamily="34" charset="-122"/>
+                <a:cs typeface="Calibri" pitchFamily="34" charset="-120"/>
+              </a:rPr>
+              <a:t>↓</a:t>
+            </a:r>
+            <a:endParaRPr lang="en-US" sz="1100" dirty="0"/>
+          </a:p>
+        </p:txBody>
+      </p:sp>
+      <p:sp>
+        <p:nvSpPr>
+          <p:cNvPr id="24" name="Shape 22"/>
+          <p:cNvSpPr/>
+          <p:nvPr/>
+        </p:nvSpPr>
+        <p:spPr>
+          <a:xfrm>
+            <a:off x="4937760" y="3968496"/>
+            <a:ext cx="3108960" cy="548640"/>
+          </a:xfrm>
+          <a:prstGeom prst="roundRect">
+            <a:avLst>
+              <a:gd name="adj" fmla="val 10000"/>
+            </a:avLst>
+          </a:prstGeom>
+          <a:solidFill>
+            <a:srgbClr val="FBEFD9"/>
+          </a:solidFill>
+          <a:ln w="12700">
+            <a:solidFill>
+              <a:srgbClr val="D97706"/>
+            </a:solidFill>
+            <a:prstDash val="solid"/>
+          </a:ln>
+        </p:spPr>
+      </p:sp>
+      <p:sp>
+        <p:nvSpPr>
+          <p:cNvPr id="25" name="Text 23"/>
+          <p:cNvSpPr/>
+          <p:nvPr/>
+        </p:nvSpPr>
+        <p:spPr>
+          <a:xfrm>
+            <a:off x="5047488" y="4014216"/>
+            <a:ext cx="2889504" cy="237744"/>
+          </a:xfrm>
+          <a:prstGeom prst="rect">
+            <a:avLst/>
+          </a:prstGeom>
+          <a:noFill/>
+          <a:ln/>
+        </p:spPr>
+        <p:txBody>
+          <a:bodyPr wrap="square" lIns="0" tIns="0" rIns="0" bIns="0" rtlCol="0" anchor="ctr"/>
+          <a:lstStyle/>
+          <a:p>
+            <a:pPr indent="0" marL="0">
+              <a:buNone/>
+            </a:pPr>
+            <a:r>
+              <a:rPr lang="en-US" sz="1150" b="1" dirty="0">
+                <a:solidFill>
+                  <a:srgbClr val="D97706"/>
+                </a:solidFill>
+                <a:latin typeface="Calibri" pitchFamily="34" charset="0"/>
+                <a:ea typeface="Calibri" pitchFamily="34" charset="-122"/>
+                <a:cs typeface="Calibri" pitchFamily="34" charset="-120"/>
+              </a:rPr>
+              <a:t>planner · Fast Downward</a:t>
+            </a:r>
+            <a:endParaRPr lang="en-US" sz="1150" dirty="0"/>
+          </a:p>
+        </p:txBody>
+      </p:sp>
+      <p:sp>
+        <p:nvSpPr>
+          <p:cNvPr id="26" name="Text 24"/>
+          <p:cNvSpPr/>
+          <p:nvPr/>
+        </p:nvSpPr>
+        <p:spPr>
+          <a:xfrm>
+            <a:off x="5047488" y="4251960"/>
+            <a:ext cx="2889504" cy="228600"/>
+          </a:xfrm>
+          <a:prstGeom prst="rect">
+            <a:avLst/>
+          </a:prstGeom>
+          <a:noFill/>
+          <a:ln/>
+        </p:spPr>
+        <p:txBody>
+          <a:bodyPr wrap="square" lIns="0" tIns="0" rIns="0" bIns="0" rtlCol="0" anchor="ctr"/>
+          <a:lstStyle/>
+          <a:p>
+            <a:pPr indent="0" marL="0">
+              <a:buNone/>
+            </a:pPr>
+            <a:r>
+              <a:rPr lang="en-US" sz="950" dirty="0">
+                <a:solidFill>
+                  <a:srgbClr val="6B7280"/>
+                </a:solidFill>
+                <a:latin typeface="Calibri" pitchFamily="34" charset="0"/>
+                <a:ea typeface="Calibri" pitchFamily="34" charset="-122"/>
+                <a:cs typeface="Calibri" pitchFamily="34" charset="-120"/>
+              </a:rPr>
+              <a:t>cost-optimal plan, ~130 ms</a:t>
+            </a:r>
+            <a:endParaRPr lang="en-US" sz="950" dirty="0"/>
+          </a:p>
+        </p:txBody>
+      </p:sp>
+      <p:sp>
+        <p:nvSpPr>
+          <p:cNvPr id="27" name="Text 25"/>
+          <p:cNvSpPr/>
+          <p:nvPr/>
+        </p:nvSpPr>
+        <p:spPr>
+          <a:xfrm>
+            <a:off x="6400800" y="4480560"/>
+            <a:ext cx="274320" cy="274320"/>
+          </a:xfrm>
+          <a:prstGeom prst="rect">
+            <a:avLst/>
+          </a:prstGeom>
+          <a:noFill/>
+          <a:ln/>
+        </p:spPr>
+        <p:txBody>
+          <a:bodyPr wrap="square" lIns="0" tIns="0" rIns="0" bIns="0" rtlCol="0" anchor="ctr"/>
+          <a:lstStyle/>
+          <a:p>
+            <a:pPr algn="ctr" indent="0" marL="0">
+              <a:buNone/>
+            </a:pPr>
+            <a:r>
+              <a:rPr lang="en-US" sz="1100" dirty="0">
+                <a:solidFill>
+                  <a:srgbClr val="6B7280"/>
+                </a:solidFill>
+                <a:latin typeface="Calibri" pitchFamily="34" charset="0"/>
+                <a:ea typeface="Calibri" pitchFamily="34" charset="-122"/>
+                <a:cs typeface="Calibri" pitchFamily="34" charset="-120"/>
+              </a:rPr>
+              <a:t>↓</a:t>
+            </a:r>
+            <a:endParaRPr lang="en-US" sz="1100" dirty="0"/>
+          </a:p>
+        </p:txBody>
+      </p:sp>
+      <p:sp>
+        <p:nvSpPr>
+          <p:cNvPr id="28" name="Shape 26"/>
+          <p:cNvSpPr/>
+          <p:nvPr/>
+        </p:nvSpPr>
+        <p:spPr>
+          <a:xfrm>
+            <a:off x="4937760" y="4727448"/>
+            <a:ext cx="3108960" cy="548640"/>
+          </a:xfrm>
+          <a:prstGeom prst="roundRect">
+            <a:avLst>
+              <a:gd name="adj" fmla="val 10000"/>
+            </a:avLst>
+          </a:prstGeom>
+          <a:solidFill>
+            <a:srgbClr val="F3F4F6"/>
+          </a:solidFill>
+          <a:ln/>
+        </p:spPr>
+      </p:sp>
+      <p:sp>
+        <p:nvSpPr>
+          <p:cNvPr id="29" name="Text 27"/>
+          <p:cNvSpPr/>
+          <p:nvPr/>
+        </p:nvSpPr>
+        <p:spPr>
+          <a:xfrm>
+            <a:off x="5047488" y="4773168"/>
+            <a:ext cx="2889504" cy="237744"/>
+          </a:xfrm>
+          <a:prstGeom prst="rect">
+            <a:avLst/>
+          </a:prstGeom>
+          <a:noFill/>
+          <a:ln/>
+        </p:spPr>
+        <p:txBody>
+          <a:bodyPr wrap="square" lIns="0" tIns="0" rIns="0" bIns="0" rtlCol="0" anchor="ctr"/>
+          <a:lstStyle/>
+          <a:p>
+            <a:pPr indent="0" marL="0">
+              <a:buNone/>
+            </a:pPr>
+            <a:r>
+              <a:rPr lang="en-US" sz="1150" b="1" dirty="0">
+                <a:solidFill>
+                  <a:srgbClr val="111827"/>
+                </a:solidFill>
+                <a:latin typeface="Calibri" pitchFamily="34" charset="0"/>
+                <a:ea typeface="Calibri" pitchFamily="34" charset="-122"/>
+                <a:cs typeface="Calibri" pitchFamily="34" charset="-120"/>
+              </a:rPr>
+              <a:t>executor</a:t>
+            </a:r>
+            <a:endParaRPr lang="en-US" sz="1150" dirty="0"/>
+          </a:p>
+        </p:txBody>
+      </p:sp>
+      <p:sp>
+        <p:nvSpPr>
+          <p:cNvPr id="30" name="Text 28"/>
+          <p:cNvSpPr/>
+          <p:nvPr/>
+        </p:nvSpPr>
+        <p:spPr>
+          <a:xfrm>
+            <a:off x="5047488" y="5010912"/>
+            <a:ext cx="2889504" cy="228600"/>
+          </a:xfrm>
+          <a:prstGeom prst="rect">
+            <a:avLst/>
+          </a:prstGeom>
+          <a:noFill/>
+          <a:ln/>
+        </p:spPr>
+        <p:txBody>
+          <a:bodyPr wrap="square" lIns="0" tIns="0" rIns="0" bIns="0" rtlCol="0" anchor="ctr"/>
+          <a:lstStyle/>
+          <a:p>
+            <a:pPr indent="0" marL="0">
+              <a:buNone/>
+            </a:pPr>
+            <a:r>
+              <a:rPr lang="en-US" sz="950" dirty="0">
+                <a:solidFill>
+                  <a:srgbClr val="6B7280"/>
+                </a:solidFill>
+                <a:latin typeface="Calibri" pitchFamily="34" charset="0"/>
+                <a:ea typeface="Calibri" pitchFamily="34" charset="-122"/>
+                <a:cs typeface="Calibri" pitchFamily="34" charset="-120"/>
+              </a:rPr>
+              <a:t>dispatches planned actions</a:t>
+            </a:r>
+            <a:endParaRPr lang="en-US" sz="950" dirty="0"/>
+          </a:p>
+        </p:txBody>
+      </p:sp>
+      <p:sp>
+        <p:nvSpPr>
+          <p:cNvPr id="31" name="Shape 29"/>
+          <p:cNvSpPr/>
+          <p:nvPr/>
+        </p:nvSpPr>
+        <p:spPr>
+          <a:xfrm>
+            <a:off x="9006840" y="1325880"/>
+            <a:ext cx="2560320" cy="4343400"/>
+          </a:xfrm>
+          <a:prstGeom prst="roundRect">
+            <a:avLst>
+              <a:gd name="adj" fmla="val 3571"/>
+            </a:avLst>
+          </a:prstGeom>
+          <a:solidFill>
+            <a:srgbClr val="FFFFFF"/>
+          </a:solidFill>
+          <a:ln w="15875">
+            <a:solidFill>
+              <a:srgbClr val="E5E7EB"/>
+            </a:solidFill>
+            <a:prstDash val="solid"/>
+          </a:ln>
+        </p:spPr>
+      </p:sp>
+      <p:sp>
+        <p:nvSpPr>
+          <p:cNvPr id="32" name="Text 30"/>
+          <p:cNvSpPr/>
+          <p:nvPr/>
+        </p:nvSpPr>
+        <p:spPr>
+          <a:xfrm>
+            <a:off x="9189720" y="1481328"/>
+            <a:ext cx="2194560" cy="320040"/>
+          </a:xfrm>
+          <a:prstGeom prst="rect">
+            <a:avLst/>
+          </a:prstGeom>
+          <a:noFill/>
+          <a:ln/>
+        </p:spPr>
+        <p:txBody>
+          <a:bodyPr wrap="square" lIns="0" tIns="0" rIns="0" bIns="0" rtlCol="0" anchor="ctr"/>
+          <a:lstStyle/>
+          <a:p>
+            <a:pPr indent="0" marL="0">
+              <a:buNone/>
+            </a:pPr>
+            <a:r>
+              <a:rPr lang="en-US" sz="1500" b="1" dirty="0">
                 <a:solidFill>
                   <a:srgbClr val="111827"/>
                 </a:solidFill>
@@ -4187,38 +4254,179 @@
                 <a:ea typeface="Cambria" pitchFamily="34" charset="-122"/>
                 <a:cs typeface="Cambria" pitchFamily="34" charset="-120"/>
               </a:rPr>
-              <a:t>24/7</a:t>
-            </a:r>
-            <a:endParaRPr lang="en-US" sz="5200" dirty="0"/>
-          </a:p>
-        </p:txBody>
-      </p:sp>
-      <p:sp>
-        <p:nvSpPr>
-          <p:cNvPr id="9" name="Text 7"/>
-          <p:cNvSpPr/>
-          <p:nvPr/>
-        </p:nvSpPr>
-        <p:spPr>
-          <a:xfrm>
-            <a:off x="8321040" y="3154680"/>
-            <a:ext cx="3246120" cy="1005840"/>
-          </a:xfrm>
-          <a:prstGeom prst="rect">
-            <a:avLst/>
-          </a:prstGeom>
-          <a:noFill/>
-          <a:ln/>
-        </p:spPr>
-        <p:txBody>
-          <a:bodyPr wrap="square" lIns="0" tIns="0" rIns="0" bIns="0" rtlCol="0" anchor="ctr"/>
-          <a:lstStyle/>
-          <a:p>
-            <a:pPr indent="0" marL="0">
-              <a:buNone/>
-            </a:pPr>
-            <a:r>
-              <a:rPr lang="en-US" sz="1450" dirty="0">
+              <a:t>Laptop · browser</a:t>
+            </a:r>
+            <a:endParaRPr lang="en-US" sz="1500" dirty="0"/>
+          </a:p>
+        </p:txBody>
+      </p:sp>
+      <p:sp>
+        <p:nvSpPr>
+          <p:cNvPr id="33" name="Text 31"/>
+          <p:cNvSpPr/>
+          <p:nvPr/>
+        </p:nvSpPr>
+        <p:spPr>
+          <a:xfrm>
+            <a:off x="9189720" y="1938528"/>
+            <a:ext cx="2194560" cy="228600"/>
+          </a:xfrm>
+          <a:prstGeom prst="rect">
+            <a:avLst/>
+          </a:prstGeom>
+          <a:noFill/>
+          <a:ln/>
+        </p:spPr>
+        <p:txBody>
+          <a:bodyPr wrap="square" lIns="0" tIns="0" rIns="0" bIns="0" rtlCol="0" anchor="ctr"/>
+          <a:lstStyle/>
+          <a:p>
+            <a:pPr indent="0" marL="0">
+              <a:buNone/>
+            </a:pPr>
+            <a:r>
+              <a:rPr lang="en-US" sz="950" b="1" spc="200" kern="0" dirty="0">
+                <a:solidFill>
+                  <a:srgbClr val="1D4ED8"/>
+                </a:solidFill>
+                <a:latin typeface="Calibri" pitchFamily="34" charset="0"/>
+                <a:ea typeface="Calibri" pitchFamily="34" charset="-122"/>
+                <a:cs typeface="Calibri" pitchFamily="34" charset="-120"/>
+              </a:rPr>
+              <a:t>LIVE DASHBOARD</a:t>
+            </a:r>
+            <a:endParaRPr lang="en-US" sz="950" dirty="0"/>
+          </a:p>
+        </p:txBody>
+      </p:sp>
+      <p:sp>
+        <p:nvSpPr>
+          <p:cNvPr id="34" name="Text 32"/>
+          <p:cNvSpPr/>
+          <p:nvPr/>
+        </p:nvSpPr>
+        <p:spPr>
+          <a:xfrm>
+            <a:off x="9189720" y="2194560"/>
+            <a:ext cx="2240280" cy="1371600"/>
+          </a:xfrm>
+          <a:prstGeom prst="rect">
+            <a:avLst/>
+          </a:prstGeom>
+          <a:noFill/>
+          <a:ln/>
+        </p:spPr>
+        <p:txBody>
+          <a:bodyPr wrap="square" lIns="0" tIns="0" rIns="0" bIns="0" rtlCol="0" anchor="ctr"/>
+          <a:lstStyle/>
+          <a:p>
+            <a:pPr indent="0" marL="0">
+              <a:lnSpc>
+                <a:spcPct val="130000"/>
+              </a:lnSpc>
+              <a:buNone/>
+            </a:pPr>
+            <a:r>
+              <a:rPr lang="en-US" sz="1200" dirty="0">
+                <a:solidFill>
+                  <a:srgbClr val="111827"/>
+                </a:solidFill>
+                <a:latin typeface="Calibri" pitchFamily="34" charset="0"/>
+                <a:ea typeface="Calibri" pitchFamily="34" charset="-122"/>
+                <a:cs typeface="Calibri" pitchFamily="34" charset="-120"/>
+              </a:rPr>
+              <a:t>seat floor plan + windows</a:t>
+            </a:r>
+            <a:endParaRPr lang="en-US" sz="1200" dirty="0"/>
+          </a:p>
+          <a:p>
+            <a:pPr indent="0" marL="0">
+              <a:lnSpc>
+                <a:spcPct val="130000"/>
+              </a:lnSpc>
+              <a:buNone/>
+            </a:pPr>
+            <a:r>
+              <a:rPr lang="en-US" sz="1200" dirty="0">
+                <a:solidFill>
+                  <a:srgbClr val="111827"/>
+                </a:solidFill>
+                <a:latin typeface="Calibri" pitchFamily="34" charset="0"/>
+                <a:ea typeface="Calibri" pitchFamily="34" charset="-122"/>
+                <a:cs typeface="Calibri" pitchFamily="34" charset="-120"/>
+              </a:rPr>
+              <a:t>current plan with cost</a:t>
+            </a:r>
+            <a:endParaRPr lang="en-US" sz="1200" dirty="0"/>
+          </a:p>
+          <a:p>
+            <a:pPr indent="0" marL="0">
+              <a:lnSpc>
+                <a:spcPct val="130000"/>
+              </a:lnSpc>
+              <a:buNone/>
+            </a:pPr>
+            <a:r>
+              <a:rPr lang="en-US" sz="1200" dirty="0">
+                <a:solidFill>
+                  <a:srgbClr val="111827"/>
+                </a:solidFill>
+                <a:latin typeface="Calibri" pitchFamily="34" charset="0"/>
+                <a:ea typeface="Calibri" pitchFamily="34" charset="-122"/>
+                <a:cs typeface="Calibri" pitchFamily="34" charset="-120"/>
+              </a:rPr>
+              <a:t>trend charts</a:t>
+            </a:r>
+            <a:endParaRPr lang="en-US" sz="1200" dirty="0"/>
+          </a:p>
+          <a:p>
+            <a:pPr indent="0" marL="0">
+              <a:lnSpc>
+                <a:spcPct val="130000"/>
+              </a:lnSpc>
+              <a:buNone/>
+            </a:pPr>
+            <a:r>
+              <a:rPr lang="en-US" sz="1200" dirty="0">
+                <a:solidFill>
+                  <a:srgbClr val="111827"/>
+                </a:solidFill>
+                <a:latin typeface="Calibri" pitchFamily="34" charset="0"/>
+                <a:ea typeface="Calibri" pitchFamily="34" charset="-122"/>
+                <a:cs typeface="Calibri" pitchFamily="34" charset="-120"/>
+              </a:rPr>
+              <a:t>Pomodoro session rings</a:t>
+            </a:r>
+            <a:endParaRPr lang="en-US" sz="1200" dirty="0"/>
+          </a:p>
+        </p:txBody>
+      </p:sp>
+      <p:sp>
+        <p:nvSpPr>
+          <p:cNvPr id="35" name="Text 33"/>
+          <p:cNvSpPr/>
+          <p:nvPr/>
+        </p:nvSpPr>
+        <p:spPr>
+          <a:xfrm>
+            <a:off x="9189720" y="4160520"/>
+            <a:ext cx="2240280" cy="914400"/>
+          </a:xfrm>
+          <a:prstGeom prst="rect">
+            <a:avLst/>
+          </a:prstGeom>
+          <a:noFill/>
+          <a:ln/>
+        </p:spPr>
+        <p:txBody>
+          <a:bodyPr wrap="square" lIns="0" tIns="0" rIns="0" bIns="0" rtlCol="0" anchor="ctr"/>
+          <a:lstStyle/>
+          <a:p>
+            <a:pPr indent="0" marL="0">
+              <a:buNone/>
+            </a:pPr>
+            <a:r>
+              <a:rPr lang="en-US" sz="1050" dirty="0">
                 <a:solidFill>
                   <a:srgbClr val="6B7280"/>
                 </a:solidFill>
@@ -4226,38 +4434,58 @@
                 <a:ea typeface="Calibri" pitchFamily="34" charset="-122"/>
                 <a:cs typeface="Calibri" pitchFamily="34" charset="-120"/>
               </a:rPr>
-              <a:t>lighting and ventilation usually run on fixed schedules, not on demand</a:t>
-            </a:r>
-            <a:endParaRPr lang="en-US" sz="1450" dirty="0"/>
-          </a:p>
-        </p:txBody>
-      </p:sp>
-      <p:sp>
-        <p:nvSpPr>
-          <p:cNvPr id="10" name="Text 8"/>
-          <p:cNvSpPr/>
-          <p:nvPr/>
-        </p:nvSpPr>
-        <p:spPr>
-          <a:xfrm>
-            <a:off x="640080" y="5212080"/>
-            <a:ext cx="10881360" cy="822960"/>
-          </a:xfrm>
-          <a:prstGeom prst="rect">
-            <a:avLst/>
-          </a:prstGeom>
-          <a:noFill/>
-          <a:ln/>
-        </p:spPr>
-        <p:txBody>
-          <a:bodyPr wrap="square" lIns="0" tIns="0" rIns="0" bIns="0" rtlCol="0" anchor="ctr"/>
-          <a:lstStyle/>
-          <a:p>
-            <a:pPr indent="0" marL="0">
-              <a:buNone/>
-            </a:pPr>
-            <a:r>
-              <a:rPr lang="en-US" sz="1700" dirty="0">
+              <a:t>in demo mode the laptop joins the WiFi access point spanned by the Pi 5</a:t>
+            </a:r>
+            <a:endParaRPr lang="en-US" sz="1050" dirty="0"/>
+          </a:p>
+        </p:txBody>
+      </p:sp>
+      <p:sp>
+        <p:nvSpPr>
+          <p:cNvPr id="36" name="Shape 34"/>
+          <p:cNvSpPr/>
+          <p:nvPr/>
+        </p:nvSpPr>
+        <p:spPr>
+          <a:xfrm>
+            <a:off x="4059936" y="2148840"/>
+            <a:ext cx="621792" cy="292608"/>
+          </a:xfrm>
+          <a:prstGeom prst="rightArrow">
+            <a:avLst/>
+          </a:prstGeom>
+          <a:solidFill>
+            <a:srgbClr val="15803D"/>
+          </a:solidFill>
+          <a:ln/>
+        </p:spPr>
+      </p:sp>
+      <p:sp>
+        <p:nvSpPr>
+          <p:cNvPr id="37" name="Text 35"/>
+          <p:cNvSpPr/>
+          <p:nvPr/>
+        </p:nvSpPr>
+        <p:spPr>
+          <a:xfrm>
+            <a:off x="3913632" y="1847088"/>
+            <a:ext cx="914400" cy="256032"/>
+          </a:xfrm>
+          <a:prstGeom prst="rect">
+            <a:avLst/>
+          </a:prstGeom>
+          <a:noFill/>
+          <a:ln/>
+        </p:spPr>
+        <p:txBody>
+          <a:bodyPr wrap="square" lIns="0" tIns="0" rIns="0" bIns="0" rtlCol="0" anchor="ctr"/>
+          <a:lstStyle/>
+          <a:p>
+            <a:pPr algn="ctr" indent="0" marL="0">
+              <a:buNone/>
+            </a:pPr>
+            <a:r>
+              <a:rPr lang="en-US" sz="950" dirty="0">
                 <a:solidFill>
                   <a:srgbClr val="6B7280"/>
                 </a:solidFill>
@@ -4265,9 +4493,189 @@
                 <a:ea typeface="Calibri" pitchFamily="34" charset="-122"/>
                 <a:cs typeface="Calibri" pitchFamily="34" charset="-120"/>
               </a:rPr>
-              <a:t>Our project: a reading zone that controls light, air quality and break timing automatically, with transparent decisions.</a:t>
-            </a:r>
-            <a:endParaRPr lang="en-US" sz="1700" dirty="0"/>
+              <a:t>sensor data</a:t>
+            </a:r>
+            <a:endParaRPr lang="en-US" sz="950" dirty="0"/>
+          </a:p>
+        </p:txBody>
+      </p:sp>
+      <p:sp>
+        <p:nvSpPr>
+          <p:cNvPr id="38" name="Shape 36"/>
+          <p:cNvSpPr/>
+          <p:nvPr/>
+        </p:nvSpPr>
+        <p:spPr>
+          <a:xfrm>
+            <a:off x="4059936" y="4297680"/>
+            <a:ext cx="621792" cy="292608"/>
+          </a:xfrm>
+          <a:prstGeom prst="leftArrow">
+            <a:avLst/>
+          </a:prstGeom>
+          <a:solidFill>
+            <a:srgbClr val="D97706"/>
+          </a:solidFill>
+          <a:ln/>
+        </p:spPr>
+      </p:sp>
+      <p:sp>
+        <p:nvSpPr>
+          <p:cNvPr id="39" name="Text 37"/>
+          <p:cNvSpPr/>
+          <p:nvPr/>
+        </p:nvSpPr>
+        <p:spPr>
+          <a:xfrm>
+            <a:off x="3913632" y="4626864"/>
+            <a:ext cx="914400" cy="256032"/>
+          </a:xfrm>
+          <a:prstGeom prst="rect">
+            <a:avLst/>
+          </a:prstGeom>
+          <a:noFill/>
+          <a:ln/>
+        </p:spPr>
+        <p:txBody>
+          <a:bodyPr wrap="square" lIns="0" tIns="0" rIns="0" bIns="0" rtlCol="0" anchor="ctr"/>
+          <a:lstStyle/>
+          <a:p>
+            <a:pPr algn="ctr" indent="0" marL="0">
+              <a:buNone/>
+            </a:pPr>
+            <a:r>
+              <a:rPr lang="en-US" sz="950" dirty="0">
+                <a:solidFill>
+                  <a:srgbClr val="6B7280"/>
+                </a:solidFill>
+                <a:latin typeface="Calibri" pitchFamily="34" charset="0"/>
+                <a:ea typeface="Calibri" pitchFamily="34" charset="-122"/>
+                <a:cs typeface="Calibri" pitchFamily="34" charset="-120"/>
+              </a:rPr>
+              <a:t>actions</a:t>
+            </a:r>
+            <a:endParaRPr lang="en-US" sz="950" dirty="0"/>
+          </a:p>
+        </p:txBody>
+      </p:sp>
+      <p:sp>
+        <p:nvSpPr>
+          <p:cNvPr id="40" name="Shape 38"/>
+          <p:cNvSpPr/>
+          <p:nvPr/>
+        </p:nvSpPr>
+        <p:spPr>
+          <a:xfrm>
+            <a:off x="8311896" y="2148840"/>
+            <a:ext cx="621792" cy="292608"/>
+          </a:xfrm>
+          <a:prstGeom prst="rightArrow">
+            <a:avLst/>
+          </a:prstGeom>
+          <a:solidFill>
+            <a:srgbClr val="1D4ED8"/>
+          </a:solidFill>
+          <a:ln/>
+        </p:spPr>
+      </p:sp>
+      <p:sp>
+        <p:nvSpPr>
+          <p:cNvPr id="41" name="Text 39"/>
+          <p:cNvSpPr/>
+          <p:nvPr/>
+        </p:nvSpPr>
+        <p:spPr>
+          <a:xfrm>
+            <a:off x="8156448" y="1847088"/>
+            <a:ext cx="960120" cy="256032"/>
+          </a:xfrm>
+          <a:prstGeom prst="rect">
+            <a:avLst/>
+          </a:prstGeom>
+          <a:noFill/>
+          <a:ln/>
+        </p:spPr>
+        <p:txBody>
+          <a:bodyPr wrap="square" lIns="0" tIns="0" rIns="0" bIns="0" rtlCol="0" anchor="ctr"/>
+          <a:lstStyle/>
+          <a:p>
+            <a:pPr algn="ctr" indent="0" marL="0">
+              <a:buNone/>
+            </a:pPr>
+            <a:r>
+              <a:rPr lang="en-US" sz="950" dirty="0">
+                <a:solidFill>
+                  <a:srgbClr val="6B7280"/>
+                </a:solidFill>
+                <a:latin typeface="Calibri" pitchFamily="34" charset="0"/>
+                <a:ea typeface="Calibri" pitchFamily="34" charset="-122"/>
+                <a:cs typeface="Calibri" pitchFamily="34" charset="-120"/>
+              </a:rPr>
+              <a:t>state + plan</a:t>
+            </a:r>
+            <a:endParaRPr lang="en-US" sz="950" dirty="0"/>
+          </a:p>
+        </p:txBody>
+      </p:sp>
+      <p:sp>
+        <p:nvSpPr>
+          <p:cNvPr id="42" name="Shape 40"/>
+          <p:cNvSpPr/>
+          <p:nvPr/>
+        </p:nvSpPr>
+        <p:spPr>
+          <a:xfrm>
+            <a:off x="640080" y="5989320"/>
+            <a:ext cx="10927080" cy="0"/>
+          </a:xfrm>
+          <a:prstGeom prst="line">
+            <a:avLst/>
+          </a:prstGeom>
+          <a:noFill/>
+          <a:ln w="9525">
+            <a:solidFill>
+              <a:srgbClr val="E5E7EB"/>
+            </a:solidFill>
+            <a:prstDash val="solid"/>
+          </a:ln>
+        </p:spPr>
+      </p:sp>
+      <p:sp>
+        <p:nvSpPr>
+          <p:cNvPr id="43" name="Text 41"/>
+          <p:cNvSpPr/>
+          <p:nvPr/>
+        </p:nvSpPr>
+        <p:spPr>
+          <a:xfrm>
+            <a:off x="640080" y="6126480"/>
+            <a:ext cx="10927080" cy="457200"/>
+          </a:xfrm>
+          <a:prstGeom prst="rect">
+            <a:avLst/>
+          </a:prstGeom>
+          <a:noFill/>
+          <a:ln/>
+        </p:spPr>
+        <p:txBody>
+          <a:bodyPr wrap="square" lIns="0" tIns="0" rIns="0" bIns="0" rtlCol="0" anchor="ctr"/>
+          <a:lstStyle/>
+          <a:p>
+            <a:pPr algn="ctr" indent="0" marL="0">
+              <a:buNone/>
+            </a:pPr>
+            <a:r>
+              <a:rPr lang="en-US" sz="1250" dirty="0">
+                <a:solidFill>
+                  <a:srgbClr val="6B7280"/>
+                </a:solidFill>
+                <a:latin typeface="Calibri" pitchFamily="34" charset="0"/>
+                <a:ea typeface="Calibri" pitchFamily="34" charset="-122"/>
+                <a:cs typeface="Calibri" pitchFamily="34" charset="-120"/>
+              </a:rPr>
+              <a:t>In effect: the lamp follows occupancy and darkness · the airing strategy follows weather costs · breaks are nudged after 2 min · disturbances are corrected in under 1 s</a:t>
+            </a:r>
+            <a:endParaRPr lang="en-US" sz="1250" dirty="0"/>
           </a:p>
         </p:txBody>
       </p:sp>

</xml_diff>

<commit_message>
Presentation: Before/With opener, honest demo run-sheet
</commit_message>
<xml_diff>
--- a/docs/presentation/LibriSense_Demo.pptx
+++ b/docs/presentation/LibriSense_Demo.pptx
@@ -601,7 +601,7 @@
           <a:p>
             <a:r>
               <a:rPr lang="en-US" dirty="0"/>
-              <a:t>Role split: person A at the desk triggers each moment, person B narrates the dashboard, person C explains the plan card whenever it changes. Keep this slide up during the live part as the run-sheet. On 'disturbance': steps 2 and 3 are deliberately different. Covering the sensor (step 2) is a normal input change — the room simply reacts by lighting the lamp. Step 3 is the real disturbance: someone switches the lamp off by hand while the seat is still occupied and dark, so the world stops matching the plan's goal; the closed loop notices the mismatch and re-plans to switch it back on within a second. That robustness to outside interference is the point, not just reacting to darkness.</a:t>
+              <a:t>Role split: person A at the desk triggers each moment, person B narrates the dashboard, person C explains the plan card whenever it changes. Keep this slide up during the live part as the run-sheet. On the closed loop: the honest, demonstrable self-correction is the light one. Covering the sensor is an environmental disturbance; the illuminance drops below the dark threshold and the planner re-lights the seat inside one 2 Hz cycle, under a second. We deliberately do NOT claim to detect a lamp switched off by hand: the lamp state in the model is the last command we sent, not a relay readback, so a manual toggle would not be seen. Keep the story to what the sensors actually close the loop on.</a:t>
             </a:r>
             <a:endParaRPr lang="en-US" dirty="0"/>
           </a:p>
@@ -865,7 +865,7 @@
           <a:p>
             <a:r>
               <a:rPr lang="en-US" dirty="0"/>
-              <a:t>Narrative opener (idea by Niclas). Tell it slowly, first person. The card numbers are an illustrative scenario; the Harvard COGfx study (2015) documented cognitive decline above roughly 1,000 ppm CO2. Close with the question, then answer it on the next slide: this is exactly what LibriSense does.</a:t>
+              <a:t>Opening contrast (concept by Niclas), rebuilt in our design. Left is the status quo: a student concentrating while CO2 silently climbs past 1,500 ppm, well above the ~1,000 ppm mark where the Harvard COGfx study (2015) measured a drop in cognitive performance. Right is the same morning with LibriSense: the room senses the rise and the planner acts, holding the air in the comfortable band. Deliver it as a single before/after beat, then move into the setup slide.</a:t>
             </a:r>
             <a:endParaRPr lang="en-US" dirty="0"/>
           </a:p>
@@ -2216,7 +2216,7 @@
                 <a:ea typeface="Calibri" pitchFamily="34" charset="-122"/>
                 <a:cs typeface="Calibri" pitchFamily="34" charset="-120"/>
               </a:rPr>
-              <a:t>occupancy detected, focus session starts</a:t>
+              <a:t>occupancy detected, the focus session starts</a:t>
             </a:r>
             <a:endParaRPr lang="en-US" sz="1250" dirty="0"/>
           </a:p>
@@ -2356,7 +2356,7 @@
                 <a:ea typeface="Calibri" pitchFamily="34" charset="-122"/>
                 <a:cs typeface="Calibri" pitchFamily="34" charset="-120"/>
               </a:rPr>
-              <a:t>normal reaction: the zone turns dark, the planner switches the lamp on</a:t>
+              <a:t>the illuminance drops, the planner re-lights the seat within one cycle, under 1 s</a:t>
             </a:r>
             <a:endParaRPr lang="en-US" sz="1250" dirty="0"/>
           </a:p>
@@ -2457,7 +2457,7 @@
                 <a:ea typeface="Cambria" pitchFamily="34" charset="-122"/>
                 <a:cs typeface="Cambria" pitchFamily="34" charset="-120"/>
               </a:rPr>
-              <a:t>Switch the lamp off by hand</a:t>
+              <a:t>Keep focusing</a:t>
             </a:r>
             <a:endParaRPr lang="en-US" sz="1600" dirty="0"/>
           </a:p>
@@ -2496,7 +2496,7 @@
                 <a:ea typeface="Calibri" pitchFamily="34" charset="-122"/>
                 <a:cs typeface="Calibri" pitchFamily="34" charset="-120"/>
               </a:rPr>
-              <a:t>an external disturbance: 'lit' no longer holds, so the planner re-lights it in under 1 s</a:t>
+              <a:t>after 2 min: LED and gentle buzzer suggest a break</a:t>
             </a:r>
             <a:endParaRPr lang="en-US" sz="1250" dirty="0"/>
           </a:p>
@@ -2597,7 +2597,7 @@
                 <a:ea typeface="Cambria" pitchFamily="34" charset="-122"/>
                 <a:cs typeface="Cambria" pitchFamily="34" charset="-120"/>
               </a:rPr>
-              <a:t>Keep focusing</a:t>
+              <a:t>CO₂ rises</a:t>
             </a:r>
             <a:endParaRPr lang="en-US" sz="1600" dirty="0"/>
           </a:p>
@@ -2636,7 +2636,7 @@
                 <a:ea typeface="Calibri" pitchFamily="34" charset="-122"/>
                 <a:cs typeface="Calibri" pitchFamily="34" charset="-120"/>
               </a:rPr>
-              <a:t>after 2 min: LED and gentle buzzer suggest a break</a:t>
+              <a:t>the planner opens the windows on the floor plan, CO₂ falls again</a:t>
             </a:r>
             <a:endParaRPr lang="en-US" sz="1250" dirty="0"/>
           </a:p>
@@ -2737,7 +2737,7 @@
                 <a:ea typeface="Cambria" pitchFamily="34" charset="-122"/>
                 <a:cs typeface="Cambria" pitchFamily="34" charset="-120"/>
               </a:rPr>
-              <a:t>CO₂ rises</a:t>
+              <a:t>Walk away</a:t>
             </a:r>
             <a:endParaRPr lang="en-US" sz="1600" dirty="0"/>
           </a:p>
@@ -2776,7 +2776,7 @@
                 <a:ea typeface="Calibri" pitchFamily="34" charset="-122"/>
                 <a:cs typeface="Calibri" pitchFamily="34" charset="-120"/>
               </a:rPr>
-              <a:t>the planner opens the windows on the floor plan, CO₂ falls again</a:t>
+              <a:t>the zone empties, the lamp switches off to save energy</a:t>
             </a:r>
             <a:endParaRPr lang="en-US" sz="1250" dirty="0"/>
           </a:p>
@@ -2808,146 +2808,6 @@
       <p:sp>
         <p:nvSpPr>
           <p:cNvPr id="24" name="Text 22"/>
-          <p:cNvSpPr/>
-          <p:nvPr/>
-        </p:nvSpPr>
-        <p:spPr>
-          <a:xfrm>
-            <a:off x="6263640" y="4498848"/>
-            <a:ext cx="502920" cy="502920"/>
-          </a:xfrm>
-          <a:prstGeom prst="rect">
-            <a:avLst/>
-          </a:prstGeom>
-          <a:noFill/>
-          <a:ln/>
-        </p:spPr>
-        <p:txBody>
-          <a:bodyPr wrap="square" lIns="0" tIns="0" rIns="0" bIns="0" rtlCol="0" anchor="ctr"/>
-          <a:lstStyle/>
-          <a:p>
-            <a:pPr indent="0" marL="0">
-              <a:buNone/>
-            </a:pPr>
-            <a:r>
-              <a:rPr lang="en-US" sz="2600" b="1" dirty="0">
-                <a:solidFill>
-                  <a:srgbClr val="D97706"/>
-                </a:solidFill>
-                <a:latin typeface="Cambria" pitchFamily="34" charset="0"/>
-                <a:ea typeface="Cambria" pitchFamily="34" charset="-122"/>
-                <a:cs typeface="Cambria" pitchFamily="34" charset="-120"/>
-              </a:rPr>
-              <a:t>6</a:t>
-            </a:r>
-            <a:endParaRPr lang="en-US" sz="2600" dirty="0"/>
-          </a:p>
-        </p:txBody>
-      </p:sp>
-      <p:sp>
-        <p:nvSpPr>
-          <p:cNvPr id="25" name="Text 23"/>
-          <p:cNvSpPr/>
-          <p:nvPr/>
-        </p:nvSpPr>
-        <p:spPr>
-          <a:xfrm>
-            <a:off x="6858000" y="4480560"/>
-            <a:ext cx="4663440" cy="384048"/>
-          </a:xfrm>
-          <a:prstGeom prst="rect">
-            <a:avLst/>
-          </a:prstGeom>
-          <a:noFill/>
-          <a:ln/>
-        </p:spPr>
-        <p:txBody>
-          <a:bodyPr wrap="square" lIns="0" tIns="0" rIns="0" bIns="0" rtlCol="0" anchor="ctr"/>
-          <a:lstStyle/>
-          <a:p>
-            <a:pPr indent="0" marL="0">
-              <a:buNone/>
-            </a:pPr>
-            <a:r>
-              <a:rPr lang="en-US" sz="1600" b="1" dirty="0">
-                <a:solidFill>
-                  <a:srgbClr val="111827"/>
-                </a:solidFill>
-                <a:latin typeface="Cambria" pitchFamily="34" charset="0"/>
-                <a:ea typeface="Cambria" pitchFamily="34" charset="-122"/>
-                <a:cs typeface="Cambria" pitchFamily="34" charset="-120"/>
-              </a:rPr>
-              <a:t>Walk away</a:t>
-            </a:r>
-            <a:endParaRPr lang="en-US" sz="1600" dirty="0"/>
-          </a:p>
-        </p:txBody>
-      </p:sp>
-      <p:sp>
-        <p:nvSpPr>
-          <p:cNvPr id="26" name="Text 24"/>
-          <p:cNvSpPr/>
-          <p:nvPr/>
-        </p:nvSpPr>
-        <p:spPr>
-          <a:xfrm>
-            <a:off x="6858000" y="4882896"/>
-            <a:ext cx="4663440" cy="548640"/>
-          </a:xfrm>
-          <a:prstGeom prst="rect">
-            <a:avLst/>
-          </a:prstGeom>
-          <a:noFill/>
-          <a:ln/>
-        </p:spPr>
-        <p:txBody>
-          <a:bodyPr wrap="square" lIns="0" tIns="0" rIns="0" bIns="0" rtlCol="0" anchor="ctr"/>
-          <a:lstStyle/>
-          <a:p>
-            <a:pPr indent="0" marL="0">
-              <a:buNone/>
-            </a:pPr>
-            <a:r>
-              <a:rPr lang="en-US" sz="1250" dirty="0">
-                <a:solidFill>
-                  <a:srgbClr val="6B7280"/>
-                </a:solidFill>
-                <a:latin typeface="Calibri" pitchFamily="34" charset="0"/>
-                <a:ea typeface="Calibri" pitchFamily="34" charset="-122"/>
-                <a:cs typeface="Calibri" pitchFamily="34" charset="-120"/>
-              </a:rPr>
-              <a:t>zone empties, lamp switches off to save energy</a:t>
-            </a:r>
-            <a:endParaRPr lang="en-US" sz="1250" dirty="0"/>
-          </a:p>
-        </p:txBody>
-      </p:sp>
-      <p:sp>
-        <p:nvSpPr>
-          <p:cNvPr id="27" name="Shape 25"/>
-          <p:cNvSpPr/>
-          <p:nvPr/>
-        </p:nvSpPr>
-        <p:spPr>
-          <a:xfrm>
-            <a:off x="6858000" y="5559552"/>
-            <a:ext cx="4572000" cy="0"/>
-          </a:xfrm>
-          <a:prstGeom prst="line">
-            <a:avLst/>
-          </a:prstGeom>
-          <a:noFill/>
-          <a:ln w="9525">
-            <a:solidFill>
-              <a:srgbClr val="E5E7EB"/>
-            </a:solidFill>
-            <a:prstDash val="solid"/>
-          </a:ln>
-        </p:spPr>
-      </p:sp>
-      <p:sp>
-        <p:nvSpPr>
-          <p:cNvPr id="28" name="Text 26"/>
           <p:cNvSpPr/>
           <p:nvPr/>
         </p:nvSpPr>
@@ -4471,7 +4331,7 @@
     <p:bg>
       <p:bgPr>
         <a:solidFill>
-          <a:srgbClr val="0F1B2D"/>
+          <a:srgbClr val="FFFFFF"/>
         </a:solidFill>
       </p:bgPr>
     </p:bg>
@@ -4491,135 +4351,657 @@
       </p:grpSpPr>
       <p:sp>
         <p:nvSpPr>
-          <p:cNvPr id="2" name="Text 0"/>
-          <p:cNvSpPr/>
-          <p:nvPr/>
-        </p:nvSpPr>
-        <p:spPr>
-          <a:xfrm>
-            <a:off x="822960" y="502920"/>
-            <a:ext cx="5486400" cy="274320"/>
-          </a:xfrm>
-          <a:prstGeom prst="rect">
-            <a:avLst/>
-          </a:prstGeom>
-          <a:noFill/>
-          <a:ln/>
-        </p:spPr>
-        <p:txBody>
-          <a:bodyPr wrap="square" lIns="0" tIns="0" rIns="0" bIns="0" rtlCol="0" anchor="ctr"/>
-          <a:lstStyle/>
-          <a:p>
-            <a:pPr indent="0" marL="0">
-              <a:buNone/>
-            </a:pPr>
-            <a:r>
-              <a:rPr lang="en-US" sz="1100" b="1" spc="200" kern="0" dirty="0">
-                <a:solidFill>
-                  <a:srgbClr val="D97706"/>
-                </a:solidFill>
-                <a:latin typeface="Calibri" pitchFamily="34" charset="0"/>
-                <a:ea typeface="Calibri" pitchFamily="34" charset="-122"/>
-                <a:cs typeface="Calibri" pitchFamily="34" charset="-120"/>
-              </a:rPr>
-              <a:t>THE PROBLEM</a:t>
-            </a:r>
-            <a:endParaRPr lang="en-US" sz="1100" dirty="0"/>
-          </a:p>
-        </p:txBody>
-      </p:sp>
-      <p:sp>
-        <p:nvSpPr>
-          <p:cNvPr id="3" name="Text 1"/>
-          <p:cNvSpPr/>
-          <p:nvPr/>
-        </p:nvSpPr>
-        <p:spPr>
-          <a:xfrm>
-            <a:off x="822960" y="1097280"/>
-            <a:ext cx="5852160" cy="1600200"/>
-          </a:xfrm>
-          <a:prstGeom prst="rect">
-            <a:avLst/>
-          </a:prstGeom>
-          <a:noFill/>
-          <a:ln/>
-        </p:spPr>
-        <p:txBody>
-          <a:bodyPr wrap="square" lIns="0" tIns="0" rIns="0" bIns="0" rtlCol="0" anchor="ctr"/>
-          <a:lstStyle/>
-          <a:p>
-            <a:pPr indent="0" marL="0">
-              <a:lnSpc>
-                <a:spcPct val="115000"/>
-              </a:lnSpc>
-              <a:buNone/>
-            </a:pPr>
-            <a:r>
-              <a:rPr lang="en-US" sz="2500" b="1" dirty="0">
-                <a:solidFill>
-                  <a:srgbClr val="FFFFFF"/>
+          <p:cNvPr id="2" name="Shape 0"/>
+          <p:cNvSpPr/>
+          <p:nvPr/>
+        </p:nvSpPr>
+        <p:spPr>
+          <a:xfrm>
+            <a:off x="6094476" y="0"/>
+            <a:ext cx="6094476" cy="6858000"/>
+          </a:xfrm>
+          <a:prstGeom prst="rect">
+            <a:avLst/>
+          </a:prstGeom>
+          <a:solidFill>
+            <a:srgbClr val="0F1B2D"/>
+          </a:solidFill>
+          <a:ln/>
+        </p:spPr>
+      </p:sp>
+      <p:sp>
+        <p:nvSpPr>
+          <p:cNvPr id="3" name="Shape 1"/>
+          <p:cNvSpPr/>
+          <p:nvPr/>
+        </p:nvSpPr>
+        <p:spPr>
+          <a:xfrm>
+            <a:off x="0" y="0"/>
+            <a:ext cx="6094476" cy="54864"/>
+          </a:xfrm>
+          <a:prstGeom prst="rect">
+            <a:avLst/>
+          </a:prstGeom>
+          <a:solidFill>
+            <a:srgbClr val="B91C1C"/>
+          </a:solidFill>
+          <a:ln/>
+        </p:spPr>
+      </p:sp>
+      <p:sp>
+        <p:nvSpPr>
+          <p:cNvPr id="4" name="Shape 2"/>
+          <p:cNvSpPr/>
+          <p:nvPr/>
+        </p:nvSpPr>
+        <p:spPr>
+          <a:xfrm>
+            <a:off x="6094476" y="0"/>
+            <a:ext cx="6094476" cy="54864"/>
+          </a:xfrm>
+          <a:prstGeom prst="rect">
+            <a:avLst/>
+          </a:prstGeom>
+          <a:solidFill>
+            <a:srgbClr val="15803D"/>
+          </a:solidFill>
+          <a:ln/>
+        </p:spPr>
+      </p:sp>
+      <p:sp>
+        <p:nvSpPr>
+          <p:cNvPr id="5" name="Text 3"/>
+          <p:cNvSpPr/>
+          <p:nvPr/>
+        </p:nvSpPr>
+        <p:spPr>
+          <a:xfrm>
+            <a:off x="685800" y="502920"/>
+            <a:ext cx="4754880" cy="274320"/>
+          </a:xfrm>
+          <a:prstGeom prst="rect">
+            <a:avLst/>
+          </a:prstGeom>
+          <a:noFill/>
+          <a:ln/>
+        </p:spPr>
+        <p:txBody>
+          <a:bodyPr wrap="square" lIns="0" tIns="0" rIns="0" bIns="0" rtlCol="0" anchor="ctr"/>
+          <a:lstStyle/>
+          <a:p>
+            <a:pPr indent="0" marL="0">
+              <a:buNone/>
+            </a:pPr>
+            <a:r>
+              <a:rPr lang="en-US" sz="1200" b="1" spc="300" kern="0" dirty="0">
+                <a:solidFill>
+                  <a:srgbClr val="B91C1C"/>
+                </a:solidFill>
+                <a:latin typeface="Calibri" pitchFamily="34" charset="0"/>
+                <a:ea typeface="Calibri" pitchFamily="34" charset="-122"/>
+                <a:cs typeface="Calibri" pitchFamily="34" charset="-120"/>
+              </a:rPr>
+              <a:t>BEFORE</a:t>
+            </a:r>
+            <a:endParaRPr lang="en-US" sz="1200" dirty="0"/>
+          </a:p>
+        </p:txBody>
+      </p:sp>
+      <p:sp>
+        <p:nvSpPr>
+          <p:cNvPr id="6" name="Text 4"/>
+          <p:cNvSpPr/>
+          <p:nvPr/>
+        </p:nvSpPr>
+        <p:spPr>
+          <a:xfrm>
+            <a:off x="685800" y="914400"/>
+            <a:ext cx="5120640" cy="640080"/>
+          </a:xfrm>
+          <a:prstGeom prst="rect">
+            <a:avLst/>
+          </a:prstGeom>
+          <a:noFill/>
+          <a:ln/>
+        </p:spPr>
+        <p:txBody>
+          <a:bodyPr wrap="square" lIns="0" tIns="0" rIns="0" bIns="0" rtlCol="0" anchor="ctr"/>
+          <a:lstStyle/>
+          <a:p>
+            <a:pPr indent="0" marL="0">
+              <a:buNone/>
+            </a:pPr>
+            <a:r>
+              <a:rPr lang="en-US" sz="3000" b="1" dirty="0">
+                <a:solidFill>
+                  <a:srgbClr val="111827"/>
                 </a:solidFill>
                 <a:latin typeface="Cambria" pitchFamily="34" charset="0"/>
                 <a:ea typeface="Cambria" pitchFamily="34" charset="-122"/>
                 <a:cs typeface="Cambria" pitchFamily="34" charset="-120"/>
               </a:rPr>
-              <a:t>It's a hot Monday morning.</a:t>
-            </a:r>
-            <a:endParaRPr lang="en-US" sz="2500" dirty="0"/>
-          </a:p>
-          <a:p>
-            <a:pPr indent="0" marL="0">
-              <a:lnSpc>
-                <a:spcPct val="115000"/>
-              </a:lnSpc>
-              <a:buNone/>
-            </a:pPr>
-            <a:r>
-              <a:rPr lang="en-US" sz="2500" b="1" dirty="0">
-                <a:solidFill>
-                  <a:srgbClr val="FFFFFF"/>
+              <a:t>Monday morning.</a:t>
+            </a:r>
+            <a:endParaRPr lang="en-US" sz="3000" dirty="0"/>
+          </a:p>
+        </p:txBody>
+      </p:sp>
+      <p:sp>
+        <p:nvSpPr>
+          <p:cNvPr id="7" name="Text 5"/>
+          <p:cNvSpPr/>
+          <p:nvPr/>
+        </p:nvSpPr>
+        <p:spPr>
+          <a:xfrm>
+            <a:off x="685800" y="1874520"/>
+            <a:ext cx="5029200" cy="457200"/>
+          </a:xfrm>
+          <a:prstGeom prst="rect">
+            <a:avLst/>
+          </a:prstGeom>
+          <a:noFill/>
+          <a:ln/>
+        </p:spPr>
+        <p:txBody>
+          <a:bodyPr wrap="square" lIns="0" tIns="0" rIns="0" bIns="0" rtlCol="0" anchor="ctr"/>
+          <a:lstStyle/>
+          <a:p>
+            <a:pPr indent="0" marL="0">
+              <a:buNone/>
+            </a:pPr>
+            <a:r>
+              <a:rPr lang="en-US" sz="1550" dirty="0">
+                <a:solidFill>
+                  <a:srgbClr val="6B7280"/>
+                </a:solidFill>
+                <a:latin typeface="Calibri" pitchFamily="34" charset="0"/>
+                <a:ea typeface="Calibri" pitchFamily="34" charset="-122"/>
+                <a:cs typeface="Calibri" pitchFamily="34" charset="-120"/>
+              </a:rPr>
+              <a:t>Library. Studying for Friday's exam.</a:t>
+            </a:r>
+            <a:endParaRPr lang="en-US" sz="1550" dirty="0"/>
+          </a:p>
+        </p:txBody>
+      </p:sp>
+      <p:sp>
+        <p:nvSpPr>
+          <p:cNvPr id="8" name="Text 6"/>
+          <p:cNvSpPr/>
+          <p:nvPr/>
+        </p:nvSpPr>
+        <p:spPr>
+          <a:xfrm>
+            <a:off x="685800" y="2423160"/>
+            <a:ext cx="5029200" cy="457200"/>
+          </a:xfrm>
+          <a:prstGeom prst="rect">
+            <a:avLst/>
+          </a:prstGeom>
+          <a:noFill/>
+          <a:ln/>
+        </p:spPr>
+        <p:txBody>
+          <a:bodyPr wrap="square" lIns="0" tIns="0" rIns="0" bIns="0" rtlCol="0" anchor="ctr"/>
+          <a:lstStyle/>
+          <a:p>
+            <a:pPr indent="0" marL="0">
+              <a:buNone/>
+            </a:pPr>
+            <a:r>
+              <a:rPr lang="en-US" sz="1550" dirty="0">
+                <a:solidFill>
+                  <a:srgbClr val="6B7280"/>
+                </a:solidFill>
+                <a:latin typeface="Calibri" pitchFamily="34" charset="0"/>
+                <a:ea typeface="Calibri" pitchFamily="34" charset="-122"/>
+                <a:cs typeface="Calibri" pitchFamily="34" charset="-120"/>
+              </a:rPr>
+              <a:t>Head down, full concentration.</a:t>
+            </a:r>
+            <a:endParaRPr lang="en-US" sz="1550" dirty="0"/>
+          </a:p>
+        </p:txBody>
+      </p:sp>
+      <p:sp>
+        <p:nvSpPr>
+          <p:cNvPr id="9" name="Text 7"/>
+          <p:cNvSpPr/>
+          <p:nvPr/>
+        </p:nvSpPr>
+        <p:spPr>
+          <a:xfrm>
+            <a:off x="685800" y="2971800"/>
+            <a:ext cx="5029200" cy="457200"/>
+          </a:xfrm>
+          <a:prstGeom prst="rect">
+            <a:avLst/>
+          </a:prstGeom>
+          <a:noFill/>
+          <a:ln/>
+        </p:spPr>
+        <p:txBody>
+          <a:bodyPr wrap="square" lIns="0" tIns="0" rIns="0" bIns="0" rtlCol="0" anchor="ctr"/>
+          <a:lstStyle/>
+          <a:p>
+            <a:pPr indent="0" marL="0">
+              <a:buNone/>
+            </a:pPr>
+            <a:r>
+              <a:rPr lang="en-US" sz="1550" dirty="0">
+                <a:solidFill>
+                  <a:srgbClr val="6B7280"/>
+                </a:solidFill>
+                <a:latin typeface="Calibri" pitchFamily="34" charset="0"/>
+                <a:ea typeface="Calibri" pitchFamily="34" charset="-122"/>
+                <a:cs typeface="Calibri" pitchFamily="34" charset="-120"/>
+              </a:rPr>
+              <a:t>CO₂ climbs past 1,500 ppm. Silently.</a:t>
+            </a:r>
+            <a:endParaRPr lang="en-US" sz="1550" dirty="0"/>
+          </a:p>
+        </p:txBody>
+      </p:sp>
+      <p:sp>
+        <p:nvSpPr>
+          <p:cNvPr id="10" name="Text 8"/>
+          <p:cNvSpPr/>
+          <p:nvPr/>
+        </p:nvSpPr>
+        <p:spPr>
+          <a:xfrm>
+            <a:off x="685800" y="3566160"/>
+            <a:ext cx="5029200" cy="457200"/>
+          </a:xfrm>
+          <a:prstGeom prst="rect">
+            <a:avLst/>
+          </a:prstGeom>
+          <a:noFill/>
+          <a:ln/>
+        </p:spPr>
+        <p:txBody>
+          <a:bodyPr wrap="square" lIns="0" tIns="0" rIns="0" bIns="0" rtlCol="0" anchor="ctr"/>
+          <a:lstStyle/>
+          <a:p>
+            <a:pPr indent="0" marL="0">
+              <a:buNone/>
+            </a:pPr>
+            <a:r>
+              <a:rPr lang="en-US" sz="1650" b="1" dirty="0">
+                <a:solidFill>
+                  <a:srgbClr val="111827"/>
+                </a:solidFill>
+                <a:latin typeface="Calibri" pitchFamily="34" charset="0"/>
+                <a:ea typeface="Calibri" pitchFamily="34" charset="-122"/>
+                <a:cs typeface="Calibri" pitchFamily="34" charset="-120"/>
+              </a:rPr>
+              <a:t>Your work is wasted.</a:t>
+            </a:r>
+            <a:endParaRPr lang="en-US" sz="1650" dirty="0"/>
+          </a:p>
+        </p:txBody>
+      </p:sp>
+      <p:sp>
+        <p:nvSpPr>
+          <p:cNvPr id="11" name="Shape 9"/>
+          <p:cNvSpPr/>
+          <p:nvPr/>
+        </p:nvSpPr>
+        <p:spPr>
+          <a:xfrm>
+            <a:off x="685800" y="4297680"/>
+            <a:ext cx="4663440" cy="0"/>
+          </a:xfrm>
+          <a:prstGeom prst="line">
+            <a:avLst/>
+          </a:prstGeom>
+          <a:noFill/>
+          <a:ln w="12700">
+            <a:solidFill>
+              <a:srgbClr val="E5E7EB"/>
+            </a:solidFill>
+            <a:prstDash val="solid"/>
+          </a:ln>
+        </p:spPr>
+      </p:sp>
+      <p:sp>
+        <p:nvSpPr>
+          <p:cNvPr id="12" name="Text 10"/>
+          <p:cNvSpPr/>
+          <p:nvPr/>
+        </p:nvSpPr>
+        <p:spPr>
+          <a:xfrm>
+            <a:off x="685800" y="4526280"/>
+            <a:ext cx="5029200" cy="822960"/>
+          </a:xfrm>
+          <a:prstGeom prst="rect">
+            <a:avLst/>
+          </a:prstGeom>
+          <a:noFill/>
+          <a:ln/>
+        </p:spPr>
+        <p:txBody>
+          <a:bodyPr wrap="square" lIns="0" tIns="0" rIns="0" bIns="0" rtlCol="0" anchor="ctr"/>
+          <a:lstStyle/>
+          <a:p>
+            <a:pPr indent="0" marL="0">
+              <a:buNone/>
+            </a:pPr>
+            <a:r>
+              <a:rPr lang="en-US" sz="4600" b="1" dirty="0">
+                <a:solidFill>
+                  <a:srgbClr val="B91C1C"/>
                 </a:solidFill>
                 <a:latin typeface="Cambria" pitchFamily="34" charset="0"/>
                 <a:ea typeface="Cambria" pitchFamily="34" charset="-122"/>
                 <a:cs typeface="Cambria" pitchFamily="34" charset="-120"/>
               </a:rPr>
-              <a:t>You find a seat in the library,</a:t>
-            </a:r>
-            <a:endParaRPr lang="en-US" sz="2500" dirty="0"/>
-          </a:p>
-          <a:p>
-            <a:pPr indent="0" marL="0">
-              <a:lnSpc>
-                <a:spcPct val="115000"/>
-              </a:lnSpc>
-              <a:buNone/>
-            </a:pPr>
-            <a:r>
-              <a:rPr lang="en-US" sz="2500" b="1" dirty="0">
-                <a:solidFill>
-                  <a:srgbClr val="FFFFFF"/>
+              <a:t>1,500</a:t>
+            </a:r>
+            <a:pPr indent="0" marL="0">
+              <a:buNone/>
+            </a:pPr>
+            <a:r>
+              <a:rPr lang="en-US" sz="2000" dirty="0">
+                <a:solidFill>
+                  <a:srgbClr val="6B7280"/>
                 </a:solidFill>
                 <a:latin typeface="Cambria" pitchFamily="34" charset="0"/>
                 <a:ea typeface="Cambria" pitchFamily="34" charset="-122"/>
                 <a:cs typeface="Cambria" pitchFamily="34" charset="-120"/>
               </a:rPr>
-              <a:t>close the door.</a:t>
-            </a:r>
-            <a:endParaRPr lang="en-US" sz="2500" dirty="0"/>
-          </a:p>
-        </p:txBody>
-      </p:sp>
-      <p:sp>
-        <p:nvSpPr>
-          <p:cNvPr id="4" name="Shape 2"/>
-          <p:cNvSpPr/>
-          <p:nvPr/>
-        </p:nvSpPr>
-        <p:spPr>
-          <a:xfrm>
-            <a:off x="822960" y="2926080"/>
-            <a:ext cx="2377440" cy="0"/>
+              <a:t>  ppm</a:t>
+            </a:r>
+            <a:endParaRPr lang="en-US" sz="4600" dirty="0"/>
+          </a:p>
+        </p:txBody>
+      </p:sp>
+      <p:sp>
+        <p:nvSpPr>
+          <p:cNvPr id="13" name="Text 11"/>
+          <p:cNvSpPr/>
+          <p:nvPr/>
+        </p:nvSpPr>
+        <p:spPr>
+          <a:xfrm>
+            <a:off x="685800" y="5440680"/>
+            <a:ext cx="5029200" cy="457200"/>
+          </a:xfrm>
+          <a:prstGeom prst="rect">
+            <a:avLst/>
+          </a:prstGeom>
+          <a:noFill/>
+          <a:ln/>
+        </p:spPr>
+        <p:txBody>
+          <a:bodyPr wrap="square" lIns="0" tIns="0" rIns="0" bIns="0" rtlCol="0" anchor="ctr"/>
+          <a:lstStyle/>
+          <a:p>
+            <a:pPr indent="0" marL="0">
+              <a:buNone/>
+            </a:pPr>
+            <a:r>
+              <a:rPr lang="en-US" sz="1200" i="1" dirty="0">
+                <a:solidFill>
+                  <a:srgbClr val="6B7280"/>
+                </a:solidFill>
+                <a:latin typeface="Calibri" pitchFamily="34" charset="0"/>
+                <a:ea typeface="Calibri" pitchFamily="34" charset="-122"/>
+                <a:cs typeface="Calibri" pitchFamily="34" charset="-120"/>
+              </a:rPr>
+              <a:t>above 1,000 ppm, cognitive performance measurably drops</a:t>
+            </a:r>
+            <a:endParaRPr lang="en-US" sz="1200" dirty="0"/>
+          </a:p>
+        </p:txBody>
+      </p:sp>
+      <p:sp>
+        <p:nvSpPr>
+          <p:cNvPr id="14" name="Text 12"/>
+          <p:cNvSpPr/>
+          <p:nvPr/>
+        </p:nvSpPr>
+        <p:spPr>
+          <a:xfrm>
+            <a:off x="6766560" y="502920"/>
+            <a:ext cx="4754880" cy="274320"/>
+          </a:xfrm>
+          <a:prstGeom prst="rect">
+            <a:avLst/>
+          </a:prstGeom>
+          <a:noFill/>
+          <a:ln/>
+        </p:spPr>
+        <p:txBody>
+          <a:bodyPr wrap="square" lIns="0" tIns="0" rIns="0" bIns="0" rtlCol="0" anchor="ctr"/>
+          <a:lstStyle/>
+          <a:p>
+            <a:pPr indent="0" marL="0">
+              <a:buNone/>
+            </a:pPr>
+            <a:r>
+              <a:rPr lang="en-US" sz="1200" b="1" spc="300" kern="0" dirty="0">
+                <a:solidFill>
+                  <a:srgbClr val="3FBF7F"/>
+                </a:solidFill>
+                <a:latin typeface="Calibri" pitchFamily="34" charset="0"/>
+                <a:ea typeface="Calibri" pitchFamily="34" charset="-122"/>
+                <a:cs typeface="Calibri" pitchFamily="34" charset="-120"/>
+              </a:rPr>
+              <a:t>WITH LIBRISENSE</a:t>
+            </a:r>
+            <a:endParaRPr lang="en-US" sz="1200" dirty="0"/>
+          </a:p>
+        </p:txBody>
+      </p:sp>
+      <p:sp>
+        <p:nvSpPr>
+          <p:cNvPr id="15" name="Text 13"/>
+          <p:cNvSpPr/>
+          <p:nvPr/>
+        </p:nvSpPr>
+        <p:spPr>
+          <a:xfrm>
+            <a:off x="6766560" y="914400"/>
+            <a:ext cx="5120640" cy="640080"/>
+          </a:xfrm>
+          <a:prstGeom prst="rect">
+            <a:avLst/>
+          </a:prstGeom>
+          <a:noFill/>
+          <a:ln/>
+        </p:spPr>
+        <p:txBody>
+          <a:bodyPr wrap="square" lIns="0" tIns="0" rIns="0" bIns="0" rtlCol="0" anchor="ctr"/>
+          <a:lstStyle/>
+          <a:p>
+            <a:pPr indent="0" marL="0">
+              <a:buNone/>
+            </a:pPr>
+            <a:r>
+              <a:rPr lang="en-US" sz="3000" b="1" dirty="0">
+                <a:solidFill>
+                  <a:srgbClr val="FFFFFF"/>
+                </a:solidFill>
+                <a:latin typeface="Cambria" pitchFamily="34" charset="0"/>
+                <a:ea typeface="Cambria" pitchFamily="34" charset="-122"/>
+                <a:cs typeface="Cambria" pitchFamily="34" charset="-120"/>
+              </a:rPr>
+              <a:t>Same morning.</a:t>
+            </a:r>
+            <a:endParaRPr lang="en-US" sz="3000" dirty="0"/>
+          </a:p>
+        </p:txBody>
+      </p:sp>
+      <p:sp>
+        <p:nvSpPr>
+          <p:cNvPr id="16" name="Text 14"/>
+          <p:cNvSpPr/>
+          <p:nvPr/>
+        </p:nvSpPr>
+        <p:spPr>
+          <a:xfrm>
+            <a:off x="6766560" y="1874520"/>
+            <a:ext cx="4937760" cy="457200"/>
+          </a:xfrm>
+          <a:prstGeom prst="rect">
+            <a:avLst/>
+          </a:prstGeom>
+          <a:noFill/>
+          <a:ln/>
+        </p:spPr>
+        <p:txBody>
+          <a:bodyPr wrap="square" lIns="0" tIns="0" rIns="0" bIns="0" rtlCol="0" anchor="ctr"/>
+          <a:lstStyle/>
+          <a:p>
+            <a:pPr indent="0" marL="0">
+              <a:buNone/>
+            </a:pPr>
+            <a:r>
+              <a:rPr lang="en-US" sz="1550" dirty="0">
+                <a:solidFill>
+                  <a:srgbClr val="9DB2C7"/>
+                </a:solidFill>
+                <a:latin typeface="Calibri" pitchFamily="34" charset="0"/>
+                <a:ea typeface="Calibri" pitchFamily="34" charset="-122"/>
+                <a:cs typeface="Calibri" pitchFamily="34" charset="-120"/>
+              </a:rPr>
+              <a:t>Sensors catch the CO₂ rise.</a:t>
+            </a:r>
+            <a:endParaRPr lang="en-US" sz="1550" dirty="0"/>
+          </a:p>
+        </p:txBody>
+      </p:sp>
+      <p:sp>
+        <p:nvSpPr>
+          <p:cNvPr id="17" name="Text 15"/>
+          <p:cNvSpPr/>
+          <p:nvPr/>
+        </p:nvSpPr>
+        <p:spPr>
+          <a:xfrm>
+            <a:off x="6766560" y="2423160"/>
+            <a:ext cx="4937760" cy="457200"/>
+          </a:xfrm>
+          <a:prstGeom prst="rect">
+            <a:avLst/>
+          </a:prstGeom>
+          <a:noFill/>
+          <a:ln/>
+        </p:spPr>
+        <p:txBody>
+          <a:bodyPr wrap="square" lIns="0" tIns="0" rIns="0" bIns="0" rtlCol="0" anchor="ctr"/>
+          <a:lstStyle/>
+          <a:p>
+            <a:pPr indent="0" marL="0">
+              <a:buNone/>
+            </a:pPr>
+            <a:r>
+              <a:rPr lang="en-US" sz="1550" dirty="0">
+                <a:solidFill>
+                  <a:srgbClr val="9DB2C7"/>
+                </a:solidFill>
+                <a:latin typeface="Calibri" pitchFamily="34" charset="0"/>
+                <a:ea typeface="Calibri" pitchFamily="34" charset="-122"/>
+                <a:cs typeface="Calibri" pitchFamily="34" charset="-120"/>
+              </a:rPr>
+              <a:t>The AI planner finds the optimal environment.</a:t>
+            </a:r>
+            <a:endParaRPr lang="en-US" sz="1550" dirty="0"/>
+          </a:p>
+        </p:txBody>
+      </p:sp>
+      <p:sp>
+        <p:nvSpPr>
+          <p:cNvPr id="18" name="Text 16"/>
+          <p:cNvSpPr/>
+          <p:nvPr/>
+        </p:nvSpPr>
+        <p:spPr>
+          <a:xfrm>
+            <a:off x="6766560" y="2971800"/>
+            <a:ext cx="4937760" cy="457200"/>
+          </a:xfrm>
+          <a:prstGeom prst="rect">
+            <a:avLst/>
+          </a:prstGeom>
+          <a:noFill/>
+          <a:ln/>
+        </p:spPr>
+        <p:txBody>
+          <a:bodyPr wrap="square" lIns="0" tIns="0" rIns="0" bIns="0" rtlCol="0" anchor="ctr"/>
+          <a:lstStyle/>
+          <a:p>
+            <a:pPr indent="0" marL="0">
+              <a:buNone/>
+            </a:pPr>
+            <a:r>
+              <a:rPr lang="en-US" sz="1550" dirty="0">
+                <a:solidFill>
+                  <a:srgbClr val="9DB2C7"/>
+                </a:solidFill>
+                <a:latin typeface="Calibri" pitchFamily="34" charset="0"/>
+                <a:ea typeface="Calibri" pitchFamily="34" charset="-122"/>
+                <a:cs typeface="Calibri" pitchFamily="34" charset="-120"/>
+              </a:rPr>
+              <a:t>It optimises the whole room, not just your seat.</a:t>
+            </a:r>
+            <a:endParaRPr lang="en-US" sz="1550" dirty="0"/>
+          </a:p>
+        </p:txBody>
+      </p:sp>
+      <p:sp>
+        <p:nvSpPr>
+          <p:cNvPr id="19" name="Text 17"/>
+          <p:cNvSpPr/>
+          <p:nvPr/>
+        </p:nvSpPr>
+        <p:spPr>
+          <a:xfrm>
+            <a:off x="6766560" y="3566160"/>
+            <a:ext cx="4937760" cy="457200"/>
+          </a:xfrm>
+          <a:prstGeom prst="rect">
+            <a:avLst/>
+          </a:prstGeom>
+          <a:noFill/>
+          <a:ln/>
+        </p:spPr>
+        <p:txBody>
+          <a:bodyPr wrap="square" lIns="0" tIns="0" rIns="0" bIns="0" rtlCol="0" anchor="ctr"/>
+          <a:lstStyle/>
+          <a:p>
+            <a:pPr indent="0" marL="0">
+              <a:buNone/>
+            </a:pPr>
+            <a:r>
+              <a:rPr lang="en-US" sz="1650" b="1" dirty="0">
+                <a:solidFill>
+                  <a:srgbClr val="FFFFFF"/>
+                </a:solidFill>
+                <a:latin typeface="Calibri" pitchFamily="34" charset="0"/>
+                <a:ea typeface="Calibri" pitchFamily="34" charset="-122"/>
+                <a:cs typeface="Calibri" pitchFamily="34" charset="-120"/>
+              </a:rPr>
+              <a:t>The room manages itself.</a:t>
+            </a:r>
+            <a:endParaRPr lang="en-US" sz="1650" dirty="0"/>
+          </a:p>
+        </p:txBody>
+      </p:sp>
+      <p:sp>
+        <p:nvSpPr>
+          <p:cNvPr id="20" name="Shape 18"/>
+          <p:cNvSpPr/>
+          <p:nvPr/>
+        </p:nvSpPr>
+        <p:spPr>
+          <a:xfrm>
+            <a:off x="6766560" y="4297680"/>
+            <a:ext cx="4663440" cy="0"/>
           </a:xfrm>
           <a:prstGeom prst="line">
             <a:avLst/>
@@ -4627,7 +5009,7 @@
           <a:noFill/>
           <a:ln w="12700">
             <a:solidFill>
-              <a:srgbClr val="3A4A63"/>
+              <a:srgbClr val="2A3B55"/>
             </a:solidFill>
             <a:prstDash val="solid"/>
           </a:ln>
@@ -4635,53 +5017,83 @@
       </p:sp>
       <p:sp>
         <p:nvSpPr>
-          <p:cNvPr id="5" name="Text 3"/>
-          <p:cNvSpPr/>
-          <p:nvPr/>
-        </p:nvSpPr>
-        <p:spPr>
-          <a:xfrm>
-            <a:off x="822960" y="3154680"/>
-            <a:ext cx="5852160" cy="1234440"/>
-          </a:xfrm>
-          <a:prstGeom prst="rect">
-            <a:avLst/>
-          </a:prstGeom>
-          <a:noFill/>
-          <a:ln/>
-        </p:spPr>
-        <p:txBody>
-          <a:bodyPr wrap="square" lIns="0" tIns="0" rIns="0" bIns="0" rtlCol="0" anchor="ctr"/>
-          <a:lstStyle/>
-          <a:p>
-            <a:pPr indent="0" marL="0">
-              <a:lnSpc>
-                <a:spcPct val="130000"/>
-              </a:lnSpc>
-              <a:buNone/>
-            </a:pPr>
-            <a:r>
-              <a:rPr lang="en-US" sz="1550" dirty="0">
+          <p:cNvPr id="21" name="Text 19"/>
+          <p:cNvSpPr/>
+          <p:nvPr/>
+        </p:nvSpPr>
+        <p:spPr>
+          <a:xfrm>
+            <a:off x="6766560" y="4526280"/>
+            <a:ext cx="4937760" cy="822960"/>
+          </a:xfrm>
+          <a:prstGeom prst="rect">
+            <a:avLst/>
+          </a:prstGeom>
+          <a:noFill/>
+          <a:ln/>
+        </p:spPr>
+        <p:txBody>
+          <a:bodyPr wrap="square" lIns="0" tIns="0" rIns="0" bIns="0" rtlCol="0" anchor="ctr"/>
+          <a:lstStyle/>
+          <a:p>
+            <a:pPr indent="0" marL="0">
+              <a:buNone/>
+            </a:pPr>
+            <a:r>
+              <a:rPr lang="en-US" sz="4600" b="1" dirty="0">
+                <a:solidFill>
+                  <a:srgbClr val="3FBF7F"/>
+                </a:solidFill>
+                <a:latin typeface="Cambria" pitchFamily="34" charset="0"/>
+                <a:ea typeface="Cambria" pitchFamily="34" charset="-122"/>
+                <a:cs typeface="Cambria" pitchFamily="34" charset="-120"/>
+              </a:rPr>
+              <a:t>800</a:t>
+            </a:r>
+            <a:pPr indent="0" marL="0">
+              <a:buNone/>
+            </a:pPr>
+            <a:r>
+              <a:rPr lang="en-US" sz="2000" dirty="0">
                 <a:solidFill>
                   <a:srgbClr val="9DB2C7"/>
                 </a:solidFill>
-                <a:latin typeface="Calibri" pitchFamily="34" charset="0"/>
-                <a:ea typeface="Calibri" pitchFamily="34" charset="-122"/>
-                <a:cs typeface="Calibri" pitchFamily="34" charset="-120"/>
-              </a:rPr>
-              <a:t>Two hours in, the air is heavy.</a:t>
-            </a:r>
-            <a:endParaRPr lang="en-US" sz="1550" dirty="0"/>
-          </a:p>
-          <a:p>
-            <a:pPr indent="0" marL="0">
-              <a:lnSpc>
-                <a:spcPct val="130000"/>
-              </a:lnSpc>
-              <a:buNone/>
-            </a:pPr>
-            <a:r>
-              <a:rPr lang="en-US" sz="1550" dirty="0">
+                <a:latin typeface="Cambria" pitchFamily="34" charset="0"/>
+                <a:ea typeface="Cambria" pitchFamily="34" charset="-122"/>
+                <a:cs typeface="Cambria" pitchFamily="34" charset="-120"/>
+              </a:rPr>
+              <a:t>  ppm  ✓</a:t>
+            </a:r>
+            <a:endParaRPr lang="en-US" sz="4600" dirty="0"/>
+          </a:p>
+        </p:txBody>
+      </p:sp>
+      <p:sp>
+        <p:nvSpPr>
+          <p:cNvPr id="22" name="Text 20"/>
+          <p:cNvSpPr/>
+          <p:nvPr/>
+        </p:nvSpPr>
+        <p:spPr>
+          <a:xfrm>
+            <a:off x="6766560" y="5440680"/>
+            <a:ext cx="4937760" cy="457200"/>
+          </a:xfrm>
+          <a:prstGeom prst="rect">
+            <a:avLst/>
+          </a:prstGeom>
+          <a:noFill/>
+          <a:ln/>
+        </p:spPr>
+        <p:txBody>
+          <a:bodyPr wrap="square" lIns="0" tIns="0" rIns="0" bIns="0" rtlCol="0" anchor="ctr"/>
+          <a:lstStyle/>
+          <a:p>
+            <a:pPr indent="0" marL="0">
+              <a:buNone/>
+            </a:pPr>
+            <a:r>
+              <a:rPr lang="en-US" sz="1200" i="1" dirty="0">
                 <a:solidFill>
                   <a:srgbClr val="9DB2C7"/>
                 </a:solidFill>
@@ -4689,560 +5101,36 @@
                 <a:ea typeface="Calibri" pitchFamily="34" charset="-122"/>
                 <a:cs typeface="Calibri" pitchFamily="34" charset="-120"/>
               </a:rPr>
-              <a:t>You can't open the window.</a:t>
-            </a:r>
-            <a:endParaRPr lang="en-US" sz="1550" dirty="0"/>
-          </a:p>
-          <a:p>
-            <a:pPr indent="0" marL="0">
-              <a:lnSpc>
-                <a:spcPct val="130000"/>
-              </a:lnSpc>
-              <a:buNone/>
-            </a:pPr>
-            <a:r>
-              <a:rPr lang="en-US" sz="1550" dirty="0">
-                <a:solidFill>
-                  <a:srgbClr val="9DB2C7"/>
-                </a:solidFill>
-                <a:latin typeface="Calibri" pitchFamily="34" charset="0"/>
-                <a:ea typeface="Calibri" pitchFamily="34" charset="-122"/>
-                <a:cs typeface="Calibri" pitchFamily="34" charset="-120"/>
-              </a:rPr>
-              <a:t>It's hotter outside than in.</a:t>
-            </a:r>
-            <a:endParaRPr lang="en-US" sz="1550" dirty="0"/>
-          </a:p>
-        </p:txBody>
-      </p:sp>
-      <p:sp>
-        <p:nvSpPr>
-          <p:cNvPr id="6" name="Text 4"/>
-          <p:cNvSpPr/>
-          <p:nvPr/>
-        </p:nvSpPr>
-        <p:spPr>
-          <a:xfrm>
-            <a:off x="822960" y="4526280"/>
-            <a:ext cx="5852160" cy="457200"/>
-          </a:xfrm>
-          <a:prstGeom prst="rect">
-            <a:avLst/>
-          </a:prstGeom>
-          <a:noFill/>
-          <a:ln/>
-        </p:spPr>
-        <p:txBody>
-          <a:bodyPr wrap="square" lIns="0" tIns="0" rIns="0" bIns="0" rtlCol="0" anchor="ctr"/>
-          <a:lstStyle/>
-          <a:p>
-            <a:pPr indent="0" marL="0">
-              <a:buNone/>
-            </a:pPr>
-            <a:r>
-              <a:rPr lang="en-US" sz="1550" dirty="0">
-                <a:solidFill>
-                  <a:srgbClr val="9DB2C7"/>
-                </a:solidFill>
-                <a:latin typeface="Calibri" pitchFamily="34" charset="0"/>
-                <a:ea typeface="Calibri" pitchFamily="34" charset="-122"/>
-                <a:cs typeface="Calibri" pitchFamily="34" charset="-120"/>
-              </a:rPr>
-              <a:t>By hour three, you're rereading the same paragraph.</a:t>
-            </a:r>
-            <a:endParaRPr lang="en-US" sz="1550" dirty="0"/>
-          </a:p>
-        </p:txBody>
-      </p:sp>
-      <p:sp>
-        <p:nvSpPr>
-          <p:cNvPr id="7" name="Text 5"/>
-          <p:cNvSpPr/>
-          <p:nvPr/>
-        </p:nvSpPr>
-        <p:spPr>
-          <a:xfrm>
-            <a:off x="822960" y="5120640"/>
-            <a:ext cx="5852160" cy="457200"/>
-          </a:xfrm>
-          <a:prstGeom prst="rect">
-            <a:avLst/>
-          </a:prstGeom>
-          <a:noFill/>
-          <a:ln/>
-        </p:spPr>
-        <p:txBody>
-          <a:bodyPr wrap="square" lIns="0" tIns="0" rIns="0" bIns="0" rtlCol="0" anchor="ctr"/>
-          <a:lstStyle/>
-          <a:p>
-            <a:pPr indent="0" marL="0">
-              <a:buNone/>
-            </a:pPr>
-            <a:r>
-              <a:rPr lang="en-US" sz="1650" b="1" dirty="0">
-                <a:solidFill>
-                  <a:srgbClr val="FFFFFF"/>
-                </a:solidFill>
-                <a:latin typeface="Calibri" pitchFamily="34" charset="0"/>
-                <a:ea typeface="Calibri" pitchFamily="34" charset="-122"/>
-                <a:cs typeface="Calibri" pitchFamily="34" charset="-120"/>
-              </a:rPr>
-              <a:t>Nobody noticed. Nobody acted.</a:t>
-            </a:r>
-            <a:endParaRPr lang="en-US" sz="1650" dirty="0"/>
-          </a:p>
-        </p:txBody>
-      </p:sp>
-      <p:sp>
-        <p:nvSpPr>
-          <p:cNvPr id="8" name="Shape 6"/>
-          <p:cNvSpPr/>
-          <p:nvPr/>
-        </p:nvSpPr>
-        <p:spPr>
-          <a:xfrm>
-            <a:off x="7223760" y="960120"/>
-            <a:ext cx="4297680" cy="1874520"/>
-          </a:xfrm>
-          <a:prstGeom prst="roundRect">
-            <a:avLst>
-              <a:gd name="adj" fmla="val 4878"/>
-            </a:avLst>
+              <a:t>comfort · energy · focus: the whole room, optimised</a:t>
+            </a:r>
+            <a:endParaRPr lang="en-US" sz="1200" dirty="0"/>
+          </a:p>
+        </p:txBody>
+      </p:sp>
+      <p:sp>
+        <p:nvSpPr>
+          <p:cNvPr id="23" name="Shape 21"/>
+          <p:cNvSpPr/>
+          <p:nvPr/>
+        </p:nvSpPr>
+        <p:spPr>
+          <a:xfrm>
+            <a:off x="5838444" y="3063240"/>
+            <a:ext cx="512064" cy="310896"/>
+          </a:xfrm>
+          <a:prstGeom prst="rightArrow">
+            <a:avLst/>
           </a:prstGeom>
           <a:solidFill>
-            <a:srgbClr val="2A2113"/>
+            <a:srgbClr val="D97706"/>
           </a:solidFill>
           <a:ln w="12700">
             <a:solidFill>
-              <a:srgbClr val="6B5426"/>
+              <a:srgbClr val="FFFFFF"/>
             </a:solidFill>
             <a:prstDash val="solid"/>
           </a:ln>
         </p:spPr>
-      </p:sp>
-      <p:sp>
-        <p:nvSpPr>
-          <p:cNvPr id="9" name="Text 7"/>
-          <p:cNvSpPr/>
-          <p:nvPr/>
-        </p:nvSpPr>
-        <p:spPr>
-          <a:xfrm>
-            <a:off x="7452360" y="1143000"/>
-            <a:ext cx="3840480" cy="256032"/>
-          </a:xfrm>
-          <a:prstGeom prst="rect">
-            <a:avLst/>
-          </a:prstGeom>
-          <a:noFill/>
-          <a:ln/>
-        </p:spPr>
-        <p:txBody>
-          <a:bodyPr wrap="square" lIns="0" tIns="0" rIns="0" bIns="0" rtlCol="0" anchor="ctr"/>
-          <a:lstStyle/>
-          <a:p>
-            <a:pPr indent="0" marL="0">
-              <a:buNone/>
-            </a:pPr>
-            <a:r>
-              <a:rPr lang="en-US" sz="1050" b="1" spc="200" kern="0" dirty="0">
-                <a:solidFill>
-                  <a:srgbClr val="E8B45A"/>
-                </a:solidFill>
-                <a:latin typeface="Calibri" pitchFamily="34" charset="0"/>
-                <a:ea typeface="Calibri" pitchFamily="34" charset="-122"/>
-                <a:cs typeface="Calibri" pitchFamily="34" charset="-120"/>
-              </a:rPr>
-              <a:t>OUTDOOR TEMPERATURE</a:t>
-            </a:r>
-            <a:endParaRPr lang="en-US" sz="1050" dirty="0"/>
-          </a:p>
-        </p:txBody>
-      </p:sp>
-      <p:sp>
-        <p:nvSpPr>
-          <p:cNvPr id="10" name="Text 8"/>
-          <p:cNvSpPr/>
-          <p:nvPr/>
-        </p:nvSpPr>
-        <p:spPr>
-          <a:xfrm>
-            <a:off x="7452360" y="1463040"/>
-            <a:ext cx="3840480" cy="777240"/>
-          </a:xfrm>
-          <a:prstGeom prst="rect">
-            <a:avLst/>
-          </a:prstGeom>
-          <a:noFill/>
-          <a:ln/>
-        </p:spPr>
-        <p:txBody>
-          <a:bodyPr wrap="square" lIns="0" tIns="0" rIns="0" bIns="0" rtlCol="0" anchor="ctr"/>
-          <a:lstStyle/>
-          <a:p>
-            <a:pPr indent="0" marL="0">
-              <a:buNone/>
-            </a:pPr>
-            <a:r>
-              <a:rPr lang="en-US" sz="4400" b="1" dirty="0">
-                <a:solidFill>
-                  <a:srgbClr val="D97706"/>
-                </a:solidFill>
-                <a:latin typeface="Cambria" pitchFamily="34" charset="0"/>
-                <a:ea typeface="Cambria" pitchFamily="34" charset="-122"/>
-                <a:cs typeface="Cambria" pitchFamily="34" charset="-120"/>
-              </a:rPr>
-              <a:t>33 °C</a:t>
-            </a:r>
-            <a:endParaRPr lang="en-US" sz="4400" dirty="0"/>
-          </a:p>
-        </p:txBody>
-      </p:sp>
-      <p:sp>
-        <p:nvSpPr>
-          <p:cNvPr id="11" name="Text 9"/>
-          <p:cNvSpPr/>
-          <p:nvPr/>
-        </p:nvSpPr>
-        <p:spPr>
-          <a:xfrm>
-            <a:off x="7452360" y="2331720"/>
-            <a:ext cx="3840480" cy="365760"/>
-          </a:xfrm>
-          <a:prstGeom prst="rect">
-            <a:avLst/>
-          </a:prstGeom>
-          <a:noFill/>
-          <a:ln/>
-        </p:spPr>
-        <p:txBody>
-          <a:bodyPr wrap="square" lIns="0" tIns="0" rIns="0" bIns="0" rtlCol="0" anchor="ctr"/>
-          <a:lstStyle/>
-          <a:p>
-            <a:pPr indent="0" marL="0">
-              <a:buNone/>
-            </a:pPr>
-            <a:r>
-              <a:rPr lang="en-US" sz="1150" dirty="0">
-                <a:solidFill>
-                  <a:srgbClr val="B08D4F"/>
-                </a:solidFill>
-                <a:latin typeface="Calibri" pitchFamily="34" charset="0"/>
-                <a:ea typeface="Calibri" pitchFamily="34" charset="-122"/>
-                <a:cs typeface="Calibri" pitchFamily="34" charset="-120"/>
-              </a:rPr>
-              <a:t>windows stay closed, hotter outside than in</a:t>
-            </a:r>
-            <a:endParaRPr lang="en-US" sz="1150" dirty="0"/>
-          </a:p>
-        </p:txBody>
-      </p:sp>
-      <p:sp>
-        <p:nvSpPr>
-          <p:cNvPr id="12" name="Shape 10"/>
-          <p:cNvSpPr/>
-          <p:nvPr/>
-        </p:nvSpPr>
-        <p:spPr>
-          <a:xfrm>
-            <a:off x="7223760" y="3063240"/>
-            <a:ext cx="4297680" cy="2331720"/>
-          </a:xfrm>
-          <a:prstGeom prst="roundRect">
-            <a:avLst>
-              <a:gd name="adj" fmla="val 3922"/>
-            </a:avLst>
-          </a:prstGeom>
-          <a:solidFill>
-            <a:srgbClr val="2A1214"/>
-          </a:solidFill>
-          <a:ln w="12700">
-            <a:solidFill>
-              <a:srgbClr val="7A2E2E"/>
-            </a:solidFill>
-            <a:prstDash val="solid"/>
-          </a:ln>
-        </p:spPr>
-      </p:sp>
-      <p:sp>
-        <p:nvSpPr>
-          <p:cNvPr id="13" name="Text 11"/>
-          <p:cNvSpPr/>
-          <p:nvPr/>
-        </p:nvSpPr>
-        <p:spPr>
-          <a:xfrm>
-            <a:off x="7452360" y="3246120"/>
-            <a:ext cx="3840480" cy="256032"/>
-          </a:xfrm>
-          <a:prstGeom prst="rect">
-            <a:avLst/>
-          </a:prstGeom>
-          <a:noFill/>
-          <a:ln/>
-        </p:spPr>
-        <p:txBody>
-          <a:bodyPr wrap="square" lIns="0" tIns="0" rIns="0" bIns="0" rtlCol="0" anchor="ctr"/>
-          <a:lstStyle/>
-          <a:p>
-            <a:pPr indent="0" marL="0">
-              <a:buNone/>
-            </a:pPr>
-            <a:r>
-              <a:rPr lang="en-US" sz="1050" b="1" spc="200" kern="0" dirty="0">
-                <a:solidFill>
-                  <a:srgbClr val="F0655A"/>
-                </a:solidFill>
-                <a:latin typeface="Calibri" pitchFamily="34" charset="0"/>
-                <a:ea typeface="Calibri" pitchFamily="34" charset="-122"/>
-                <a:cs typeface="Calibri" pitchFamily="34" charset="-120"/>
-              </a:rPr>
-              <a:t>CO₂ CONCENTRATION</a:t>
-            </a:r>
-            <a:endParaRPr lang="en-US" sz="1050" dirty="0"/>
-          </a:p>
-        </p:txBody>
-      </p:sp>
-      <p:sp>
-        <p:nvSpPr>
-          <p:cNvPr id="14" name="Shape 12"/>
-          <p:cNvSpPr/>
-          <p:nvPr/>
-        </p:nvSpPr>
-        <p:spPr>
-          <a:xfrm>
-            <a:off x="7452360" y="3675888"/>
-            <a:ext cx="3840480" cy="0"/>
-          </a:xfrm>
-          <a:prstGeom prst="line">
-            <a:avLst/>
-          </a:prstGeom>
-          <a:noFill/>
-          <a:ln w="25400">
-            <a:solidFill>
-              <a:srgbClr val="F0655A"/>
-            </a:solidFill>
-            <a:prstDash val="solid"/>
-          </a:ln>
-        </p:spPr>
-      </p:sp>
-      <p:sp>
-        <p:nvSpPr>
-          <p:cNvPr id="15" name="Shape 13"/>
-          <p:cNvSpPr/>
-          <p:nvPr/>
-        </p:nvSpPr>
-        <p:spPr>
-          <a:xfrm>
-            <a:off x="9966960" y="3584448"/>
-            <a:ext cx="0" cy="182880"/>
-          </a:xfrm>
-          <a:prstGeom prst="line">
-            <a:avLst/>
-          </a:prstGeom>
-          <a:noFill/>
-          <a:ln w="25400">
-            <a:solidFill>
-              <a:srgbClr val="F0655A"/>
-            </a:solidFill>
-            <a:prstDash val="solid"/>
-          </a:ln>
-        </p:spPr>
-      </p:sp>
-      <p:sp>
-        <p:nvSpPr>
-          <p:cNvPr id="16" name="Text 14"/>
-          <p:cNvSpPr/>
-          <p:nvPr/>
-        </p:nvSpPr>
-        <p:spPr>
-          <a:xfrm>
-            <a:off x="9052560" y="3767328"/>
-            <a:ext cx="2240280" cy="228600"/>
-          </a:xfrm>
-          <a:prstGeom prst="rect">
-            <a:avLst/>
-          </a:prstGeom>
-          <a:noFill/>
-          <a:ln/>
-        </p:spPr>
-        <p:txBody>
-          <a:bodyPr wrap="square" lIns="0" tIns="0" rIns="0" bIns="0" rtlCol="0" anchor="ctr"/>
-          <a:lstStyle/>
-          <a:p>
-            <a:pPr indent="0" marL="0">
-              <a:buNone/>
-            </a:pPr>
-            <a:r>
-              <a:rPr lang="en-US" sz="950" dirty="0">
-                <a:solidFill>
-                  <a:srgbClr val="B76A6A"/>
-                </a:solidFill>
-                <a:latin typeface="Calibri" pitchFamily="34" charset="0"/>
-                <a:ea typeface="Calibri" pitchFamily="34" charset="-122"/>
-                <a:cs typeface="Calibri" pitchFamily="34" charset="-120"/>
-              </a:rPr>
-              <a:t>1,000 ppm threshold</a:t>
-            </a:r>
-            <a:endParaRPr lang="en-US" sz="950" dirty="0"/>
-          </a:p>
-        </p:txBody>
-      </p:sp>
-      <p:sp>
-        <p:nvSpPr>
-          <p:cNvPr id="17" name="Text 15"/>
-          <p:cNvSpPr/>
-          <p:nvPr/>
-        </p:nvSpPr>
-        <p:spPr>
-          <a:xfrm>
-            <a:off x="7452360" y="4023360"/>
-            <a:ext cx="3840480" cy="777240"/>
-          </a:xfrm>
-          <a:prstGeom prst="rect">
-            <a:avLst/>
-          </a:prstGeom>
-          <a:noFill/>
-          <a:ln/>
-        </p:spPr>
-        <p:txBody>
-          <a:bodyPr wrap="square" lIns="0" tIns="0" rIns="0" bIns="0" rtlCol="0" anchor="ctr"/>
-          <a:lstStyle/>
-          <a:p>
-            <a:pPr indent="0" marL="0">
-              <a:buNone/>
-            </a:pPr>
-            <a:r>
-              <a:rPr lang="en-US" sz="4600" b="1" dirty="0">
-                <a:solidFill>
-                  <a:srgbClr val="F0655A"/>
-                </a:solidFill>
-                <a:latin typeface="Cambria" pitchFamily="34" charset="0"/>
-                <a:ea typeface="Cambria" pitchFamily="34" charset="-122"/>
-                <a:cs typeface="Cambria" pitchFamily="34" charset="-120"/>
-              </a:rPr>
-              <a:t>1,547</a:t>
-            </a:r>
-            <a:endParaRPr lang="en-US" sz="4600" dirty="0"/>
-          </a:p>
-        </p:txBody>
-      </p:sp>
-      <p:sp>
-        <p:nvSpPr>
-          <p:cNvPr id="18" name="Text 16"/>
-          <p:cNvSpPr/>
-          <p:nvPr/>
-        </p:nvSpPr>
-        <p:spPr>
-          <a:xfrm>
-            <a:off x="7452360" y="4892040"/>
-            <a:ext cx="3840480" cy="457200"/>
-          </a:xfrm>
-          <a:prstGeom prst="rect">
-            <a:avLst/>
-          </a:prstGeom>
-          <a:noFill/>
-          <a:ln/>
-        </p:spPr>
-        <p:txBody>
-          <a:bodyPr wrap="square" lIns="0" tIns="0" rIns="0" bIns="0" rtlCol="0" anchor="ctr"/>
-          <a:lstStyle/>
-          <a:p>
-            <a:pPr indent="0" marL="0">
-              <a:buNone/>
-            </a:pPr>
-            <a:r>
-              <a:rPr lang="en-US" sz="1100" dirty="0">
-                <a:solidFill>
-                  <a:srgbClr val="B76A6A"/>
-                </a:solidFill>
-                <a:latin typeface="Calibri" pitchFamily="34" charset="0"/>
-                <a:ea typeface="Calibri" pitchFamily="34" charset="-122"/>
-                <a:cs typeface="Calibri" pitchFamily="34" charset="-120"/>
-              </a:rPr>
-              <a:t>ppm · cognitive performance declines above 1,000 ppm (Harvard study, 2015)</a:t>
-            </a:r>
-            <a:endParaRPr lang="en-US" sz="1100" dirty="0"/>
-          </a:p>
-        </p:txBody>
-      </p:sp>
-      <p:sp>
-        <p:nvSpPr>
-          <p:cNvPr id="19" name="Text 17"/>
-          <p:cNvSpPr/>
-          <p:nvPr/>
-        </p:nvSpPr>
-        <p:spPr>
-          <a:xfrm>
-            <a:off x="7223760" y="5532120"/>
-            <a:ext cx="4297680" cy="228600"/>
-          </a:xfrm>
-          <a:prstGeom prst="rect">
-            <a:avLst/>
-          </a:prstGeom>
-          <a:noFill/>
-          <a:ln/>
-        </p:spPr>
-        <p:txBody>
-          <a:bodyPr wrap="square" lIns="0" tIns="0" rIns="0" bIns="0" rtlCol="0" anchor="ctr"/>
-          <a:lstStyle/>
-          <a:p>
-            <a:pPr algn="r" indent="0" marL="0">
-              <a:buNone/>
-            </a:pPr>
-            <a:r>
-              <a:rPr lang="en-US" sz="900" spc="200" kern="0" dirty="0">
-                <a:solidFill>
-                  <a:srgbClr val="3A4A63"/>
-                </a:solidFill>
-                <a:latin typeface="Calibri" pitchFamily="34" charset="0"/>
-                <a:ea typeface="Calibri" pitchFamily="34" charset="-122"/>
-                <a:cs typeface="Calibri" pitchFamily="34" charset="-120"/>
-              </a:rPr>
-              <a:t>UNIVERSITÄTSBIBLIOTHEK STUTTGART</a:t>
-            </a:r>
-            <a:endParaRPr lang="en-US" sz="900" dirty="0"/>
-          </a:p>
-        </p:txBody>
-      </p:sp>
-      <p:sp>
-        <p:nvSpPr>
-          <p:cNvPr id="20" name="Text 18"/>
-          <p:cNvSpPr/>
-          <p:nvPr/>
-        </p:nvSpPr>
-        <p:spPr>
-          <a:xfrm>
-            <a:off x="0" y="6035040"/>
-            <a:ext cx="12188952" cy="548640"/>
-          </a:xfrm>
-          <a:prstGeom prst="rect">
-            <a:avLst/>
-          </a:prstGeom>
-          <a:noFill/>
-          <a:ln/>
-        </p:spPr>
-        <p:txBody>
-          <a:bodyPr wrap="square" lIns="0" tIns="0" rIns="0" bIns="0" rtlCol="0" anchor="ctr"/>
-          <a:lstStyle/>
-          <a:p>
-            <a:pPr algn="ctr" indent="0" marL="0">
-              <a:buNone/>
-            </a:pPr>
-            <a:r>
-              <a:rPr lang="en-US" sz="2600" b="1" dirty="0">
-                <a:solidFill>
-                  <a:srgbClr val="FFFFFF"/>
-                </a:solidFill>
-                <a:latin typeface="Cambria" pitchFamily="34" charset="0"/>
-                <a:ea typeface="Cambria" pitchFamily="34" charset="-122"/>
-                <a:cs typeface="Cambria" pitchFamily="34" charset="-120"/>
-              </a:rPr>
-              <a:t>What if the room could?</a:t>
-            </a:r>
-            <a:endParaRPr lang="en-US" sz="2600" dirty="0"/>
-          </a:p>
-        </p:txBody>
       </p:sp>
     </p:spTree>
   </p:cSld>

</xml_diff>

<commit_message>
Dashboard toggle for demo seats; ground opener copy
</commit_message>
<xml_diff>
--- a/docs/presentation/LibriSense_Demo.pptx
+++ b/docs/presentation/LibriSense_Demo.pptx
@@ -4598,7 +4598,7 @@
                 <a:ea typeface="Calibri" pitchFamily="34" charset="-122"/>
                 <a:cs typeface="Calibri" pitchFamily="34" charset="-120"/>
               </a:rPr>
-              <a:t>CO₂ climbs past 1,500 ppm. Silently.</a:t>
+              <a:t>CO₂ climbs past 1,500 ppm. Nobody notices.</a:t>
             </a:r>
             <a:endParaRPr lang="en-US" sz="1550" dirty="0"/>
           </a:p>
@@ -4637,7 +4637,7 @@
                 <a:ea typeface="Calibri" pitchFamily="34" charset="-122"/>
                 <a:cs typeface="Calibri" pitchFamily="34" charset="-120"/>
               </a:rPr>
-              <a:t>Your work is wasted.</a:t>
+              <a:t>The focus quietly slips away.</a:t>
             </a:r>
             <a:endParaRPr lang="en-US" sz="1650" dirty="0"/>
           </a:p>
@@ -4869,7 +4869,7 @@
                 <a:ea typeface="Calibri" pitchFamily="34" charset="-122"/>
                 <a:cs typeface="Calibri" pitchFamily="34" charset="-120"/>
               </a:rPr>
-              <a:t>Sensors catch the CO₂ rise.</a:t>
+              <a:t>The sensors pick up the CO₂ rise.</a:t>
             </a:r>
             <a:endParaRPr lang="en-US" sz="1550" dirty="0"/>
           </a:p>
@@ -4908,7 +4908,7 @@
                 <a:ea typeface="Calibri" pitchFamily="34" charset="-122"/>
                 <a:cs typeface="Calibri" pitchFamily="34" charset="-120"/>
               </a:rPr>
-              <a:t>The AI planner finds the optimal environment.</a:t>
+              <a:t>The planner airs the room in time.</a:t>
             </a:r>
             <a:endParaRPr lang="en-US" sz="1550" dirty="0"/>
           </a:p>
@@ -4947,7 +4947,7 @@
                 <a:ea typeface="Calibri" pitchFamily="34" charset="-122"/>
                 <a:cs typeface="Calibri" pitchFamily="34" charset="-120"/>
               </a:rPr>
-              <a:t>It optimises the whole room, not just your seat.</a:t>
+              <a:t>Light, air and breaks stay in range.</a:t>
             </a:r>
             <a:endParaRPr lang="en-US" sz="1550" dirty="0"/>
           </a:p>
@@ -4986,7 +4986,7 @@
                 <a:ea typeface="Calibri" pitchFamily="34" charset="-122"/>
                 <a:cs typeface="Calibri" pitchFamily="34" charset="-120"/>
               </a:rPr>
-              <a:t>The room manages itself.</a:t>
+              <a:t>The room adjusts on its own.</a:t>
             </a:r>
             <a:endParaRPr lang="en-US" sz="1650" dirty="0"/>
           </a:p>
@@ -5101,7 +5101,7 @@
                 <a:ea typeface="Calibri" pitchFamily="34" charset="-122"/>
                 <a:cs typeface="Calibri" pitchFamily="34" charset="-120"/>
               </a:rPr>
-              <a:t>comfort · energy · focus: the whole room, optimised</a:t>
+              <a:t>back inside the comfortable range</a:t>
             </a:r>
             <a:endParaRPr lang="en-US" sz="1200" dirty="0"/>
           </a:p>

</xml_diff>